<commit_message>
minor start of L18
</commit_message>
<xml_diff>
--- a/Lectures/Slides/L18.pptx
+++ b/Lectures/Slides/L18.pptx
@@ -5,7 +5,7 @@
     <p:sldMasterId id="2147483648" r:id="rId1"/>
   </p:sldMasterIdLst>
   <p:notesMasterIdLst>
-    <p:notesMasterId r:id="rId22"/>
+    <p:notesMasterId r:id="rId23"/>
   </p:notesMasterIdLst>
   <p:sldIdLst>
     <p:sldId id="256" r:id="rId2"/>
@@ -14,20 +14,21 @@
     <p:sldId id="272" r:id="rId5"/>
     <p:sldId id="258" r:id="rId6"/>
     <p:sldId id="418" r:id="rId7"/>
-    <p:sldId id="259" r:id="rId8"/>
-    <p:sldId id="260" r:id="rId9"/>
-    <p:sldId id="261" r:id="rId10"/>
-    <p:sldId id="262" r:id="rId11"/>
-    <p:sldId id="263" r:id="rId12"/>
-    <p:sldId id="264" r:id="rId13"/>
-    <p:sldId id="265" r:id="rId14"/>
-    <p:sldId id="266" r:id="rId15"/>
-    <p:sldId id="267" r:id="rId16"/>
-    <p:sldId id="268" r:id="rId17"/>
-    <p:sldId id="269" r:id="rId18"/>
-    <p:sldId id="257" r:id="rId19"/>
-    <p:sldId id="271" r:id="rId20"/>
-    <p:sldId id="270" r:id="rId21"/>
+    <p:sldId id="419" r:id="rId8"/>
+    <p:sldId id="259" r:id="rId9"/>
+    <p:sldId id="260" r:id="rId10"/>
+    <p:sldId id="261" r:id="rId11"/>
+    <p:sldId id="262" r:id="rId12"/>
+    <p:sldId id="263" r:id="rId13"/>
+    <p:sldId id="264" r:id="rId14"/>
+    <p:sldId id="265" r:id="rId15"/>
+    <p:sldId id="266" r:id="rId16"/>
+    <p:sldId id="267" r:id="rId17"/>
+    <p:sldId id="268" r:id="rId18"/>
+    <p:sldId id="269" r:id="rId19"/>
+    <p:sldId id="257" r:id="rId20"/>
+    <p:sldId id="271" r:id="rId21"/>
+    <p:sldId id="270" r:id="rId22"/>
   </p:sldIdLst>
   <p:sldSz cx="12192000" cy="6858000"/>
   <p:notesSz cx="6858000" cy="9144000"/>
@@ -265,7 +266,7 @@
       <p15:sldGuideLst xmlns:p15="http://schemas.microsoft.com/office/powerpoint/2012/main"/>
     </p:ext>
     <p:ext uri="http://customooxmlschemas.google.com/">
-      <go:slidesCustomData xmlns="" xmlns:mc="http://schemas.openxmlformats.org/markup-compatibility/2006" xmlns:mv="urn:schemas-microsoft-com:mac:vml" xmlns:c="http://schemas.openxmlformats.org/drawingml/2006/chart" xmlns:dgm="http://schemas.openxmlformats.org/drawingml/2006/diagram" xmlns:o="urn:schemas-microsoft-com:office:office" xmlns:v="urn:schemas-microsoft-com:vml" xmlns:pvml="urn:schemas-microsoft-com:office:powerpoint" xmlns:com="http://schemas.openxmlformats.org/drawingml/2006/compatibility" xmlns:p14="http://schemas.microsoft.com/office/powerpoint/2010/main" xmlns:p15="http://schemas.microsoft.com/office/powerpoint/2012/main" xmlns:ahyp="http://schemas.microsoft.com/office/drawing/2018/hyperlinkcolor" xmlns:go="http://customooxmlschemas.google.com/" r:id="rId23" roundtripDataSignature="AMtx7mjKkk5wOoQj6sDPPETbbKgHU96Dzg=="/>
+      <go:slidesCustomData xmlns:go="http://customooxmlschemas.google.com/" xmlns:ahyp="http://schemas.microsoft.com/office/drawing/2018/hyperlinkcolor" xmlns:p15="http://schemas.microsoft.com/office/powerpoint/2012/main" xmlns:p14="http://schemas.microsoft.com/office/powerpoint/2010/main" xmlns:com="http://schemas.openxmlformats.org/drawingml/2006/compatibility" xmlns:pvml="urn:schemas-microsoft-com:office:powerpoint" xmlns:v="urn:schemas-microsoft-com:vml" xmlns:o="urn:schemas-microsoft-com:office:office" xmlns:dgm="http://schemas.openxmlformats.org/drawingml/2006/diagram" xmlns:c="http://schemas.openxmlformats.org/drawingml/2006/chart" xmlns:mv="urn:schemas-microsoft-com:mac:vml" xmlns:mc="http://schemas.openxmlformats.org/markup-compatibility/2006" xmlns="" r:id="rId24" roundtripDataSignature="AMtx7mjKkk5wOoQj6sDPPETbbKgHU96Dzg=="/>
     </p:ext>
   </p:extLst>
 </p:presentation>
@@ -1833,6 +1834,110 @@
   <p:cSld>
     <p:spTree>
       <p:nvGrpSpPr>
+        <p:cNvPr id="1" name="Shape 141"/>
+        <p:cNvGrpSpPr/>
+        <p:nvPr/>
+      </p:nvGrpSpPr>
+      <p:grpSpPr>
+        <a:xfrm>
+          <a:off x="0" y="0"/>
+          <a:ext cx="0" cy="0"/>
+          <a:chOff x="0" y="0"/>
+          <a:chExt cx="0" cy="0"/>
+        </a:xfrm>
+      </p:grpSpPr>
+      <p:sp>
+        <p:nvSpPr>
+          <p:cNvPr id="142" name="Google Shape;142;p31:notes"/>
+          <p:cNvSpPr txBox="1">
+            <a:spLocks noGrp="1"/>
+          </p:cNvSpPr>
+          <p:nvPr>
+            <p:ph type="body" idx="1"/>
+          </p:nvPr>
+        </p:nvSpPr>
+        <p:spPr>
+          <a:xfrm>
+            <a:off x="685800" y="4400550"/>
+            <a:ext cx="5486400" cy="3600450"/>
+          </a:xfrm>
+          <a:prstGeom prst="rect">
+            <a:avLst/>
+          </a:prstGeom>
+        </p:spPr>
+        <p:txBody>
+          <a:bodyPr spcFirstLastPara="1" wrap="square" lIns="91425" tIns="45700" rIns="91425" bIns="45700" anchor="t" anchorCtr="0">
+            <a:noAutofit/>
+          </a:bodyPr>
+          <a:lstStyle/>
+          <a:p>
+            <a:pPr marL="0" lvl="0" indent="0" algn="l" rtl="0">
+              <a:spcBef>
+                <a:spcPts val="0"/>
+              </a:spcBef>
+              <a:spcAft>
+                <a:spcPts val="0"/>
+              </a:spcAft>
+              <a:buNone/>
+            </a:pPr>
+            <a:endParaRPr/>
+          </a:p>
+        </p:txBody>
+      </p:sp>
+      <p:sp>
+        <p:nvSpPr>
+          <p:cNvPr id="143" name="Google Shape;143;p31:notes"/>
+          <p:cNvSpPr>
+            <a:spLocks noGrp="1" noRot="1" noChangeAspect="1"/>
+          </p:cNvSpPr>
+          <p:nvPr>
+            <p:ph type="sldImg" idx="2"/>
+          </p:nvPr>
+        </p:nvSpPr>
+        <p:spPr>
+          <a:xfrm>
+            <a:off x="685800" y="1143000"/>
+            <a:ext cx="5486400" cy="3086100"/>
+          </a:xfrm>
+          <a:custGeom>
+            <a:avLst/>
+            <a:gdLst/>
+            <a:ahLst/>
+            <a:cxnLst/>
+            <a:rect l="l" t="t" r="r" b="b"/>
+            <a:pathLst>
+              <a:path w="120000" h="120000" extrusionOk="0">
+                <a:moveTo>
+                  <a:pt x="0" y="0"/>
+                </a:moveTo>
+                <a:lnTo>
+                  <a:pt x="120000" y="0"/>
+                </a:lnTo>
+                <a:lnTo>
+                  <a:pt x="120000" y="120000"/>
+                </a:lnTo>
+                <a:lnTo>
+                  <a:pt x="0" y="120000"/>
+                </a:lnTo>
+                <a:close/>
+              </a:path>
+            </a:pathLst>
+          </a:custGeom>
+        </p:spPr>
+      </p:sp>
+    </p:spTree>
+  </p:cSld>
+  <p:clrMapOvr>
+    <a:masterClrMapping/>
+  </p:clrMapOvr>
+</p:notes>
+</file>
+
+<file path=ppt/notesSlides/notesSlide11.xml><?xml version="1.0" encoding="utf-8"?>
+<p:notes xmlns:a="http://schemas.openxmlformats.org/drawingml/2006/main" xmlns:r="http://schemas.openxmlformats.org/officeDocument/2006/relationships" xmlns:p="http://schemas.openxmlformats.org/presentationml/2006/main" showMasterSp="0" showMasterPhAnim="0">
+  <p:cSld>
+    <p:spTree>
+      <p:nvGrpSpPr>
         <p:cNvPr id="1" name="Shape 158"/>
         <p:cNvGrpSpPr/>
         <p:nvPr/>
@@ -1950,7 +2055,7 @@
 </p:notes>
 </file>
 
-<file path=ppt/notesSlides/notesSlide11.xml><?xml version="1.0" encoding="utf-8"?>
+<file path=ppt/notesSlides/notesSlide12.xml><?xml version="1.0" encoding="utf-8"?>
 <p:notes xmlns:a="http://schemas.openxmlformats.org/drawingml/2006/main" xmlns:r="http://schemas.openxmlformats.org/officeDocument/2006/relationships" xmlns:p="http://schemas.openxmlformats.org/presentationml/2006/main" showMasterSp="0" showMasterPhAnim="0">
   <p:cSld>
     <p:spTree>
@@ -2054,7 +2159,7 @@
 </p:notes>
 </file>
 
-<file path=ppt/notesSlides/notesSlide12.xml><?xml version="1.0" encoding="utf-8"?>
+<file path=ppt/notesSlides/notesSlide13.xml><?xml version="1.0" encoding="utf-8"?>
 <p:notes xmlns:a="http://schemas.openxmlformats.org/drawingml/2006/main" xmlns:r="http://schemas.openxmlformats.org/officeDocument/2006/relationships" xmlns:p="http://schemas.openxmlformats.org/presentationml/2006/main" showMasterSp="0" showMasterPhAnim="0">
   <p:cSld>
     <p:spTree>
@@ -2158,7 +2263,7 @@
 </p:notes>
 </file>
 
-<file path=ppt/notesSlides/notesSlide13.xml><?xml version="1.0" encoding="utf-8"?>
+<file path=ppt/notesSlides/notesSlide14.xml><?xml version="1.0" encoding="utf-8"?>
 <p:notes xmlns:a="http://schemas.openxmlformats.org/drawingml/2006/main" xmlns:r="http://schemas.openxmlformats.org/officeDocument/2006/relationships" xmlns:p="http://schemas.openxmlformats.org/presentationml/2006/main" showMasterSp="0" showMasterPhAnim="0">
   <p:cSld>
     <p:spTree>
@@ -2280,7 +2385,7 @@
 </p:notes>
 </file>
 
-<file path=ppt/notesSlides/notesSlide14.xml><?xml version="1.0" encoding="utf-8"?>
+<file path=ppt/notesSlides/notesSlide15.xml><?xml version="1.0" encoding="utf-8"?>
 <p:notes xmlns:a="http://schemas.openxmlformats.org/drawingml/2006/main" xmlns:r="http://schemas.openxmlformats.org/officeDocument/2006/relationships" xmlns:p="http://schemas.openxmlformats.org/presentationml/2006/main" showMasterSp="0" showMasterPhAnim="0">
   <p:cSld>
     <p:spTree>
@@ -2384,7 +2489,7 @@
 </p:notes>
 </file>
 
-<file path=ppt/notesSlides/notesSlide15.xml><?xml version="1.0" encoding="utf-8"?>
+<file path=ppt/notesSlides/notesSlide16.xml><?xml version="1.0" encoding="utf-8"?>
 <p:notes xmlns:a="http://schemas.openxmlformats.org/drawingml/2006/main" xmlns:r="http://schemas.openxmlformats.org/officeDocument/2006/relationships" xmlns:p="http://schemas.openxmlformats.org/presentationml/2006/main" showMasterSp="0" showMasterPhAnim="0">
   <p:cSld>
     <p:spTree>
@@ -2488,7 +2593,7 @@
 </p:notes>
 </file>
 
-<file path=ppt/notesSlides/notesSlide16.xml><?xml version="1.0" encoding="utf-8"?>
+<file path=ppt/notesSlides/notesSlide17.xml><?xml version="1.0" encoding="utf-8"?>
 <p:notes xmlns:a="http://schemas.openxmlformats.org/drawingml/2006/main" xmlns:r="http://schemas.openxmlformats.org/officeDocument/2006/relationships" xmlns:p="http://schemas.openxmlformats.org/presentationml/2006/main" showMasterSp="0" showMasterPhAnim="0">
   <p:cSld>
     <p:spTree>
@@ -2592,7 +2697,7 @@
 </p:notes>
 </file>
 
-<file path=ppt/notesSlides/notesSlide17.xml><?xml version="1.0" encoding="utf-8"?>
+<file path=ppt/notesSlides/notesSlide18.xml><?xml version="1.0" encoding="utf-8"?>
 <p:notes xmlns:a="http://schemas.openxmlformats.org/drawingml/2006/main" xmlns:r="http://schemas.openxmlformats.org/officeDocument/2006/relationships" xmlns:p="http://schemas.openxmlformats.org/presentationml/2006/main" showMasterSp="0" showMasterPhAnim="0">
   <p:cSld>
     <p:spTree>
@@ -2696,7 +2801,7 @@
 </p:notes>
 </file>
 
-<file path=ppt/notesSlides/notesSlide18.xml><?xml version="1.0" encoding="utf-8"?>
+<file path=ppt/notesSlides/notesSlide19.xml><?xml version="1.0" encoding="utf-8"?>
 <p:notes xmlns:a="http://schemas.openxmlformats.org/drawingml/2006/main" xmlns:r="http://schemas.openxmlformats.org/officeDocument/2006/relationships" xmlns:p="http://schemas.openxmlformats.org/presentationml/2006/main" showMasterSp="0" showMasterPhAnim="0">
   <p:cSld>
     <p:spTree>
@@ -2793,133 +2898,6 @@
         </p:spPr>
       </p:sp>
     </p:spTree>
-  </p:cSld>
-  <p:clrMapOvr>
-    <a:masterClrMapping/>
-  </p:clrMapOvr>
-</p:notes>
-</file>
-
-<file path=ppt/notesSlides/notesSlide19.xml><?xml version="1.0" encoding="utf-8"?>
-<p:notes xmlns:a="http://schemas.openxmlformats.org/drawingml/2006/main" xmlns:r="http://schemas.openxmlformats.org/officeDocument/2006/relationships" xmlns:p="http://schemas.openxmlformats.org/presentationml/2006/main" showMasterSp="0" showMasterPhAnim="0">
-  <p:cSld>
-    <p:spTree>
-      <p:nvGrpSpPr>
-        <p:cNvPr id="1" name="Shape 260">
-          <a:extLst>
-            <a:ext uri="{FF2B5EF4-FFF2-40B4-BE49-F238E27FC236}">
-              <a16:creationId xmlns:a16="http://schemas.microsoft.com/office/drawing/2014/main" id="{ED6D95D0-49C4-BE65-6DB0-A8408AD9A1A2}"/>
-            </a:ext>
-          </a:extLst>
-        </p:cNvPr>
-        <p:cNvGrpSpPr/>
-        <p:nvPr/>
-      </p:nvGrpSpPr>
-      <p:grpSpPr>
-        <a:xfrm>
-          <a:off x="0" y="0"/>
-          <a:ext cx="0" cy="0"/>
-          <a:chOff x="0" y="0"/>
-          <a:chExt cx="0" cy="0"/>
-        </a:xfrm>
-      </p:grpSpPr>
-      <p:sp>
-        <p:nvSpPr>
-          <p:cNvPr id="261" name="Google Shape;261;p37:notes">
-            <a:extLst>
-              <a:ext uri="{FF2B5EF4-FFF2-40B4-BE49-F238E27FC236}">
-                <a16:creationId xmlns:a16="http://schemas.microsoft.com/office/drawing/2014/main" id="{D5BF9D20-A937-E031-5ACD-4B566F245A56}"/>
-              </a:ext>
-            </a:extLst>
-          </p:cNvPr>
-          <p:cNvSpPr txBox="1">
-            <a:spLocks noGrp="1"/>
-          </p:cNvSpPr>
-          <p:nvPr>
-            <p:ph type="body" idx="1"/>
-          </p:nvPr>
-        </p:nvSpPr>
-        <p:spPr>
-          <a:xfrm>
-            <a:off x="685800" y="4400550"/>
-            <a:ext cx="5486400" cy="3600450"/>
-          </a:xfrm>
-          <a:prstGeom prst="rect">
-            <a:avLst/>
-          </a:prstGeom>
-        </p:spPr>
-        <p:txBody>
-          <a:bodyPr spcFirstLastPara="1" wrap="square" lIns="91425" tIns="45700" rIns="91425" bIns="45700" anchor="t" anchorCtr="0">
-            <a:noAutofit/>
-          </a:bodyPr>
-          <a:lstStyle/>
-          <a:p>
-            <a:pPr marL="0" lvl="0" indent="0" algn="l" rtl="0">
-              <a:spcBef>
-                <a:spcPts val="0"/>
-              </a:spcBef>
-              <a:spcAft>
-                <a:spcPts val="0"/>
-              </a:spcAft>
-              <a:buNone/>
-            </a:pPr>
-            <a:endParaRPr/>
-          </a:p>
-        </p:txBody>
-      </p:sp>
-      <p:sp>
-        <p:nvSpPr>
-          <p:cNvPr id="262" name="Google Shape;262;p37:notes">
-            <a:extLst>
-              <a:ext uri="{FF2B5EF4-FFF2-40B4-BE49-F238E27FC236}">
-                <a16:creationId xmlns:a16="http://schemas.microsoft.com/office/drawing/2014/main" id="{1666A96F-D523-1F0C-00D5-14D5F35E2C2F}"/>
-              </a:ext>
-            </a:extLst>
-          </p:cNvPr>
-          <p:cNvSpPr>
-            <a:spLocks noGrp="1" noRot="1" noChangeAspect="1"/>
-          </p:cNvSpPr>
-          <p:nvPr>
-            <p:ph type="sldImg" idx="2"/>
-          </p:nvPr>
-        </p:nvSpPr>
-        <p:spPr>
-          <a:xfrm>
-            <a:off x="685800" y="1143000"/>
-            <a:ext cx="5486400" cy="3086100"/>
-          </a:xfrm>
-          <a:custGeom>
-            <a:avLst/>
-            <a:gdLst/>
-            <a:ahLst/>
-            <a:cxnLst/>
-            <a:rect l="l" t="t" r="r" b="b"/>
-            <a:pathLst>
-              <a:path w="120000" h="120000" extrusionOk="0">
-                <a:moveTo>
-                  <a:pt x="0" y="0"/>
-                </a:moveTo>
-                <a:lnTo>
-                  <a:pt x="120000" y="0"/>
-                </a:lnTo>
-                <a:lnTo>
-                  <a:pt x="120000" y="120000"/>
-                </a:lnTo>
-                <a:lnTo>
-                  <a:pt x="0" y="120000"/>
-                </a:lnTo>
-                <a:close/>
-              </a:path>
-            </a:pathLst>
-          </a:custGeom>
-        </p:spPr>
-      </p:sp>
-    </p:spTree>
-    <p:extLst>
-      <p:ext uri="{BB962C8B-B14F-4D97-AF65-F5344CB8AC3E}">
-        <p14:creationId xmlns:p14="http://schemas.microsoft.com/office/powerpoint/2010/main" val="3888823651"/>
-      </p:ext>
-    </p:extLst>
   </p:cSld>
   <p:clrMapOvr>
     <a:masterClrMapping/>
@@ -3073,6 +3051,133 @@
 </file>
 
 <file path=ppt/notesSlides/notesSlide20.xml><?xml version="1.0" encoding="utf-8"?>
+<p:notes xmlns:a="http://schemas.openxmlformats.org/drawingml/2006/main" xmlns:r="http://schemas.openxmlformats.org/officeDocument/2006/relationships" xmlns:p="http://schemas.openxmlformats.org/presentationml/2006/main" showMasterSp="0" showMasterPhAnim="0">
+  <p:cSld>
+    <p:spTree>
+      <p:nvGrpSpPr>
+        <p:cNvPr id="1" name="Shape 260">
+          <a:extLst>
+            <a:ext uri="{FF2B5EF4-FFF2-40B4-BE49-F238E27FC236}">
+              <a16:creationId xmlns:a16="http://schemas.microsoft.com/office/drawing/2014/main" id="{ED6D95D0-49C4-BE65-6DB0-A8408AD9A1A2}"/>
+            </a:ext>
+          </a:extLst>
+        </p:cNvPr>
+        <p:cNvGrpSpPr/>
+        <p:nvPr/>
+      </p:nvGrpSpPr>
+      <p:grpSpPr>
+        <a:xfrm>
+          <a:off x="0" y="0"/>
+          <a:ext cx="0" cy="0"/>
+          <a:chOff x="0" y="0"/>
+          <a:chExt cx="0" cy="0"/>
+        </a:xfrm>
+      </p:grpSpPr>
+      <p:sp>
+        <p:nvSpPr>
+          <p:cNvPr id="261" name="Google Shape;261;p37:notes">
+            <a:extLst>
+              <a:ext uri="{FF2B5EF4-FFF2-40B4-BE49-F238E27FC236}">
+                <a16:creationId xmlns:a16="http://schemas.microsoft.com/office/drawing/2014/main" id="{D5BF9D20-A937-E031-5ACD-4B566F245A56}"/>
+              </a:ext>
+            </a:extLst>
+          </p:cNvPr>
+          <p:cNvSpPr txBox="1">
+            <a:spLocks noGrp="1"/>
+          </p:cNvSpPr>
+          <p:nvPr>
+            <p:ph type="body" idx="1"/>
+          </p:nvPr>
+        </p:nvSpPr>
+        <p:spPr>
+          <a:xfrm>
+            <a:off x="685800" y="4400550"/>
+            <a:ext cx="5486400" cy="3600450"/>
+          </a:xfrm>
+          <a:prstGeom prst="rect">
+            <a:avLst/>
+          </a:prstGeom>
+        </p:spPr>
+        <p:txBody>
+          <a:bodyPr spcFirstLastPara="1" wrap="square" lIns="91425" tIns="45700" rIns="91425" bIns="45700" anchor="t" anchorCtr="0">
+            <a:noAutofit/>
+          </a:bodyPr>
+          <a:lstStyle/>
+          <a:p>
+            <a:pPr marL="0" lvl="0" indent="0" algn="l" rtl="0">
+              <a:spcBef>
+                <a:spcPts val="0"/>
+              </a:spcBef>
+              <a:spcAft>
+                <a:spcPts val="0"/>
+              </a:spcAft>
+              <a:buNone/>
+            </a:pPr>
+            <a:endParaRPr/>
+          </a:p>
+        </p:txBody>
+      </p:sp>
+      <p:sp>
+        <p:nvSpPr>
+          <p:cNvPr id="262" name="Google Shape;262;p37:notes">
+            <a:extLst>
+              <a:ext uri="{FF2B5EF4-FFF2-40B4-BE49-F238E27FC236}">
+                <a16:creationId xmlns:a16="http://schemas.microsoft.com/office/drawing/2014/main" id="{1666A96F-D523-1F0C-00D5-14D5F35E2C2F}"/>
+              </a:ext>
+            </a:extLst>
+          </p:cNvPr>
+          <p:cNvSpPr>
+            <a:spLocks noGrp="1" noRot="1" noChangeAspect="1"/>
+          </p:cNvSpPr>
+          <p:nvPr>
+            <p:ph type="sldImg" idx="2"/>
+          </p:nvPr>
+        </p:nvSpPr>
+        <p:spPr>
+          <a:xfrm>
+            <a:off x="685800" y="1143000"/>
+            <a:ext cx="5486400" cy="3086100"/>
+          </a:xfrm>
+          <a:custGeom>
+            <a:avLst/>
+            <a:gdLst/>
+            <a:ahLst/>
+            <a:cxnLst/>
+            <a:rect l="l" t="t" r="r" b="b"/>
+            <a:pathLst>
+              <a:path w="120000" h="120000" extrusionOk="0">
+                <a:moveTo>
+                  <a:pt x="0" y="0"/>
+                </a:moveTo>
+                <a:lnTo>
+                  <a:pt x="120000" y="0"/>
+                </a:lnTo>
+                <a:lnTo>
+                  <a:pt x="120000" y="120000"/>
+                </a:lnTo>
+                <a:lnTo>
+                  <a:pt x="0" y="120000"/>
+                </a:lnTo>
+                <a:close/>
+              </a:path>
+            </a:pathLst>
+          </a:custGeom>
+        </p:spPr>
+      </p:sp>
+    </p:spTree>
+    <p:extLst>
+      <p:ext uri="{BB962C8B-B14F-4D97-AF65-F5344CB8AC3E}">
+        <p14:creationId xmlns:p14="http://schemas.microsoft.com/office/powerpoint/2010/main" val="3888823651"/>
+      </p:ext>
+    </p:extLst>
+  </p:cSld>
+  <p:clrMapOvr>
+    <a:masterClrMapping/>
+  </p:clrMapOvr>
+</p:notes>
+</file>
+
+<file path=ppt/notesSlides/notesSlide21.xml><?xml version="1.0" encoding="utf-8"?>
 <p:notes xmlns:a="http://schemas.openxmlformats.org/drawingml/2006/main" xmlns:r="http://schemas.openxmlformats.org/officeDocument/2006/relationships" xmlns:p="http://schemas.openxmlformats.org/presentationml/2006/main" showMasterSp="0" showMasterPhAnim="0">
   <p:cSld>
     <p:spTree>
@@ -3702,6 +3807,151 @@
   <p:cSld>
     <p:spTree>
       <p:nvGrpSpPr>
+        <p:cNvPr id="1" name="Shape 114">
+          <a:extLst>
+            <a:ext uri="{FF2B5EF4-FFF2-40B4-BE49-F238E27FC236}">
+              <a16:creationId xmlns:a16="http://schemas.microsoft.com/office/drawing/2014/main" id="{9550EDD1-52CE-344C-711B-8FF6DF309E6C}"/>
+            </a:ext>
+          </a:extLst>
+        </p:cNvPr>
+        <p:cNvGrpSpPr/>
+        <p:nvPr/>
+      </p:nvGrpSpPr>
+      <p:grpSpPr>
+        <a:xfrm>
+          <a:off x="0" y="0"/>
+          <a:ext cx="0" cy="0"/>
+          <a:chOff x="0" y="0"/>
+          <a:chExt cx="0" cy="0"/>
+        </a:xfrm>
+      </p:grpSpPr>
+      <p:sp>
+        <p:nvSpPr>
+          <p:cNvPr id="115" name="Google Shape;115;p29:notes">
+            <a:extLst>
+              <a:ext uri="{FF2B5EF4-FFF2-40B4-BE49-F238E27FC236}">
+                <a16:creationId xmlns:a16="http://schemas.microsoft.com/office/drawing/2014/main" id="{6902D2D7-EFD8-0EDC-0AEB-B8C2846146F8}"/>
+              </a:ext>
+            </a:extLst>
+          </p:cNvPr>
+          <p:cNvSpPr txBox="1">
+            <a:spLocks noGrp="1"/>
+          </p:cNvSpPr>
+          <p:nvPr>
+            <p:ph type="body" idx="1"/>
+          </p:nvPr>
+        </p:nvSpPr>
+        <p:spPr>
+          <a:xfrm>
+            <a:off x="685800" y="4400550"/>
+            <a:ext cx="5486400" cy="3600450"/>
+          </a:xfrm>
+          <a:prstGeom prst="rect">
+            <a:avLst/>
+          </a:prstGeom>
+          <a:noFill/>
+          <a:ln>
+            <a:noFill/>
+          </a:ln>
+        </p:spPr>
+        <p:txBody>
+          <a:bodyPr spcFirstLastPara="1" wrap="square" lIns="91425" tIns="45700" rIns="91425" bIns="45700" anchor="t" anchorCtr="0">
+            <a:noAutofit/>
+          </a:bodyPr>
+          <a:lstStyle/>
+          <a:p>
+            <a:pPr marL="0" lvl="0" indent="0" algn="l" rtl="0">
+              <a:lnSpc>
+                <a:spcPct val="100000"/>
+              </a:lnSpc>
+              <a:spcBef>
+                <a:spcPts val="0"/>
+              </a:spcBef>
+              <a:spcAft>
+                <a:spcPts val="0"/>
+              </a:spcAft>
+              <a:buSzPts val="1400"/>
+              <a:buNone/>
+            </a:pPr>
+            <a:endParaRPr/>
+          </a:p>
+        </p:txBody>
+      </p:sp>
+      <p:sp>
+        <p:nvSpPr>
+          <p:cNvPr id="116" name="Google Shape;116;p29:notes">
+            <a:extLst>
+              <a:ext uri="{FF2B5EF4-FFF2-40B4-BE49-F238E27FC236}">
+                <a16:creationId xmlns:a16="http://schemas.microsoft.com/office/drawing/2014/main" id="{B6B1CB7C-3314-95B9-DC5D-93CAEF8FADAF}"/>
+              </a:ext>
+            </a:extLst>
+          </p:cNvPr>
+          <p:cNvSpPr>
+            <a:spLocks noGrp="1" noRot="1" noChangeAspect="1"/>
+          </p:cNvSpPr>
+          <p:nvPr>
+            <p:ph type="sldImg" idx="2"/>
+          </p:nvPr>
+        </p:nvSpPr>
+        <p:spPr>
+          <a:xfrm>
+            <a:off x="685800" y="1143000"/>
+            <a:ext cx="5486400" cy="3086100"/>
+          </a:xfrm>
+          <a:custGeom>
+            <a:avLst/>
+            <a:gdLst/>
+            <a:ahLst/>
+            <a:cxnLst/>
+            <a:rect l="l" t="t" r="r" b="b"/>
+            <a:pathLst>
+              <a:path w="120000" h="120000" extrusionOk="0">
+                <a:moveTo>
+                  <a:pt x="0" y="0"/>
+                </a:moveTo>
+                <a:lnTo>
+                  <a:pt x="120000" y="0"/>
+                </a:lnTo>
+                <a:lnTo>
+                  <a:pt x="120000" y="120000"/>
+                </a:lnTo>
+                <a:lnTo>
+                  <a:pt x="0" y="120000"/>
+                </a:lnTo>
+                <a:close/>
+              </a:path>
+            </a:pathLst>
+          </a:custGeom>
+          <a:noFill/>
+          <a:ln w="12700" cap="flat" cmpd="sng">
+            <a:solidFill>
+              <a:srgbClr val="000000"/>
+            </a:solidFill>
+            <a:prstDash val="solid"/>
+            <a:round/>
+            <a:headEnd type="none" w="sm" len="sm"/>
+            <a:tailEnd type="none" w="sm" len="sm"/>
+          </a:ln>
+        </p:spPr>
+      </p:sp>
+    </p:spTree>
+    <p:extLst>
+      <p:ext uri="{BB962C8B-B14F-4D97-AF65-F5344CB8AC3E}">
+        <p14:creationId xmlns:p14="http://schemas.microsoft.com/office/powerpoint/2010/main" val="2658891594"/>
+      </p:ext>
+    </p:extLst>
+  </p:cSld>
+  <p:clrMapOvr>
+    <a:masterClrMapping/>
+  </p:clrMapOvr>
+</p:notes>
+</file>
+
+<file path=ppt/notesSlides/notesSlide8.xml><?xml version="1.0" encoding="utf-8"?>
+<p:notes xmlns:a="http://schemas.openxmlformats.org/drawingml/2006/main" xmlns:r="http://schemas.openxmlformats.org/officeDocument/2006/relationships" xmlns:p="http://schemas.openxmlformats.org/presentationml/2006/main" showMasterSp="0" showMasterPhAnim="0">
+  <p:cSld>
+    <p:spTree>
+      <p:nvGrpSpPr>
         <p:cNvPr id="1" name="Shape 114"/>
         <p:cNvGrpSpPr/>
         <p:nvPr/>
@@ -3819,7 +4069,7 @@
 </p:notes>
 </file>
 
-<file path=ppt/notesSlides/notesSlide8.xml><?xml version="1.0" encoding="utf-8"?>
+<file path=ppt/notesSlides/notesSlide9.xml><?xml version="1.0" encoding="utf-8"?>
 <p:notes xmlns:a="http://schemas.openxmlformats.org/drawingml/2006/main" xmlns:r="http://schemas.openxmlformats.org/officeDocument/2006/relationships" xmlns:p="http://schemas.openxmlformats.org/presentationml/2006/main" showMasterSp="0" showMasterPhAnim="0">
   <p:cSld>
     <p:spTree>
@@ -3877,110 +4127,6 @@
       <p:sp>
         <p:nvSpPr>
           <p:cNvPr id="129" name="Google Shape;129;p30:notes"/>
-          <p:cNvSpPr>
-            <a:spLocks noGrp="1" noRot="1" noChangeAspect="1"/>
-          </p:cNvSpPr>
-          <p:nvPr>
-            <p:ph type="sldImg" idx="2"/>
-          </p:nvPr>
-        </p:nvSpPr>
-        <p:spPr>
-          <a:xfrm>
-            <a:off x="685800" y="1143000"/>
-            <a:ext cx="5486400" cy="3086100"/>
-          </a:xfrm>
-          <a:custGeom>
-            <a:avLst/>
-            <a:gdLst/>
-            <a:ahLst/>
-            <a:cxnLst/>
-            <a:rect l="l" t="t" r="r" b="b"/>
-            <a:pathLst>
-              <a:path w="120000" h="120000" extrusionOk="0">
-                <a:moveTo>
-                  <a:pt x="0" y="0"/>
-                </a:moveTo>
-                <a:lnTo>
-                  <a:pt x="120000" y="0"/>
-                </a:lnTo>
-                <a:lnTo>
-                  <a:pt x="120000" y="120000"/>
-                </a:lnTo>
-                <a:lnTo>
-                  <a:pt x="0" y="120000"/>
-                </a:lnTo>
-                <a:close/>
-              </a:path>
-            </a:pathLst>
-          </a:custGeom>
-        </p:spPr>
-      </p:sp>
-    </p:spTree>
-  </p:cSld>
-  <p:clrMapOvr>
-    <a:masterClrMapping/>
-  </p:clrMapOvr>
-</p:notes>
-</file>
-
-<file path=ppt/notesSlides/notesSlide9.xml><?xml version="1.0" encoding="utf-8"?>
-<p:notes xmlns:a="http://schemas.openxmlformats.org/drawingml/2006/main" xmlns:r="http://schemas.openxmlformats.org/officeDocument/2006/relationships" xmlns:p="http://schemas.openxmlformats.org/presentationml/2006/main" showMasterSp="0" showMasterPhAnim="0">
-  <p:cSld>
-    <p:spTree>
-      <p:nvGrpSpPr>
-        <p:cNvPr id="1" name="Shape 141"/>
-        <p:cNvGrpSpPr/>
-        <p:nvPr/>
-      </p:nvGrpSpPr>
-      <p:grpSpPr>
-        <a:xfrm>
-          <a:off x="0" y="0"/>
-          <a:ext cx="0" cy="0"/>
-          <a:chOff x="0" y="0"/>
-          <a:chExt cx="0" cy="0"/>
-        </a:xfrm>
-      </p:grpSpPr>
-      <p:sp>
-        <p:nvSpPr>
-          <p:cNvPr id="142" name="Google Shape;142;p31:notes"/>
-          <p:cNvSpPr txBox="1">
-            <a:spLocks noGrp="1"/>
-          </p:cNvSpPr>
-          <p:nvPr>
-            <p:ph type="body" idx="1"/>
-          </p:nvPr>
-        </p:nvSpPr>
-        <p:spPr>
-          <a:xfrm>
-            <a:off x="685800" y="4400550"/>
-            <a:ext cx="5486400" cy="3600450"/>
-          </a:xfrm>
-          <a:prstGeom prst="rect">
-            <a:avLst/>
-          </a:prstGeom>
-        </p:spPr>
-        <p:txBody>
-          <a:bodyPr spcFirstLastPara="1" wrap="square" lIns="91425" tIns="45700" rIns="91425" bIns="45700" anchor="t" anchorCtr="0">
-            <a:noAutofit/>
-          </a:bodyPr>
-          <a:lstStyle/>
-          <a:p>
-            <a:pPr marL="0" lvl="0" indent="0" algn="l" rtl="0">
-              <a:spcBef>
-                <a:spcPts val="0"/>
-              </a:spcBef>
-              <a:spcAft>
-                <a:spcPts val="0"/>
-              </a:spcAft>
-              <a:buNone/>
-            </a:pPr>
-            <a:endParaRPr/>
-          </a:p>
-        </p:txBody>
-      </p:sp>
-      <p:sp>
-        <p:nvSpPr>
-          <p:cNvPr id="143" name="Google Shape;143;p31:notes"/>
           <p:cNvSpPr>
             <a:spLocks noGrp="1" noRot="1" noChangeAspect="1"/>
           </p:cNvSpPr>
@@ -16594,6 +16740,845 @@
   <p:cSld>
     <p:spTree>
       <p:nvGrpSpPr>
+        <p:cNvPr id="1" name="Shape 144"/>
+        <p:cNvGrpSpPr/>
+        <p:nvPr/>
+      </p:nvGrpSpPr>
+      <p:grpSpPr>
+        <a:xfrm>
+          <a:off x="0" y="0"/>
+          <a:ext cx="0" cy="0"/>
+          <a:chOff x="0" y="0"/>
+          <a:chExt cx="0" cy="0"/>
+        </a:xfrm>
+      </p:grpSpPr>
+      <p:sp>
+        <p:nvSpPr>
+          <p:cNvPr id="145" name="Google Shape;145;p31"/>
+          <p:cNvSpPr/>
+          <p:nvPr/>
+        </p:nvSpPr>
+        <p:spPr>
+          <a:xfrm>
+            <a:off x="475566" y="1263717"/>
+            <a:ext cx="4356660" cy="2315647"/>
+          </a:xfrm>
+          <a:prstGeom prst="rect">
+            <a:avLst/>
+          </a:prstGeom>
+          <a:solidFill>
+            <a:srgbClr val="D8D8D8"/>
+          </a:solidFill>
+          <a:ln>
+            <a:noFill/>
+          </a:ln>
+        </p:spPr>
+        <p:txBody>
+          <a:bodyPr spcFirstLastPara="1" wrap="square" lIns="91425" tIns="45700" rIns="91425" bIns="45700" anchor="ctr" anchorCtr="0">
+            <a:noAutofit/>
+          </a:bodyPr>
+          <a:lstStyle/>
+          <a:p>
+            <a:pPr marL="0" marR="0" lvl="0" indent="0" algn="ctr" rtl="0">
+              <a:lnSpc>
+                <a:spcPct val="100000"/>
+              </a:lnSpc>
+              <a:spcBef>
+                <a:spcPts val="0"/>
+              </a:spcBef>
+              <a:spcAft>
+                <a:spcPts val="0"/>
+              </a:spcAft>
+              <a:buClr>
+                <a:srgbClr val="000000"/>
+              </a:buClr>
+              <a:buSzPts val="1800"/>
+              <a:buFont typeface="Arial"/>
+              <a:buNone/>
+            </a:pPr>
+            <a:endParaRPr sz="1800" b="0" i="0" u="none" strike="noStrike" cap="none">
+              <a:solidFill>
+                <a:schemeClr val="lt1"/>
+              </a:solidFill>
+              <a:latin typeface="Calibri"/>
+              <a:ea typeface="Calibri"/>
+              <a:cs typeface="Calibri"/>
+              <a:sym typeface="Calibri"/>
+            </a:endParaRPr>
+          </a:p>
+        </p:txBody>
+      </p:sp>
+      <p:sp>
+        <p:nvSpPr>
+          <p:cNvPr id="146" name="Google Shape;146;p31"/>
+          <p:cNvSpPr txBox="1"/>
+          <p:nvPr/>
+        </p:nvSpPr>
+        <p:spPr>
+          <a:xfrm>
+            <a:off x="1494115" y="2239572"/>
+            <a:ext cx="2280491" cy="369332"/>
+          </a:xfrm>
+          <a:prstGeom prst="rect">
+            <a:avLst/>
+          </a:prstGeom>
+          <a:noFill/>
+          <a:ln>
+            <a:noFill/>
+          </a:ln>
+        </p:spPr>
+        <p:txBody>
+          <a:bodyPr spcFirstLastPara="1" wrap="square" lIns="91425" tIns="45700" rIns="91425" bIns="45700" anchor="t" anchorCtr="0">
+            <a:spAutoFit/>
+          </a:bodyPr>
+          <a:lstStyle/>
+          <a:p>
+            <a:pPr marL="0" marR="0" lvl="0" indent="0" algn="ctr" rtl="0">
+              <a:lnSpc>
+                <a:spcPct val="100000"/>
+              </a:lnSpc>
+              <a:spcBef>
+                <a:spcPts val="0"/>
+              </a:spcBef>
+              <a:spcAft>
+                <a:spcPts val="0"/>
+              </a:spcAft>
+              <a:buClr>
+                <a:srgbClr val="000000"/>
+              </a:buClr>
+              <a:buSzPts val="1800"/>
+              <a:buFont typeface="Arial"/>
+              <a:buNone/>
+            </a:pPr>
+            <a:r>
+              <a:rPr lang="en-US" sz="1800" b="0" i="0" u="none" strike="noStrike" cap="none">
+                <a:solidFill>
+                  <a:srgbClr val="A5A5A5"/>
+                </a:solidFill>
+                <a:latin typeface="Arial"/>
+                <a:ea typeface="Arial"/>
+                <a:cs typeface="Arial"/>
+                <a:sym typeface="Arial"/>
+              </a:rPr>
+              <a:t>IMAGE / GRAPHIC</a:t>
+            </a:r>
+            <a:endParaRPr sz="1400" b="0" i="0" u="none" strike="noStrike" cap="none">
+              <a:solidFill>
+                <a:srgbClr val="000000"/>
+              </a:solidFill>
+              <a:latin typeface="Arial"/>
+              <a:ea typeface="Arial"/>
+              <a:cs typeface="Arial"/>
+              <a:sym typeface="Arial"/>
+            </a:endParaRPr>
+          </a:p>
+        </p:txBody>
+      </p:sp>
+      <p:sp>
+        <p:nvSpPr>
+          <p:cNvPr id="147" name="Google Shape;147;p31"/>
+          <p:cNvSpPr/>
+          <p:nvPr/>
+        </p:nvSpPr>
+        <p:spPr>
+          <a:xfrm>
+            <a:off x="475566" y="3774068"/>
+            <a:ext cx="4356660" cy="2315647"/>
+          </a:xfrm>
+          <a:prstGeom prst="rect">
+            <a:avLst/>
+          </a:prstGeom>
+          <a:solidFill>
+            <a:srgbClr val="D8D8D8"/>
+          </a:solidFill>
+          <a:ln>
+            <a:noFill/>
+          </a:ln>
+        </p:spPr>
+        <p:txBody>
+          <a:bodyPr spcFirstLastPara="1" wrap="square" lIns="91425" tIns="45700" rIns="91425" bIns="45700" anchor="ctr" anchorCtr="0">
+            <a:noAutofit/>
+          </a:bodyPr>
+          <a:lstStyle/>
+          <a:p>
+            <a:pPr marL="0" marR="0" lvl="0" indent="0" algn="ctr" rtl="0">
+              <a:lnSpc>
+                <a:spcPct val="100000"/>
+              </a:lnSpc>
+              <a:spcBef>
+                <a:spcPts val="0"/>
+              </a:spcBef>
+              <a:spcAft>
+                <a:spcPts val="0"/>
+              </a:spcAft>
+              <a:buClr>
+                <a:srgbClr val="000000"/>
+              </a:buClr>
+              <a:buSzPts val="1800"/>
+              <a:buFont typeface="Arial"/>
+              <a:buNone/>
+            </a:pPr>
+            <a:endParaRPr sz="1800" b="0" i="0" u="none" strike="noStrike" cap="none">
+              <a:solidFill>
+                <a:schemeClr val="lt1"/>
+              </a:solidFill>
+              <a:latin typeface="Calibri"/>
+              <a:ea typeface="Calibri"/>
+              <a:cs typeface="Calibri"/>
+              <a:sym typeface="Calibri"/>
+            </a:endParaRPr>
+          </a:p>
+        </p:txBody>
+      </p:sp>
+      <p:sp>
+        <p:nvSpPr>
+          <p:cNvPr id="148" name="Google Shape;148;p31"/>
+          <p:cNvSpPr txBox="1"/>
+          <p:nvPr/>
+        </p:nvSpPr>
+        <p:spPr>
+          <a:xfrm>
+            <a:off x="1494115" y="4747225"/>
+            <a:ext cx="2280491" cy="369332"/>
+          </a:xfrm>
+          <a:prstGeom prst="rect">
+            <a:avLst/>
+          </a:prstGeom>
+          <a:noFill/>
+          <a:ln>
+            <a:noFill/>
+          </a:ln>
+        </p:spPr>
+        <p:txBody>
+          <a:bodyPr spcFirstLastPara="1" wrap="square" lIns="91425" tIns="45700" rIns="91425" bIns="45700" anchor="t" anchorCtr="0">
+            <a:spAutoFit/>
+          </a:bodyPr>
+          <a:lstStyle/>
+          <a:p>
+            <a:pPr marL="0" marR="0" lvl="0" indent="0" algn="ctr" rtl="0">
+              <a:lnSpc>
+                <a:spcPct val="100000"/>
+              </a:lnSpc>
+              <a:spcBef>
+                <a:spcPts val="0"/>
+              </a:spcBef>
+              <a:spcAft>
+                <a:spcPts val="0"/>
+              </a:spcAft>
+              <a:buClr>
+                <a:srgbClr val="000000"/>
+              </a:buClr>
+              <a:buSzPts val="1800"/>
+              <a:buFont typeface="Arial"/>
+              <a:buNone/>
+            </a:pPr>
+            <a:r>
+              <a:rPr lang="en-US" sz="1800" b="0" i="0" u="none" strike="noStrike" cap="none">
+                <a:solidFill>
+                  <a:srgbClr val="A5A5A5"/>
+                </a:solidFill>
+                <a:latin typeface="Arial"/>
+                <a:ea typeface="Arial"/>
+                <a:cs typeface="Arial"/>
+                <a:sym typeface="Arial"/>
+              </a:rPr>
+              <a:t>IMAGE / GRAPHIC</a:t>
+            </a:r>
+            <a:endParaRPr sz="1400" b="0" i="0" u="none" strike="noStrike" cap="none">
+              <a:solidFill>
+                <a:srgbClr val="000000"/>
+              </a:solidFill>
+              <a:latin typeface="Arial"/>
+              <a:ea typeface="Arial"/>
+              <a:cs typeface="Arial"/>
+              <a:sym typeface="Arial"/>
+            </a:endParaRPr>
+          </a:p>
+        </p:txBody>
+      </p:sp>
+      <p:sp>
+        <p:nvSpPr>
+          <p:cNvPr id="149" name="Google Shape;149;p31"/>
+          <p:cNvSpPr txBox="1"/>
+          <p:nvPr/>
+        </p:nvSpPr>
+        <p:spPr>
+          <a:xfrm>
+            <a:off x="5122548" y="1334279"/>
+            <a:ext cx="6686464" cy="4821102"/>
+          </a:xfrm>
+          <a:prstGeom prst="rect">
+            <a:avLst/>
+          </a:prstGeom>
+          <a:noFill/>
+          <a:ln>
+            <a:noFill/>
+          </a:ln>
+        </p:spPr>
+        <p:txBody>
+          <a:bodyPr spcFirstLastPara="1" wrap="square" lIns="91425" tIns="45700" rIns="91425" bIns="45700" anchor="t" anchorCtr="0">
+            <a:noAutofit/>
+          </a:bodyPr>
+          <a:lstStyle/>
+          <a:p>
+            <a:pPr marL="0" marR="0" lvl="0" indent="0" algn="l" rtl="0">
+              <a:lnSpc>
+                <a:spcPct val="100000"/>
+              </a:lnSpc>
+              <a:spcBef>
+                <a:spcPts val="0"/>
+              </a:spcBef>
+              <a:spcAft>
+                <a:spcPts val="0"/>
+              </a:spcAft>
+              <a:buNone/>
+            </a:pPr>
+            <a:r>
+              <a:rPr lang="en-US" sz="2600" b="1" i="0" u="none" strike="noStrike" cap="none">
+                <a:solidFill>
+                  <a:srgbClr val="E84B36"/>
+                </a:solidFill>
+                <a:latin typeface="Arial"/>
+                <a:ea typeface="Arial"/>
+                <a:cs typeface="Arial"/>
+                <a:sym typeface="Arial"/>
+              </a:rPr>
+              <a:t>Lorem Ipsum Dolor Sit Amet Consectetur Adipiscing</a:t>
+            </a:r>
+            <a:endParaRPr sz="2600" b="1" i="0" u="none" strike="noStrike" cap="none">
+              <a:solidFill>
+                <a:srgbClr val="E84B36"/>
+              </a:solidFill>
+              <a:latin typeface="Arial"/>
+              <a:ea typeface="Arial"/>
+              <a:cs typeface="Arial"/>
+              <a:sym typeface="Arial"/>
+            </a:endParaRPr>
+          </a:p>
+          <a:p>
+            <a:pPr marL="0" marR="0" lvl="0" indent="0" algn="l" rtl="0">
+              <a:lnSpc>
+                <a:spcPct val="100000"/>
+              </a:lnSpc>
+              <a:spcBef>
+                <a:spcPts val="0"/>
+              </a:spcBef>
+              <a:spcAft>
+                <a:spcPts val="0"/>
+              </a:spcAft>
+              <a:buNone/>
+            </a:pPr>
+            <a:endParaRPr sz="1800" b="0" i="0" u="none" strike="noStrike" cap="none">
+              <a:solidFill>
+                <a:schemeClr val="dk1"/>
+              </a:solidFill>
+              <a:latin typeface="Arial"/>
+              <a:ea typeface="Arial"/>
+              <a:cs typeface="Arial"/>
+              <a:sym typeface="Arial"/>
+            </a:endParaRPr>
+          </a:p>
+          <a:p>
+            <a:pPr marL="0" marR="0" lvl="0" indent="0" algn="l" rtl="0">
+              <a:lnSpc>
+                <a:spcPct val="100000"/>
+              </a:lnSpc>
+              <a:spcBef>
+                <a:spcPts val="0"/>
+              </a:spcBef>
+              <a:spcAft>
+                <a:spcPts val="0"/>
+              </a:spcAft>
+              <a:buNone/>
+            </a:pPr>
+            <a:r>
+              <a:rPr lang="en-US" sz="1800" b="0" i="0" u="none" strike="noStrike" cap="none">
+                <a:solidFill>
+                  <a:srgbClr val="000000"/>
+                </a:solidFill>
+                <a:latin typeface="Arial"/>
+                <a:ea typeface="Arial"/>
+                <a:cs typeface="Arial"/>
+                <a:sym typeface="Arial"/>
+              </a:rPr>
+              <a:t>Lorem ipsum dolor sit amet, consectetur adipiscing elit, sed do eiusmod tempor incididunt ut labore et dolore magna aliqua. Ut enim ad minim veniam, quis nostrud exercitation ullamco laboris nisi ut aliquip ex ea commodo consequat. </a:t>
+            </a:r>
+            <a:endParaRPr/>
+          </a:p>
+          <a:p>
+            <a:pPr marL="0" marR="0" lvl="0" indent="0" algn="l" rtl="0">
+              <a:lnSpc>
+                <a:spcPct val="100000"/>
+              </a:lnSpc>
+              <a:spcBef>
+                <a:spcPts val="0"/>
+              </a:spcBef>
+              <a:spcAft>
+                <a:spcPts val="0"/>
+              </a:spcAft>
+              <a:buNone/>
+            </a:pPr>
+            <a:endParaRPr sz="1800" b="0" i="0" u="none" strike="noStrike" cap="none">
+              <a:solidFill>
+                <a:schemeClr val="dk1"/>
+              </a:solidFill>
+              <a:latin typeface="Arial"/>
+              <a:ea typeface="Arial"/>
+              <a:cs typeface="Arial"/>
+              <a:sym typeface="Arial"/>
+            </a:endParaRPr>
+          </a:p>
+          <a:p>
+            <a:pPr marL="0" marR="0" lvl="0" indent="0" algn="l" rtl="0">
+              <a:lnSpc>
+                <a:spcPct val="100000"/>
+              </a:lnSpc>
+              <a:spcBef>
+                <a:spcPts val="0"/>
+              </a:spcBef>
+              <a:spcAft>
+                <a:spcPts val="0"/>
+              </a:spcAft>
+              <a:buNone/>
+            </a:pPr>
+            <a:r>
+              <a:rPr lang="en-US" sz="2000" b="1" i="0" u="none" strike="noStrike" cap="none">
+                <a:solidFill>
+                  <a:srgbClr val="15264B"/>
+                </a:solidFill>
+                <a:latin typeface="Arial"/>
+                <a:ea typeface="Arial"/>
+                <a:cs typeface="Arial"/>
+                <a:sym typeface="Arial"/>
+              </a:rPr>
+              <a:t>Lorem Ipsum Dolor Sit Amet Consectetur Adipiscing</a:t>
+            </a:r>
+            <a:endParaRPr sz="2000" b="1" i="0" u="none" strike="noStrike" cap="none">
+              <a:solidFill>
+                <a:srgbClr val="15264B"/>
+              </a:solidFill>
+              <a:latin typeface="Arial"/>
+              <a:ea typeface="Arial"/>
+              <a:cs typeface="Arial"/>
+              <a:sym typeface="Arial"/>
+            </a:endParaRPr>
+          </a:p>
+          <a:p>
+            <a:pPr marL="0" marR="0" lvl="0" indent="0" algn="l" rtl="0">
+              <a:lnSpc>
+                <a:spcPct val="100000"/>
+              </a:lnSpc>
+              <a:spcBef>
+                <a:spcPts val="0"/>
+              </a:spcBef>
+              <a:spcAft>
+                <a:spcPts val="0"/>
+              </a:spcAft>
+              <a:buNone/>
+            </a:pPr>
+            <a:endParaRPr sz="1800" b="1" i="0" u="none" strike="noStrike" cap="none">
+              <a:solidFill>
+                <a:schemeClr val="dk1"/>
+              </a:solidFill>
+              <a:latin typeface="Arial"/>
+              <a:ea typeface="Arial"/>
+              <a:cs typeface="Arial"/>
+              <a:sym typeface="Arial"/>
+            </a:endParaRPr>
+          </a:p>
+          <a:p>
+            <a:pPr marL="0" marR="0" lvl="0" indent="0" algn="l" rtl="0">
+              <a:lnSpc>
+                <a:spcPct val="100000"/>
+              </a:lnSpc>
+              <a:spcBef>
+                <a:spcPts val="0"/>
+              </a:spcBef>
+              <a:spcAft>
+                <a:spcPts val="0"/>
+              </a:spcAft>
+              <a:buNone/>
+            </a:pPr>
+            <a:r>
+              <a:rPr lang="en-US" sz="1800" b="0" i="0" u="none" strike="noStrike" cap="none">
+                <a:solidFill>
+                  <a:srgbClr val="000000"/>
+                </a:solidFill>
+                <a:latin typeface="Arial"/>
+                <a:ea typeface="Arial"/>
+                <a:cs typeface="Arial"/>
+                <a:sym typeface="Arial"/>
+              </a:rPr>
+              <a:t>Lorem ipsum dolor sit amet, consectetur adipiscing elit, sed do eiusmod tempor incididunt ut labore et dolore magna aliqua.</a:t>
+            </a:r>
+            <a:endParaRPr sz="1800" b="1" i="0" u="none" strike="noStrike" cap="none">
+              <a:solidFill>
+                <a:schemeClr val="dk1"/>
+              </a:solidFill>
+              <a:latin typeface="Arial"/>
+              <a:ea typeface="Arial"/>
+              <a:cs typeface="Arial"/>
+              <a:sym typeface="Arial"/>
+            </a:endParaRPr>
+          </a:p>
+        </p:txBody>
+      </p:sp>
+      <p:sp>
+        <p:nvSpPr>
+          <p:cNvPr id="150" name="Google Shape;150;p31"/>
+          <p:cNvSpPr/>
+          <p:nvPr/>
+        </p:nvSpPr>
+        <p:spPr>
+          <a:xfrm rot="10800000" flipH="1">
+            <a:off x="0" y="0"/>
+            <a:ext cx="12192000" cy="868220"/>
+          </a:xfrm>
+          <a:prstGeom prst="rect">
+            <a:avLst/>
+          </a:prstGeom>
+          <a:solidFill>
+            <a:srgbClr val="13294B"/>
+          </a:solidFill>
+          <a:ln>
+            <a:noFill/>
+          </a:ln>
+        </p:spPr>
+        <p:txBody>
+          <a:bodyPr spcFirstLastPara="1" wrap="square" lIns="91425" tIns="45700" rIns="91425" bIns="45700" anchor="ctr" anchorCtr="0">
+            <a:noAutofit/>
+          </a:bodyPr>
+          <a:lstStyle/>
+          <a:p>
+            <a:pPr marL="0" marR="0" lvl="0" indent="0" algn="ctr" rtl="0">
+              <a:lnSpc>
+                <a:spcPct val="100000"/>
+              </a:lnSpc>
+              <a:spcBef>
+                <a:spcPts val="0"/>
+              </a:spcBef>
+              <a:spcAft>
+                <a:spcPts val="0"/>
+              </a:spcAft>
+              <a:buClr>
+                <a:schemeClr val="lt1"/>
+              </a:buClr>
+              <a:buSzPts val="1800"/>
+              <a:buFont typeface="Calibri"/>
+              <a:buNone/>
+            </a:pPr>
+            <a:endParaRPr sz="1800" b="0" i="0" u="none" strike="noStrike" cap="none">
+              <a:solidFill>
+                <a:srgbClr val="13294B"/>
+              </a:solidFill>
+              <a:latin typeface="Calibri"/>
+              <a:ea typeface="Calibri"/>
+              <a:cs typeface="Calibri"/>
+              <a:sym typeface="Calibri"/>
+            </a:endParaRPr>
+          </a:p>
+        </p:txBody>
+      </p:sp>
+      <p:sp>
+        <p:nvSpPr>
+          <p:cNvPr id="151" name="Google Shape;151;p31"/>
+          <p:cNvSpPr txBox="1"/>
+          <p:nvPr/>
+        </p:nvSpPr>
+        <p:spPr>
+          <a:xfrm>
+            <a:off x="376810" y="204051"/>
+            <a:ext cx="10910026" cy="461624"/>
+          </a:xfrm>
+          <a:prstGeom prst="rect">
+            <a:avLst/>
+          </a:prstGeom>
+          <a:noFill/>
+          <a:ln>
+            <a:noFill/>
+          </a:ln>
+        </p:spPr>
+        <p:txBody>
+          <a:bodyPr spcFirstLastPara="1" wrap="square" lIns="91425" tIns="45700" rIns="91425" bIns="45700" anchor="t" anchorCtr="0">
+            <a:spAutoFit/>
+          </a:bodyPr>
+          <a:lstStyle/>
+          <a:p>
+            <a:pPr marL="0" marR="0" lvl="0" indent="0" algn="l" rtl="0">
+              <a:lnSpc>
+                <a:spcPct val="100000"/>
+              </a:lnSpc>
+              <a:spcBef>
+                <a:spcPts val="0"/>
+              </a:spcBef>
+              <a:spcAft>
+                <a:spcPts val="0"/>
+              </a:spcAft>
+              <a:buClr>
+                <a:srgbClr val="000000"/>
+              </a:buClr>
+              <a:buSzPts val="2400"/>
+              <a:buFont typeface="Arial"/>
+              <a:buNone/>
+            </a:pPr>
+            <a:r>
+              <a:rPr lang="en-US" sz="2400" b="0" i="0" u="none" strike="noStrike" cap="none">
+                <a:solidFill>
+                  <a:schemeClr val="lt1"/>
+                </a:solidFill>
+                <a:latin typeface="Arial"/>
+                <a:ea typeface="Arial"/>
+                <a:cs typeface="Arial"/>
+                <a:sym typeface="Arial"/>
+              </a:rPr>
+              <a:t>Slide Title</a:t>
+            </a:r>
+            <a:endParaRPr sz="2400" b="0" i="0" u="none" strike="noStrike" cap="none">
+              <a:solidFill>
+                <a:schemeClr val="lt1"/>
+              </a:solidFill>
+              <a:latin typeface="Arial"/>
+              <a:ea typeface="Arial"/>
+              <a:cs typeface="Arial"/>
+              <a:sym typeface="Arial"/>
+            </a:endParaRPr>
+          </a:p>
+        </p:txBody>
+      </p:sp>
+      <p:pic>
+        <p:nvPicPr>
+          <p:cNvPr id="152" name="Google Shape;152;p31"/>
+          <p:cNvPicPr preferRelativeResize="0"/>
+          <p:nvPr/>
+        </p:nvPicPr>
+        <p:blipFill rotWithShape="1">
+          <a:blip r:embed="rId3">
+            <a:alphaModFix/>
+          </a:blip>
+          <a:srcRect/>
+          <a:stretch/>
+        </p:blipFill>
+        <p:spPr>
+          <a:xfrm>
+            <a:off x="11557509" y="233819"/>
+            <a:ext cx="271308" cy="389810"/>
+          </a:xfrm>
+          <a:prstGeom prst="rect">
+            <a:avLst/>
+          </a:prstGeom>
+          <a:noFill/>
+          <a:ln>
+            <a:noFill/>
+          </a:ln>
+        </p:spPr>
+      </p:pic>
+      <p:sp>
+        <p:nvSpPr>
+          <p:cNvPr id="153" name="Google Shape;153;p31"/>
+          <p:cNvSpPr txBox="1"/>
+          <p:nvPr/>
+        </p:nvSpPr>
+        <p:spPr>
+          <a:xfrm>
+            <a:off x="9335597" y="6524381"/>
+            <a:ext cx="2473415" cy="230792"/>
+          </a:xfrm>
+          <a:prstGeom prst="rect">
+            <a:avLst/>
+          </a:prstGeom>
+          <a:noFill/>
+          <a:ln>
+            <a:noFill/>
+          </a:ln>
+        </p:spPr>
+        <p:txBody>
+          <a:bodyPr spcFirstLastPara="1" wrap="square" lIns="91425" tIns="45700" rIns="91425" bIns="45700" anchor="t" anchorCtr="0">
+            <a:spAutoFit/>
+          </a:bodyPr>
+          <a:lstStyle/>
+          <a:p>
+            <a:pPr marL="0" marR="0" lvl="0" indent="0" algn="r" rtl="0">
+              <a:lnSpc>
+                <a:spcPct val="100000"/>
+              </a:lnSpc>
+              <a:spcBef>
+                <a:spcPts val="0"/>
+              </a:spcBef>
+              <a:spcAft>
+                <a:spcPts val="0"/>
+              </a:spcAft>
+              <a:buNone/>
+            </a:pPr>
+            <a:r>
+              <a:rPr lang="en-US" sz="900" b="0" i="0" u="none" strike="noStrike" cap="none">
+                <a:solidFill>
+                  <a:srgbClr val="13294B"/>
+                </a:solidFill>
+                <a:latin typeface="Arial"/>
+                <a:ea typeface="Arial"/>
+                <a:cs typeface="Arial"/>
+                <a:sym typeface="Arial"/>
+              </a:rPr>
+              <a:t>GRAINGER ENGINEERING</a:t>
+            </a:r>
+            <a:endParaRPr/>
+          </a:p>
+        </p:txBody>
+      </p:sp>
+      <p:sp>
+        <p:nvSpPr>
+          <p:cNvPr id="154" name="Google Shape;154;p31"/>
+          <p:cNvSpPr txBox="1"/>
+          <p:nvPr/>
+        </p:nvSpPr>
+        <p:spPr>
+          <a:xfrm>
+            <a:off x="376807" y="6524381"/>
+            <a:ext cx="7991400" cy="230700"/>
+          </a:xfrm>
+          <a:prstGeom prst="rect">
+            <a:avLst/>
+          </a:prstGeom>
+          <a:noFill/>
+          <a:ln>
+            <a:noFill/>
+          </a:ln>
+        </p:spPr>
+        <p:txBody>
+          <a:bodyPr spcFirstLastPara="1" wrap="square" lIns="91425" tIns="45700" rIns="91425" bIns="45700" anchor="t" anchorCtr="0">
+            <a:spAutoFit/>
+          </a:bodyPr>
+          <a:lstStyle/>
+          <a:p>
+            <a:pPr marL="0" marR="0" lvl="0" indent="0" algn="l" rtl="0">
+              <a:lnSpc>
+                <a:spcPct val="100000"/>
+              </a:lnSpc>
+              <a:spcBef>
+                <a:spcPts val="0"/>
+              </a:spcBef>
+              <a:spcAft>
+                <a:spcPts val="0"/>
+              </a:spcAft>
+              <a:buNone/>
+            </a:pPr>
+            <a:r>
+              <a:rPr lang="en-US" sz="900" dirty="0">
+                <a:solidFill>
+                  <a:srgbClr val="13294B"/>
+                </a:solidFill>
+              </a:rPr>
+              <a:t>SYSTEMS ENGINEERING</a:t>
+            </a:r>
+            <a:endParaRPr dirty="0"/>
+          </a:p>
+        </p:txBody>
+      </p:sp>
+      <p:grpSp>
+        <p:nvGrpSpPr>
+          <p:cNvPr id="155" name="Google Shape;155;p31"/>
+          <p:cNvGrpSpPr/>
+          <p:nvPr/>
+        </p:nvGrpSpPr>
+        <p:grpSpPr>
+          <a:xfrm>
+            <a:off x="4066674" y="6601537"/>
+            <a:ext cx="5233412" cy="70446"/>
+            <a:chOff x="4033424" y="6601537"/>
+            <a:chExt cx="5233412" cy="70446"/>
+          </a:xfrm>
+        </p:grpSpPr>
+        <p:cxnSp>
+          <p:nvCxnSpPr>
+            <p:cNvPr id="156" name="Google Shape;156;p31"/>
+            <p:cNvCxnSpPr/>
+            <p:nvPr/>
+          </p:nvCxnSpPr>
+          <p:spPr>
+            <a:xfrm rot="10800000">
+              <a:off x="4033424" y="6639606"/>
+              <a:ext cx="5164651" cy="0"/>
+            </a:xfrm>
+            <a:prstGeom prst="straightConnector1">
+              <a:avLst/>
+            </a:prstGeom>
+            <a:noFill/>
+            <a:ln w="9525" cap="flat" cmpd="sng">
+              <a:solidFill>
+                <a:srgbClr val="13294B"/>
+              </a:solidFill>
+              <a:prstDash val="solid"/>
+              <a:round/>
+              <a:headEnd type="none" w="sm" len="sm"/>
+              <a:tailEnd type="none" w="sm" len="sm"/>
+            </a:ln>
+          </p:spPr>
+        </p:cxnSp>
+        <p:sp>
+          <p:nvSpPr>
+            <p:cNvPr id="157" name="Google Shape;157;p31"/>
+            <p:cNvSpPr/>
+            <p:nvPr/>
+          </p:nvSpPr>
+          <p:spPr>
+            <a:xfrm>
+              <a:off x="9196390" y="6601537"/>
+              <a:ext cx="70446" cy="70446"/>
+            </a:xfrm>
+            <a:prstGeom prst="ellipse">
+              <a:avLst/>
+            </a:prstGeom>
+            <a:solidFill>
+              <a:srgbClr val="13294B"/>
+            </a:solidFill>
+            <a:ln>
+              <a:noFill/>
+            </a:ln>
+          </p:spPr>
+          <p:txBody>
+            <a:bodyPr spcFirstLastPara="1" wrap="square" lIns="91425" tIns="45700" rIns="91425" bIns="45700" anchor="ctr" anchorCtr="0">
+              <a:noAutofit/>
+            </a:bodyPr>
+            <a:lstStyle/>
+            <a:p>
+              <a:pPr marL="0" marR="0" lvl="0" indent="0" algn="ctr" rtl="0">
+                <a:lnSpc>
+                  <a:spcPct val="100000"/>
+                </a:lnSpc>
+                <a:spcBef>
+                  <a:spcPts val="0"/>
+                </a:spcBef>
+                <a:spcAft>
+                  <a:spcPts val="0"/>
+                </a:spcAft>
+                <a:buNone/>
+              </a:pPr>
+              <a:endParaRPr sz="1400" b="0" i="0" u="none" strike="noStrike" cap="none">
+                <a:solidFill>
+                  <a:srgbClr val="13294B"/>
+                </a:solidFill>
+                <a:latin typeface="Arial"/>
+                <a:ea typeface="Arial"/>
+                <a:cs typeface="Arial"/>
+                <a:sym typeface="Arial"/>
+              </a:endParaRPr>
+            </a:p>
+          </p:txBody>
+        </p:sp>
+      </p:grpSp>
+    </p:spTree>
+  </p:cSld>
+  <p:clrMapOvr>
+    <a:masterClrMapping/>
+  </p:clrMapOvr>
+</p:sld>
+</file>
+
+<file path=ppt/slides/slide11.xml><?xml version="1.0" encoding="utf-8"?>
+<p:sld xmlns:a="http://schemas.openxmlformats.org/drawingml/2006/main" xmlns:r="http://schemas.openxmlformats.org/officeDocument/2006/relationships" xmlns:p="http://schemas.openxmlformats.org/presentationml/2006/main">
+  <p:cSld>
+    <p:spTree>
+      <p:nvGrpSpPr>
         <p:cNvPr id="1" name="Shape 161"/>
         <p:cNvGrpSpPr/>
         <p:nvPr/>
@@ -17429,7 +18414,7 @@
 </p:sld>
 </file>
 
-<file path=ppt/slides/slide11.xml><?xml version="1.0" encoding="utf-8"?>
+<file path=ppt/slides/slide12.xml><?xml version="1.0" encoding="utf-8"?>
 <p:sld xmlns:a="http://schemas.openxmlformats.org/drawingml/2006/main" xmlns:r="http://schemas.openxmlformats.org/officeDocument/2006/relationships" xmlns:p="http://schemas.openxmlformats.org/presentationml/2006/main">
   <p:cSld>
     <p:spTree>
@@ -18146,7 +19131,7 @@
 </p:sld>
 </file>
 
-<file path=ppt/slides/slide12.xml><?xml version="1.0" encoding="utf-8"?>
+<file path=ppt/slides/slide13.xml><?xml version="1.0" encoding="utf-8"?>
 <p:sld xmlns:a="http://schemas.openxmlformats.org/drawingml/2006/main" xmlns:r="http://schemas.openxmlformats.org/officeDocument/2006/relationships" xmlns:p="http://schemas.openxmlformats.org/presentationml/2006/main">
   <p:cSld>
     <p:spTree>
@@ -18863,7 +19848,7 @@
 </p:sld>
 </file>
 
-<file path=ppt/slides/slide13.xml><?xml version="1.0" encoding="utf-8"?>
+<file path=ppt/slides/slide14.xml><?xml version="1.0" encoding="utf-8"?>
 <p:sld xmlns:a="http://schemas.openxmlformats.org/drawingml/2006/main" xmlns:r="http://schemas.openxmlformats.org/officeDocument/2006/relationships" xmlns:p="http://schemas.openxmlformats.org/presentationml/2006/main">
   <p:cSld>
     <p:spTree>
@@ -19419,7 +20404,7 @@
 </p:sld>
 </file>
 
-<file path=ppt/slides/slide14.xml><?xml version="1.0" encoding="utf-8"?>
+<file path=ppt/slides/slide15.xml><?xml version="1.0" encoding="utf-8"?>
 <p:sld xmlns:a="http://schemas.openxmlformats.org/drawingml/2006/main" xmlns:r="http://schemas.openxmlformats.org/officeDocument/2006/relationships" xmlns:p="http://schemas.openxmlformats.org/presentationml/2006/main">
   <p:cSld>
     <p:spTree>
@@ -19885,7 +20870,7 @@
 </p:sld>
 </file>
 
-<file path=ppt/slides/slide15.xml><?xml version="1.0" encoding="utf-8"?>
+<file path=ppt/slides/slide16.xml><?xml version="1.0" encoding="utf-8"?>
 <p:sld xmlns:a="http://schemas.openxmlformats.org/drawingml/2006/main" xmlns:r="http://schemas.openxmlformats.org/officeDocument/2006/relationships" xmlns:p="http://schemas.openxmlformats.org/presentationml/2006/main">
   <p:cSld>
     <p:bg>
@@ -20488,7 +21473,7 @@
 </p:sld>
 </file>
 
-<file path=ppt/slides/slide16.xml><?xml version="1.0" encoding="utf-8"?>
+<file path=ppt/slides/slide17.xml><?xml version="1.0" encoding="utf-8"?>
 <p:sld xmlns:a="http://schemas.openxmlformats.org/drawingml/2006/main" xmlns:r="http://schemas.openxmlformats.org/officeDocument/2006/relationships" xmlns:p="http://schemas.openxmlformats.org/presentationml/2006/main">
   <p:cSld>
     <p:spTree>
@@ -21062,7 +22047,7 @@
 </p:sld>
 </file>
 
-<file path=ppt/slides/slide17.xml><?xml version="1.0" encoding="utf-8"?>
+<file path=ppt/slides/slide18.xml><?xml version="1.0" encoding="utf-8"?>
 <p:sld xmlns:a="http://schemas.openxmlformats.org/drawingml/2006/main" xmlns:r="http://schemas.openxmlformats.org/officeDocument/2006/relationships" xmlns:p="http://schemas.openxmlformats.org/presentationml/2006/main">
   <p:cSld>
     <p:bg>
@@ -21594,7 +22579,7 @@
 </p:sld>
 </file>
 
-<file path=ppt/slides/slide18.xml><?xml version="1.0" encoding="utf-8"?>
+<file path=ppt/slides/slide19.xml><?xml version="1.0" encoding="utf-8"?>
 <p:sld xmlns:a="http://schemas.openxmlformats.org/drawingml/2006/main" xmlns:r="http://schemas.openxmlformats.org/officeDocument/2006/relationships" xmlns:p="http://schemas.openxmlformats.org/presentationml/2006/main">
   <p:cSld>
     <p:bg>
@@ -22116,7 +23101,633 @@
 </p:sld>
 </file>
 
-<file path=ppt/slides/slide19.xml><?xml version="1.0" encoding="utf-8"?>
+<file path=ppt/slides/slide2.xml><?xml version="1.0" encoding="utf-8"?>
+<p:sld xmlns:a="http://schemas.openxmlformats.org/drawingml/2006/main" xmlns:r="http://schemas.openxmlformats.org/officeDocument/2006/relationships" xmlns:p="http://schemas.openxmlformats.org/presentationml/2006/main">
+  <p:cSld>
+    <p:spTree>
+      <p:nvGrpSpPr>
+        <p:cNvPr id="1" name="Shape 117">
+          <a:extLst>
+            <a:ext uri="{FF2B5EF4-FFF2-40B4-BE49-F238E27FC236}">
+              <a16:creationId xmlns:a16="http://schemas.microsoft.com/office/drawing/2014/main" id="{B787707C-0AB4-57C3-5639-B4BEF4389386}"/>
+            </a:ext>
+          </a:extLst>
+        </p:cNvPr>
+        <p:cNvGrpSpPr/>
+        <p:nvPr/>
+      </p:nvGrpSpPr>
+      <p:grpSpPr>
+        <a:xfrm>
+          <a:off x="0" y="0"/>
+          <a:ext cx="0" cy="0"/>
+          <a:chOff x="0" y="0"/>
+          <a:chExt cx="0" cy="0"/>
+        </a:xfrm>
+      </p:grpSpPr>
+      <p:sp>
+        <p:nvSpPr>
+          <p:cNvPr id="118" name="Google Shape;118;p29">
+            <a:extLst>
+              <a:ext uri="{FF2B5EF4-FFF2-40B4-BE49-F238E27FC236}">
+                <a16:creationId xmlns:a16="http://schemas.microsoft.com/office/drawing/2014/main" id="{E7EA1A55-2BAC-C6A5-ABC3-168138F62B6C}"/>
+              </a:ext>
+            </a:extLst>
+          </p:cNvPr>
+          <p:cNvSpPr txBox="1">
+            <a:spLocks noGrp="1"/>
+          </p:cNvSpPr>
+          <p:nvPr>
+            <p:ph type="body" idx="1"/>
+          </p:nvPr>
+        </p:nvSpPr>
+        <p:spPr>
+          <a:xfrm>
+            <a:off x="376809" y="1334279"/>
+            <a:ext cx="11177401" cy="4821102"/>
+          </a:xfrm>
+          <a:prstGeom prst="rect">
+            <a:avLst/>
+          </a:prstGeom>
+          <a:noFill/>
+          <a:ln>
+            <a:noFill/>
+          </a:ln>
+        </p:spPr>
+        <p:txBody>
+          <a:bodyPr spcFirstLastPara="1" wrap="square" lIns="91425" tIns="45700" rIns="91425" bIns="45700" anchor="t" anchorCtr="0">
+            <a:noAutofit/>
+          </a:bodyPr>
+          <a:lstStyle/>
+          <a:p>
+            <a:pPr marL="0" indent="0">
+              <a:lnSpc>
+                <a:spcPct val="100000"/>
+              </a:lnSpc>
+              <a:spcBef>
+                <a:spcPts val="0"/>
+              </a:spcBef>
+              <a:buSzPts val="3000"/>
+              <a:buNone/>
+            </a:pPr>
+            <a:r>
+              <a:rPr lang="en-US" sz="2400" dirty="0">
+                <a:solidFill>
+                  <a:schemeClr val="dk1"/>
+                </a:solidFill>
+                <a:latin typeface="Arial"/>
+                <a:ea typeface="Arial"/>
+                <a:cs typeface="Arial"/>
+                <a:sym typeface="Arial"/>
+              </a:rPr>
+              <a:t>Talk to the person next to you and answer these questions.</a:t>
+            </a:r>
+          </a:p>
+          <a:p>
+            <a:pPr marL="285750" indent="-285750">
+              <a:lnSpc>
+                <a:spcPct val="100000"/>
+              </a:lnSpc>
+              <a:spcBef>
+                <a:spcPts val="0"/>
+              </a:spcBef>
+              <a:buSzPts val="3000"/>
+            </a:pPr>
+            <a:endParaRPr lang="en-US" sz="2400" dirty="0">
+              <a:latin typeface="Arial"/>
+              <a:ea typeface="Arial"/>
+              <a:cs typeface="Arial"/>
+              <a:sym typeface="Arial"/>
+            </a:endParaRPr>
+          </a:p>
+          <a:p>
+            <a:pPr marL="285750" indent="-285750">
+              <a:lnSpc>
+                <a:spcPct val="100000"/>
+              </a:lnSpc>
+              <a:spcBef>
+                <a:spcPts val="0"/>
+              </a:spcBef>
+              <a:buSzPts val="3000"/>
+            </a:pPr>
+            <a:r>
+              <a:rPr lang="en-US" sz="2400" dirty="0">
+                <a:solidFill>
+                  <a:schemeClr val="dk1"/>
+                </a:solidFill>
+                <a:latin typeface="Arial"/>
+                <a:ea typeface="Arial"/>
+                <a:cs typeface="Arial"/>
+                <a:sym typeface="Arial"/>
+              </a:rPr>
+              <a:t>Last lecture we said we used “BFS”, what does it stand for? What type of data structure is this most commonly used?</a:t>
+            </a:r>
+          </a:p>
+          <a:p>
+            <a:pPr marL="285750" indent="-285750">
+              <a:lnSpc>
+                <a:spcPct val="100000"/>
+              </a:lnSpc>
+              <a:spcBef>
+                <a:spcPts val="0"/>
+              </a:spcBef>
+              <a:buSzPts val="3000"/>
+            </a:pPr>
+            <a:r>
+              <a:rPr lang="en-US" sz="2400" dirty="0">
+                <a:solidFill>
+                  <a:schemeClr val="dk1"/>
+                </a:solidFill>
+                <a:latin typeface="Arial"/>
+                <a:ea typeface="Arial"/>
+                <a:cs typeface="Arial"/>
+                <a:sym typeface="Arial"/>
+              </a:rPr>
+              <a:t>Open on the </a:t>
+            </a:r>
+            <a:r>
+              <a:rPr lang="en-US" sz="2400" dirty="0">
+                <a:latin typeface="Arial"/>
+                <a:ea typeface="Arial"/>
+                <a:cs typeface="Arial"/>
+                <a:sym typeface="Arial"/>
+              </a:rPr>
+              <a:t>lecture’s website the path planning visualization that was made for this lecture (</a:t>
+            </a:r>
+            <a:r>
+              <a:rPr lang="en-US" sz="2400" dirty="0">
+                <a:latin typeface="Arial"/>
+                <a:ea typeface="Arial"/>
+                <a:cs typeface="Arial"/>
+                <a:sym typeface="Arial"/>
+                <a:hlinkClick r:id="rId3"/>
+              </a:rPr>
+              <a:t>https://marius-juston.github.io/SE-423---Class-Material/path_planning.html</a:t>
+            </a:r>
+            <a:r>
+              <a:rPr lang="en-US" sz="2400" dirty="0">
+                <a:latin typeface="Arial"/>
+                <a:ea typeface="Arial"/>
+                <a:cs typeface="Arial"/>
+                <a:sym typeface="Arial"/>
+              </a:rPr>
+              <a:t>), play around and draw some things and press the run button. You don’t need to understand what A* Search, BFS, </a:t>
+            </a:r>
+            <a:r>
+              <a:rPr lang="en-US" sz="2400" dirty="0" err="1">
+                <a:latin typeface="Arial"/>
+                <a:ea typeface="Arial"/>
+                <a:cs typeface="Arial"/>
+                <a:sym typeface="Arial"/>
+              </a:rPr>
+              <a:t>Dijstras</a:t>
+            </a:r>
+            <a:r>
+              <a:rPr lang="en-US" sz="2400" dirty="0">
+                <a:latin typeface="Arial"/>
+                <a:ea typeface="Arial"/>
+                <a:cs typeface="Arial"/>
+                <a:sym typeface="Arial"/>
+              </a:rPr>
+              <a:t> is yet, but I would recommend having this up during lecture so that you can see the different algorithms and settings</a:t>
+            </a:r>
+            <a:endParaRPr lang="en-US" sz="2400" dirty="0">
+              <a:solidFill>
+                <a:schemeClr val="dk1"/>
+              </a:solidFill>
+              <a:latin typeface="Arial"/>
+              <a:ea typeface="Arial"/>
+              <a:cs typeface="Arial"/>
+              <a:sym typeface="Arial"/>
+            </a:endParaRPr>
+          </a:p>
+          <a:p>
+            <a:pPr marL="0" indent="0">
+              <a:lnSpc>
+                <a:spcPct val="100000"/>
+              </a:lnSpc>
+              <a:spcBef>
+                <a:spcPts val="0"/>
+              </a:spcBef>
+              <a:buSzPts val="3000"/>
+              <a:buNone/>
+            </a:pPr>
+            <a:endParaRPr lang="en-US" sz="2400" dirty="0">
+              <a:solidFill>
+                <a:schemeClr val="dk1"/>
+              </a:solidFill>
+              <a:latin typeface="Arial"/>
+              <a:ea typeface="Arial"/>
+              <a:cs typeface="Arial"/>
+              <a:sym typeface="Arial"/>
+            </a:endParaRPr>
+          </a:p>
+        </p:txBody>
+      </p:sp>
+      <p:sp>
+        <p:nvSpPr>
+          <p:cNvPr id="119" name="Google Shape;119;p29">
+            <a:extLst>
+              <a:ext uri="{FF2B5EF4-FFF2-40B4-BE49-F238E27FC236}">
+                <a16:creationId xmlns:a16="http://schemas.microsoft.com/office/drawing/2014/main" id="{AADDCC56-907C-FD39-6E34-87042D08FA2E}"/>
+              </a:ext>
+            </a:extLst>
+          </p:cNvPr>
+          <p:cNvSpPr/>
+          <p:nvPr/>
+        </p:nvSpPr>
+        <p:spPr>
+          <a:xfrm rot="10800000" flipH="1">
+            <a:off x="0" y="0"/>
+            <a:ext cx="12192000" cy="868220"/>
+          </a:xfrm>
+          <a:prstGeom prst="rect">
+            <a:avLst/>
+          </a:prstGeom>
+          <a:solidFill>
+            <a:srgbClr val="13294B"/>
+          </a:solidFill>
+          <a:ln>
+            <a:noFill/>
+          </a:ln>
+        </p:spPr>
+        <p:txBody>
+          <a:bodyPr spcFirstLastPara="1" wrap="square" lIns="91425" tIns="45700" rIns="91425" bIns="45700" anchor="ctr" anchorCtr="0">
+            <a:noAutofit/>
+          </a:bodyPr>
+          <a:lstStyle/>
+          <a:p>
+            <a:pPr marL="0" marR="0" lvl="0" indent="0" algn="ctr" rtl="0">
+              <a:lnSpc>
+                <a:spcPct val="100000"/>
+              </a:lnSpc>
+              <a:spcBef>
+                <a:spcPts val="0"/>
+              </a:spcBef>
+              <a:spcAft>
+                <a:spcPts val="0"/>
+              </a:spcAft>
+              <a:buClr>
+                <a:schemeClr val="lt1"/>
+              </a:buClr>
+              <a:buSzPts val="1800"/>
+              <a:buFont typeface="Calibri"/>
+              <a:buNone/>
+            </a:pPr>
+            <a:endParaRPr sz="1800" b="0" i="0" u="none" strike="noStrike" cap="none">
+              <a:solidFill>
+                <a:srgbClr val="13294B"/>
+              </a:solidFill>
+              <a:latin typeface="Calibri"/>
+              <a:ea typeface="Calibri"/>
+              <a:cs typeface="Calibri"/>
+              <a:sym typeface="Calibri"/>
+            </a:endParaRPr>
+          </a:p>
+        </p:txBody>
+      </p:sp>
+      <p:sp>
+        <p:nvSpPr>
+          <p:cNvPr id="120" name="Google Shape;120;p29">
+            <a:extLst>
+              <a:ext uri="{FF2B5EF4-FFF2-40B4-BE49-F238E27FC236}">
+                <a16:creationId xmlns:a16="http://schemas.microsoft.com/office/drawing/2014/main" id="{C941C760-8B23-A46D-5C4A-981290CB9EBC}"/>
+              </a:ext>
+            </a:extLst>
+          </p:cNvPr>
+          <p:cNvSpPr txBox="1"/>
+          <p:nvPr/>
+        </p:nvSpPr>
+        <p:spPr>
+          <a:xfrm>
+            <a:off x="376810" y="204051"/>
+            <a:ext cx="10910026" cy="461624"/>
+          </a:xfrm>
+          <a:prstGeom prst="rect">
+            <a:avLst/>
+          </a:prstGeom>
+          <a:noFill/>
+          <a:ln>
+            <a:noFill/>
+          </a:ln>
+        </p:spPr>
+        <p:txBody>
+          <a:bodyPr spcFirstLastPara="1" wrap="square" lIns="91425" tIns="45700" rIns="91425" bIns="45700" anchor="t" anchorCtr="0">
+            <a:spAutoFit/>
+          </a:bodyPr>
+          <a:lstStyle/>
+          <a:p>
+            <a:pPr marL="0" marR="0" lvl="0" indent="0" algn="l" rtl="0">
+              <a:lnSpc>
+                <a:spcPct val="100000"/>
+              </a:lnSpc>
+              <a:spcBef>
+                <a:spcPts val="0"/>
+              </a:spcBef>
+              <a:spcAft>
+                <a:spcPts val="0"/>
+              </a:spcAft>
+              <a:buClr>
+                <a:srgbClr val="000000"/>
+              </a:buClr>
+              <a:buSzPts val="2400"/>
+              <a:buFont typeface="Arial"/>
+              <a:buNone/>
+            </a:pPr>
+            <a:r>
+              <a:rPr lang="en-US" sz="2400" b="0" i="0" u="none" strike="noStrike" cap="none" dirty="0">
+                <a:solidFill>
+                  <a:schemeClr val="lt1"/>
+                </a:solidFill>
+                <a:latin typeface="Arial"/>
+                <a:ea typeface="Arial"/>
+                <a:cs typeface="Arial"/>
+                <a:sym typeface="Arial"/>
+              </a:rPr>
+              <a:t>Review – 5-minute partner discussion</a:t>
+            </a:r>
+            <a:endParaRPr sz="2400" b="0" i="0" u="none" strike="noStrike" cap="none" dirty="0">
+              <a:solidFill>
+                <a:schemeClr val="lt1"/>
+              </a:solidFill>
+              <a:latin typeface="Arial"/>
+              <a:ea typeface="Arial"/>
+              <a:cs typeface="Arial"/>
+              <a:sym typeface="Arial"/>
+            </a:endParaRPr>
+          </a:p>
+        </p:txBody>
+      </p:sp>
+      <p:pic>
+        <p:nvPicPr>
+          <p:cNvPr id="121" name="Google Shape;121;p29">
+            <a:extLst>
+              <a:ext uri="{FF2B5EF4-FFF2-40B4-BE49-F238E27FC236}">
+                <a16:creationId xmlns:a16="http://schemas.microsoft.com/office/drawing/2014/main" id="{C1984774-B7FA-53FC-ECBE-3FFBD377F556}"/>
+              </a:ext>
+            </a:extLst>
+          </p:cNvPr>
+          <p:cNvPicPr preferRelativeResize="0"/>
+          <p:nvPr/>
+        </p:nvPicPr>
+        <p:blipFill rotWithShape="1">
+          <a:blip r:embed="rId4">
+            <a:alphaModFix/>
+          </a:blip>
+          <a:srcRect/>
+          <a:stretch/>
+        </p:blipFill>
+        <p:spPr>
+          <a:xfrm>
+            <a:off x="11557509" y="233819"/>
+            <a:ext cx="271308" cy="389810"/>
+          </a:xfrm>
+          <a:prstGeom prst="rect">
+            <a:avLst/>
+          </a:prstGeom>
+          <a:noFill/>
+          <a:ln>
+            <a:noFill/>
+          </a:ln>
+        </p:spPr>
+      </p:pic>
+      <p:sp>
+        <p:nvSpPr>
+          <p:cNvPr id="122" name="Google Shape;122;p29">
+            <a:extLst>
+              <a:ext uri="{FF2B5EF4-FFF2-40B4-BE49-F238E27FC236}">
+                <a16:creationId xmlns:a16="http://schemas.microsoft.com/office/drawing/2014/main" id="{D52648EA-0120-942E-FA7D-98B9C25F4F34}"/>
+              </a:ext>
+            </a:extLst>
+          </p:cNvPr>
+          <p:cNvSpPr txBox="1"/>
+          <p:nvPr/>
+        </p:nvSpPr>
+        <p:spPr>
+          <a:xfrm>
+            <a:off x="9335597" y="6524381"/>
+            <a:ext cx="2473415" cy="230792"/>
+          </a:xfrm>
+          <a:prstGeom prst="rect">
+            <a:avLst/>
+          </a:prstGeom>
+          <a:noFill/>
+          <a:ln>
+            <a:noFill/>
+          </a:ln>
+        </p:spPr>
+        <p:txBody>
+          <a:bodyPr spcFirstLastPara="1" wrap="square" lIns="91425" tIns="45700" rIns="91425" bIns="45700" anchor="t" anchorCtr="0">
+            <a:spAutoFit/>
+          </a:bodyPr>
+          <a:lstStyle/>
+          <a:p>
+            <a:pPr marL="0" marR="0" lvl="0" indent="0" algn="r" rtl="0">
+              <a:lnSpc>
+                <a:spcPct val="100000"/>
+              </a:lnSpc>
+              <a:spcBef>
+                <a:spcPts val="0"/>
+              </a:spcBef>
+              <a:spcAft>
+                <a:spcPts val="0"/>
+              </a:spcAft>
+              <a:buNone/>
+            </a:pPr>
+            <a:r>
+              <a:rPr lang="en-US" sz="900" b="0" i="0" u="none" strike="noStrike" cap="none">
+                <a:solidFill>
+                  <a:srgbClr val="13294B"/>
+                </a:solidFill>
+                <a:latin typeface="Arial"/>
+                <a:ea typeface="Arial"/>
+                <a:cs typeface="Arial"/>
+                <a:sym typeface="Arial"/>
+              </a:rPr>
+              <a:t>GRAINGER ENGINEERING</a:t>
+            </a:r>
+            <a:endParaRPr/>
+          </a:p>
+        </p:txBody>
+      </p:sp>
+      <p:sp>
+        <p:nvSpPr>
+          <p:cNvPr id="123" name="Google Shape;123;p29">
+            <a:extLst>
+              <a:ext uri="{FF2B5EF4-FFF2-40B4-BE49-F238E27FC236}">
+                <a16:creationId xmlns:a16="http://schemas.microsoft.com/office/drawing/2014/main" id="{9187DBB9-03BE-10E2-9B63-400A9675CEAD}"/>
+              </a:ext>
+            </a:extLst>
+          </p:cNvPr>
+          <p:cNvSpPr txBox="1"/>
+          <p:nvPr/>
+        </p:nvSpPr>
+        <p:spPr>
+          <a:xfrm>
+            <a:off x="376807" y="6524381"/>
+            <a:ext cx="7991337" cy="230792"/>
+          </a:xfrm>
+          <a:prstGeom prst="rect">
+            <a:avLst/>
+          </a:prstGeom>
+          <a:noFill/>
+          <a:ln>
+            <a:noFill/>
+          </a:ln>
+        </p:spPr>
+        <p:txBody>
+          <a:bodyPr spcFirstLastPara="1" wrap="square" lIns="91425" tIns="45700" rIns="91425" bIns="45700" anchor="t" anchorCtr="0">
+            <a:spAutoFit/>
+          </a:bodyPr>
+          <a:lstStyle/>
+          <a:p>
+            <a:pPr marL="0" marR="0" lvl="0" indent="0" algn="l" rtl="0">
+              <a:lnSpc>
+                <a:spcPct val="100000"/>
+              </a:lnSpc>
+              <a:spcBef>
+                <a:spcPts val="0"/>
+              </a:spcBef>
+              <a:spcAft>
+                <a:spcPts val="0"/>
+              </a:spcAft>
+              <a:buNone/>
+            </a:pPr>
+            <a:r>
+              <a:rPr lang="en-US" sz="900" dirty="0">
+                <a:solidFill>
+                  <a:srgbClr val="13294B"/>
+                </a:solidFill>
+              </a:rPr>
+              <a:t>SYSTEMS ENGINEERING </a:t>
+            </a:r>
+            <a:endParaRPr dirty="0"/>
+          </a:p>
+        </p:txBody>
+      </p:sp>
+      <p:grpSp>
+        <p:nvGrpSpPr>
+          <p:cNvPr id="124" name="Google Shape;124;p29">
+            <a:extLst>
+              <a:ext uri="{FF2B5EF4-FFF2-40B4-BE49-F238E27FC236}">
+                <a16:creationId xmlns:a16="http://schemas.microsoft.com/office/drawing/2014/main" id="{73B542CF-2028-95AA-CCEF-91A8D02AD178}"/>
+              </a:ext>
+            </a:extLst>
+          </p:cNvPr>
+          <p:cNvGrpSpPr/>
+          <p:nvPr/>
+        </p:nvGrpSpPr>
+        <p:grpSpPr>
+          <a:xfrm>
+            <a:off x="4066674" y="6601537"/>
+            <a:ext cx="5233412" cy="70446"/>
+            <a:chOff x="4033424" y="6601537"/>
+            <a:chExt cx="5233412" cy="70446"/>
+          </a:xfrm>
+        </p:grpSpPr>
+        <p:cxnSp>
+          <p:nvCxnSpPr>
+            <p:cNvPr id="125" name="Google Shape;125;p29">
+              <a:extLst>
+                <a:ext uri="{FF2B5EF4-FFF2-40B4-BE49-F238E27FC236}">
+                  <a16:creationId xmlns:a16="http://schemas.microsoft.com/office/drawing/2014/main" id="{33141631-F3ED-2759-4D92-932A85BC40E3}"/>
+                </a:ext>
+              </a:extLst>
+            </p:cNvPr>
+            <p:cNvCxnSpPr/>
+            <p:nvPr/>
+          </p:nvCxnSpPr>
+          <p:spPr>
+            <a:xfrm rot="10800000">
+              <a:off x="4033424" y="6639606"/>
+              <a:ext cx="5164651" cy="0"/>
+            </a:xfrm>
+            <a:prstGeom prst="straightConnector1">
+              <a:avLst/>
+            </a:prstGeom>
+            <a:noFill/>
+            <a:ln w="9525" cap="flat" cmpd="sng">
+              <a:solidFill>
+                <a:srgbClr val="13294B"/>
+              </a:solidFill>
+              <a:prstDash val="solid"/>
+              <a:round/>
+              <a:headEnd type="none" w="sm" len="sm"/>
+              <a:tailEnd type="none" w="sm" len="sm"/>
+            </a:ln>
+          </p:spPr>
+        </p:cxnSp>
+        <p:sp>
+          <p:nvSpPr>
+            <p:cNvPr id="126" name="Google Shape;126;p29">
+              <a:extLst>
+                <a:ext uri="{FF2B5EF4-FFF2-40B4-BE49-F238E27FC236}">
+                  <a16:creationId xmlns:a16="http://schemas.microsoft.com/office/drawing/2014/main" id="{E4D9BF8E-CB10-CAD2-7648-4939A5B564E5}"/>
+                </a:ext>
+              </a:extLst>
+            </p:cNvPr>
+            <p:cNvSpPr/>
+            <p:nvPr/>
+          </p:nvSpPr>
+          <p:spPr>
+            <a:xfrm>
+              <a:off x="9196390" y="6601537"/>
+              <a:ext cx="70446" cy="70446"/>
+            </a:xfrm>
+            <a:prstGeom prst="ellipse">
+              <a:avLst/>
+            </a:prstGeom>
+            <a:solidFill>
+              <a:srgbClr val="13294B"/>
+            </a:solidFill>
+            <a:ln>
+              <a:noFill/>
+            </a:ln>
+          </p:spPr>
+          <p:txBody>
+            <a:bodyPr spcFirstLastPara="1" wrap="square" lIns="91425" tIns="45700" rIns="91425" bIns="45700" anchor="ctr" anchorCtr="0">
+              <a:noAutofit/>
+            </a:bodyPr>
+            <a:lstStyle/>
+            <a:p>
+              <a:pPr marL="0" marR="0" lvl="0" indent="0" algn="ctr" rtl="0">
+                <a:lnSpc>
+                  <a:spcPct val="100000"/>
+                </a:lnSpc>
+                <a:spcBef>
+                  <a:spcPts val="0"/>
+                </a:spcBef>
+                <a:spcAft>
+                  <a:spcPts val="0"/>
+                </a:spcAft>
+                <a:buNone/>
+              </a:pPr>
+              <a:endParaRPr sz="1400" b="0" i="0" u="none" strike="noStrike" cap="none">
+                <a:solidFill>
+                  <a:srgbClr val="13294B"/>
+                </a:solidFill>
+                <a:latin typeface="Arial"/>
+                <a:ea typeface="Arial"/>
+                <a:cs typeface="Arial"/>
+                <a:sym typeface="Arial"/>
+              </a:endParaRPr>
+            </a:p>
+          </p:txBody>
+        </p:sp>
+      </p:grpSp>
+    </p:spTree>
+    <p:extLst>
+      <p:ext uri="{BB962C8B-B14F-4D97-AF65-F5344CB8AC3E}">
+        <p14:creationId xmlns:p14="http://schemas.microsoft.com/office/powerpoint/2010/main" val="1702080834"/>
+      </p:ext>
+    </p:extLst>
+  </p:cSld>
+  <p:clrMapOvr>
+    <a:masterClrMapping/>
+  </p:clrMapOvr>
+</p:sld>
+</file>
+
+<file path=ppt/slides/slide20.xml><?xml version="1.0" encoding="utf-8"?>
 <p:sld xmlns:a="http://schemas.openxmlformats.org/drawingml/2006/main" xmlns:r="http://schemas.openxmlformats.org/officeDocument/2006/relationships" xmlns:p="http://schemas.openxmlformats.org/presentationml/2006/main">
   <p:cSld>
     <p:bg>
@@ -22473,583 +24084,7 @@
 </p:sld>
 </file>
 
-<file path=ppt/slides/slide2.xml><?xml version="1.0" encoding="utf-8"?>
-<p:sld xmlns:a="http://schemas.openxmlformats.org/drawingml/2006/main" xmlns:r="http://schemas.openxmlformats.org/officeDocument/2006/relationships" xmlns:p="http://schemas.openxmlformats.org/presentationml/2006/main">
-  <p:cSld>
-    <p:spTree>
-      <p:nvGrpSpPr>
-        <p:cNvPr id="1" name="Shape 117">
-          <a:extLst>
-            <a:ext uri="{FF2B5EF4-FFF2-40B4-BE49-F238E27FC236}">
-              <a16:creationId xmlns:a16="http://schemas.microsoft.com/office/drawing/2014/main" id="{B787707C-0AB4-57C3-5639-B4BEF4389386}"/>
-            </a:ext>
-          </a:extLst>
-        </p:cNvPr>
-        <p:cNvGrpSpPr/>
-        <p:nvPr/>
-      </p:nvGrpSpPr>
-      <p:grpSpPr>
-        <a:xfrm>
-          <a:off x="0" y="0"/>
-          <a:ext cx="0" cy="0"/>
-          <a:chOff x="0" y="0"/>
-          <a:chExt cx="0" cy="0"/>
-        </a:xfrm>
-      </p:grpSpPr>
-      <p:sp>
-        <p:nvSpPr>
-          <p:cNvPr id="118" name="Google Shape;118;p29">
-            <a:extLst>
-              <a:ext uri="{FF2B5EF4-FFF2-40B4-BE49-F238E27FC236}">
-                <a16:creationId xmlns:a16="http://schemas.microsoft.com/office/drawing/2014/main" id="{E7EA1A55-2BAC-C6A5-ABC3-168138F62B6C}"/>
-              </a:ext>
-            </a:extLst>
-          </p:cNvPr>
-          <p:cNvSpPr txBox="1">
-            <a:spLocks noGrp="1"/>
-          </p:cNvSpPr>
-          <p:nvPr>
-            <p:ph type="body" idx="1"/>
-          </p:nvPr>
-        </p:nvSpPr>
-        <p:spPr>
-          <a:xfrm>
-            <a:off x="376809" y="1334279"/>
-            <a:ext cx="11177401" cy="4821102"/>
-          </a:xfrm>
-          <a:prstGeom prst="rect">
-            <a:avLst/>
-          </a:prstGeom>
-          <a:noFill/>
-          <a:ln>
-            <a:noFill/>
-          </a:ln>
-        </p:spPr>
-        <p:txBody>
-          <a:bodyPr spcFirstLastPara="1" wrap="square" lIns="91425" tIns="45700" rIns="91425" bIns="45700" anchor="t" anchorCtr="0">
-            <a:noAutofit/>
-          </a:bodyPr>
-          <a:lstStyle/>
-          <a:p>
-            <a:pPr marL="0" indent="0">
-              <a:lnSpc>
-                <a:spcPct val="100000"/>
-              </a:lnSpc>
-              <a:spcBef>
-                <a:spcPts val="0"/>
-              </a:spcBef>
-              <a:buSzPts val="3000"/>
-              <a:buNone/>
-            </a:pPr>
-            <a:r>
-              <a:rPr lang="en-US" sz="2400" dirty="0">
-                <a:solidFill>
-                  <a:schemeClr val="dk1"/>
-                </a:solidFill>
-                <a:latin typeface="Arial"/>
-                <a:ea typeface="Arial"/>
-                <a:cs typeface="Arial"/>
-                <a:sym typeface="Arial"/>
-              </a:rPr>
-              <a:t>Talk to the person next to you and answer these questions.</a:t>
-            </a:r>
-          </a:p>
-          <a:p>
-            <a:pPr marL="285750" indent="-285750">
-              <a:lnSpc>
-                <a:spcPct val="100000"/>
-              </a:lnSpc>
-              <a:spcBef>
-                <a:spcPts val="0"/>
-              </a:spcBef>
-              <a:buSzPts val="3000"/>
-            </a:pPr>
-            <a:endParaRPr lang="en-US" sz="2400" dirty="0">
-              <a:latin typeface="Arial"/>
-              <a:ea typeface="Arial"/>
-              <a:cs typeface="Arial"/>
-              <a:sym typeface="Arial"/>
-            </a:endParaRPr>
-          </a:p>
-          <a:p>
-            <a:pPr marL="285750" indent="-285750">
-              <a:lnSpc>
-                <a:spcPct val="100000"/>
-              </a:lnSpc>
-              <a:spcBef>
-                <a:spcPts val="0"/>
-              </a:spcBef>
-              <a:buSzPts val="3000"/>
-            </a:pPr>
-            <a:r>
-              <a:rPr lang="en-US" sz="2400" dirty="0">
-                <a:solidFill>
-                  <a:schemeClr val="dk1"/>
-                </a:solidFill>
-                <a:latin typeface="Arial"/>
-                <a:ea typeface="Arial"/>
-                <a:cs typeface="Arial"/>
-                <a:sym typeface="Arial"/>
-              </a:rPr>
-              <a:t>Question 1</a:t>
-            </a:r>
-          </a:p>
-          <a:p>
-            <a:pPr marL="285750" indent="-285750">
-              <a:lnSpc>
-                <a:spcPct val="100000"/>
-              </a:lnSpc>
-              <a:spcBef>
-                <a:spcPts val="0"/>
-              </a:spcBef>
-              <a:buSzPts val="3000"/>
-            </a:pPr>
-            <a:r>
-              <a:rPr lang="en-US" sz="2400" dirty="0">
-                <a:latin typeface="Arial"/>
-                <a:ea typeface="Arial"/>
-                <a:cs typeface="Arial"/>
-                <a:sym typeface="Arial"/>
-              </a:rPr>
-              <a:t>Question 2</a:t>
-            </a:r>
-            <a:endParaRPr lang="en-US" sz="2400" dirty="0">
-              <a:solidFill>
-                <a:schemeClr val="dk1"/>
-              </a:solidFill>
-              <a:latin typeface="Arial"/>
-              <a:ea typeface="Arial"/>
-              <a:cs typeface="Arial"/>
-              <a:sym typeface="Arial"/>
-            </a:endParaRPr>
-          </a:p>
-          <a:p>
-            <a:pPr marL="285750" indent="-285750">
-              <a:lnSpc>
-                <a:spcPct val="100000"/>
-              </a:lnSpc>
-              <a:spcBef>
-                <a:spcPts val="0"/>
-              </a:spcBef>
-              <a:buSzPts val="3000"/>
-            </a:pPr>
-            <a:endParaRPr sz="2400" dirty="0">
-              <a:solidFill>
-                <a:schemeClr val="dk1"/>
-              </a:solidFill>
-              <a:latin typeface="Arial"/>
-              <a:ea typeface="Arial"/>
-              <a:cs typeface="Arial"/>
-              <a:sym typeface="Arial"/>
-            </a:endParaRPr>
-          </a:p>
-        </p:txBody>
-      </p:sp>
-      <p:sp>
-        <p:nvSpPr>
-          <p:cNvPr id="119" name="Google Shape;119;p29">
-            <a:extLst>
-              <a:ext uri="{FF2B5EF4-FFF2-40B4-BE49-F238E27FC236}">
-                <a16:creationId xmlns:a16="http://schemas.microsoft.com/office/drawing/2014/main" id="{AADDCC56-907C-FD39-6E34-87042D08FA2E}"/>
-              </a:ext>
-            </a:extLst>
-          </p:cNvPr>
-          <p:cNvSpPr/>
-          <p:nvPr/>
-        </p:nvSpPr>
-        <p:spPr>
-          <a:xfrm rot="10800000" flipH="1">
-            <a:off x="0" y="0"/>
-            <a:ext cx="12192000" cy="868220"/>
-          </a:xfrm>
-          <a:prstGeom prst="rect">
-            <a:avLst/>
-          </a:prstGeom>
-          <a:solidFill>
-            <a:srgbClr val="13294B"/>
-          </a:solidFill>
-          <a:ln>
-            <a:noFill/>
-          </a:ln>
-        </p:spPr>
-        <p:txBody>
-          <a:bodyPr spcFirstLastPara="1" wrap="square" lIns="91425" tIns="45700" rIns="91425" bIns="45700" anchor="ctr" anchorCtr="0">
-            <a:noAutofit/>
-          </a:bodyPr>
-          <a:lstStyle/>
-          <a:p>
-            <a:pPr marL="0" marR="0" lvl="0" indent="0" algn="ctr" rtl="0">
-              <a:lnSpc>
-                <a:spcPct val="100000"/>
-              </a:lnSpc>
-              <a:spcBef>
-                <a:spcPts val="0"/>
-              </a:spcBef>
-              <a:spcAft>
-                <a:spcPts val="0"/>
-              </a:spcAft>
-              <a:buClr>
-                <a:schemeClr val="lt1"/>
-              </a:buClr>
-              <a:buSzPts val="1800"/>
-              <a:buFont typeface="Calibri"/>
-              <a:buNone/>
-            </a:pPr>
-            <a:endParaRPr sz="1800" b="0" i="0" u="none" strike="noStrike" cap="none">
-              <a:solidFill>
-                <a:srgbClr val="13294B"/>
-              </a:solidFill>
-              <a:latin typeface="Calibri"/>
-              <a:ea typeface="Calibri"/>
-              <a:cs typeface="Calibri"/>
-              <a:sym typeface="Calibri"/>
-            </a:endParaRPr>
-          </a:p>
-        </p:txBody>
-      </p:sp>
-      <p:sp>
-        <p:nvSpPr>
-          <p:cNvPr id="120" name="Google Shape;120;p29">
-            <a:extLst>
-              <a:ext uri="{FF2B5EF4-FFF2-40B4-BE49-F238E27FC236}">
-                <a16:creationId xmlns:a16="http://schemas.microsoft.com/office/drawing/2014/main" id="{C941C760-8B23-A46D-5C4A-981290CB9EBC}"/>
-              </a:ext>
-            </a:extLst>
-          </p:cNvPr>
-          <p:cNvSpPr txBox="1"/>
-          <p:nvPr/>
-        </p:nvSpPr>
-        <p:spPr>
-          <a:xfrm>
-            <a:off x="376810" y="204051"/>
-            <a:ext cx="10910026" cy="461624"/>
-          </a:xfrm>
-          <a:prstGeom prst="rect">
-            <a:avLst/>
-          </a:prstGeom>
-          <a:noFill/>
-          <a:ln>
-            <a:noFill/>
-          </a:ln>
-        </p:spPr>
-        <p:txBody>
-          <a:bodyPr spcFirstLastPara="1" wrap="square" lIns="91425" tIns="45700" rIns="91425" bIns="45700" anchor="t" anchorCtr="0">
-            <a:spAutoFit/>
-          </a:bodyPr>
-          <a:lstStyle/>
-          <a:p>
-            <a:pPr marL="0" marR="0" lvl="0" indent="0" algn="l" rtl="0">
-              <a:lnSpc>
-                <a:spcPct val="100000"/>
-              </a:lnSpc>
-              <a:spcBef>
-                <a:spcPts val="0"/>
-              </a:spcBef>
-              <a:spcAft>
-                <a:spcPts val="0"/>
-              </a:spcAft>
-              <a:buClr>
-                <a:srgbClr val="000000"/>
-              </a:buClr>
-              <a:buSzPts val="2400"/>
-              <a:buFont typeface="Arial"/>
-              <a:buNone/>
-            </a:pPr>
-            <a:r>
-              <a:rPr lang="en-US" sz="2400" b="0" i="0" u="none" strike="noStrike" cap="none" dirty="0">
-                <a:solidFill>
-                  <a:schemeClr val="lt1"/>
-                </a:solidFill>
-                <a:latin typeface="Arial"/>
-                <a:ea typeface="Arial"/>
-                <a:cs typeface="Arial"/>
-                <a:sym typeface="Arial"/>
-              </a:rPr>
-              <a:t>Review – 5-minute partner discussion</a:t>
-            </a:r>
-            <a:endParaRPr sz="2400" b="0" i="0" u="none" strike="noStrike" cap="none" dirty="0">
-              <a:solidFill>
-                <a:schemeClr val="lt1"/>
-              </a:solidFill>
-              <a:latin typeface="Arial"/>
-              <a:ea typeface="Arial"/>
-              <a:cs typeface="Arial"/>
-              <a:sym typeface="Arial"/>
-            </a:endParaRPr>
-          </a:p>
-        </p:txBody>
-      </p:sp>
-      <p:pic>
-        <p:nvPicPr>
-          <p:cNvPr id="121" name="Google Shape;121;p29">
-            <a:extLst>
-              <a:ext uri="{FF2B5EF4-FFF2-40B4-BE49-F238E27FC236}">
-                <a16:creationId xmlns:a16="http://schemas.microsoft.com/office/drawing/2014/main" id="{C1984774-B7FA-53FC-ECBE-3FFBD377F556}"/>
-              </a:ext>
-            </a:extLst>
-          </p:cNvPr>
-          <p:cNvPicPr preferRelativeResize="0"/>
-          <p:nvPr/>
-        </p:nvPicPr>
-        <p:blipFill rotWithShape="1">
-          <a:blip r:embed="rId3">
-            <a:alphaModFix/>
-          </a:blip>
-          <a:srcRect/>
-          <a:stretch/>
-        </p:blipFill>
-        <p:spPr>
-          <a:xfrm>
-            <a:off x="11557509" y="233819"/>
-            <a:ext cx="271308" cy="389810"/>
-          </a:xfrm>
-          <a:prstGeom prst="rect">
-            <a:avLst/>
-          </a:prstGeom>
-          <a:noFill/>
-          <a:ln>
-            <a:noFill/>
-          </a:ln>
-        </p:spPr>
-      </p:pic>
-      <p:sp>
-        <p:nvSpPr>
-          <p:cNvPr id="122" name="Google Shape;122;p29">
-            <a:extLst>
-              <a:ext uri="{FF2B5EF4-FFF2-40B4-BE49-F238E27FC236}">
-                <a16:creationId xmlns:a16="http://schemas.microsoft.com/office/drawing/2014/main" id="{D52648EA-0120-942E-FA7D-98B9C25F4F34}"/>
-              </a:ext>
-            </a:extLst>
-          </p:cNvPr>
-          <p:cNvSpPr txBox="1"/>
-          <p:nvPr/>
-        </p:nvSpPr>
-        <p:spPr>
-          <a:xfrm>
-            <a:off x="9335597" y="6524381"/>
-            <a:ext cx="2473415" cy="230792"/>
-          </a:xfrm>
-          <a:prstGeom prst="rect">
-            <a:avLst/>
-          </a:prstGeom>
-          <a:noFill/>
-          <a:ln>
-            <a:noFill/>
-          </a:ln>
-        </p:spPr>
-        <p:txBody>
-          <a:bodyPr spcFirstLastPara="1" wrap="square" lIns="91425" tIns="45700" rIns="91425" bIns="45700" anchor="t" anchorCtr="0">
-            <a:spAutoFit/>
-          </a:bodyPr>
-          <a:lstStyle/>
-          <a:p>
-            <a:pPr marL="0" marR="0" lvl="0" indent="0" algn="r" rtl="0">
-              <a:lnSpc>
-                <a:spcPct val="100000"/>
-              </a:lnSpc>
-              <a:spcBef>
-                <a:spcPts val="0"/>
-              </a:spcBef>
-              <a:spcAft>
-                <a:spcPts val="0"/>
-              </a:spcAft>
-              <a:buNone/>
-            </a:pPr>
-            <a:r>
-              <a:rPr lang="en-US" sz="900" b="0" i="0" u="none" strike="noStrike" cap="none">
-                <a:solidFill>
-                  <a:srgbClr val="13294B"/>
-                </a:solidFill>
-                <a:latin typeface="Arial"/>
-                <a:ea typeface="Arial"/>
-                <a:cs typeface="Arial"/>
-                <a:sym typeface="Arial"/>
-              </a:rPr>
-              <a:t>GRAINGER ENGINEERING</a:t>
-            </a:r>
-            <a:endParaRPr/>
-          </a:p>
-        </p:txBody>
-      </p:sp>
-      <p:sp>
-        <p:nvSpPr>
-          <p:cNvPr id="123" name="Google Shape;123;p29">
-            <a:extLst>
-              <a:ext uri="{FF2B5EF4-FFF2-40B4-BE49-F238E27FC236}">
-                <a16:creationId xmlns:a16="http://schemas.microsoft.com/office/drawing/2014/main" id="{9187DBB9-03BE-10E2-9B63-400A9675CEAD}"/>
-              </a:ext>
-            </a:extLst>
-          </p:cNvPr>
-          <p:cNvSpPr txBox="1"/>
-          <p:nvPr/>
-        </p:nvSpPr>
-        <p:spPr>
-          <a:xfrm>
-            <a:off x="376807" y="6524381"/>
-            <a:ext cx="7991337" cy="230792"/>
-          </a:xfrm>
-          <a:prstGeom prst="rect">
-            <a:avLst/>
-          </a:prstGeom>
-          <a:noFill/>
-          <a:ln>
-            <a:noFill/>
-          </a:ln>
-        </p:spPr>
-        <p:txBody>
-          <a:bodyPr spcFirstLastPara="1" wrap="square" lIns="91425" tIns="45700" rIns="91425" bIns="45700" anchor="t" anchorCtr="0">
-            <a:spAutoFit/>
-          </a:bodyPr>
-          <a:lstStyle/>
-          <a:p>
-            <a:pPr marL="0" marR="0" lvl="0" indent="0" algn="l" rtl="0">
-              <a:lnSpc>
-                <a:spcPct val="100000"/>
-              </a:lnSpc>
-              <a:spcBef>
-                <a:spcPts val="0"/>
-              </a:spcBef>
-              <a:spcAft>
-                <a:spcPts val="0"/>
-              </a:spcAft>
-              <a:buNone/>
-            </a:pPr>
-            <a:r>
-              <a:rPr lang="en-US" sz="900" dirty="0">
-                <a:solidFill>
-                  <a:srgbClr val="13294B"/>
-                </a:solidFill>
-              </a:rPr>
-              <a:t>SYSTEMS ENGINEERING </a:t>
-            </a:r>
-            <a:endParaRPr dirty="0"/>
-          </a:p>
-        </p:txBody>
-      </p:sp>
-      <p:grpSp>
-        <p:nvGrpSpPr>
-          <p:cNvPr id="124" name="Google Shape;124;p29">
-            <a:extLst>
-              <a:ext uri="{FF2B5EF4-FFF2-40B4-BE49-F238E27FC236}">
-                <a16:creationId xmlns:a16="http://schemas.microsoft.com/office/drawing/2014/main" id="{73B542CF-2028-95AA-CCEF-91A8D02AD178}"/>
-              </a:ext>
-            </a:extLst>
-          </p:cNvPr>
-          <p:cNvGrpSpPr/>
-          <p:nvPr/>
-        </p:nvGrpSpPr>
-        <p:grpSpPr>
-          <a:xfrm>
-            <a:off x="4066674" y="6601537"/>
-            <a:ext cx="5233412" cy="70446"/>
-            <a:chOff x="4033424" y="6601537"/>
-            <a:chExt cx="5233412" cy="70446"/>
-          </a:xfrm>
-        </p:grpSpPr>
-        <p:cxnSp>
-          <p:nvCxnSpPr>
-            <p:cNvPr id="125" name="Google Shape;125;p29">
-              <a:extLst>
-                <a:ext uri="{FF2B5EF4-FFF2-40B4-BE49-F238E27FC236}">
-                  <a16:creationId xmlns:a16="http://schemas.microsoft.com/office/drawing/2014/main" id="{33141631-F3ED-2759-4D92-932A85BC40E3}"/>
-                </a:ext>
-              </a:extLst>
-            </p:cNvPr>
-            <p:cNvCxnSpPr/>
-            <p:nvPr/>
-          </p:nvCxnSpPr>
-          <p:spPr>
-            <a:xfrm rot="10800000">
-              <a:off x="4033424" y="6639606"/>
-              <a:ext cx="5164651" cy="0"/>
-            </a:xfrm>
-            <a:prstGeom prst="straightConnector1">
-              <a:avLst/>
-            </a:prstGeom>
-            <a:noFill/>
-            <a:ln w="9525" cap="flat" cmpd="sng">
-              <a:solidFill>
-                <a:srgbClr val="13294B"/>
-              </a:solidFill>
-              <a:prstDash val="solid"/>
-              <a:round/>
-              <a:headEnd type="none" w="sm" len="sm"/>
-              <a:tailEnd type="none" w="sm" len="sm"/>
-            </a:ln>
-          </p:spPr>
-        </p:cxnSp>
-        <p:sp>
-          <p:nvSpPr>
-            <p:cNvPr id="126" name="Google Shape;126;p29">
-              <a:extLst>
-                <a:ext uri="{FF2B5EF4-FFF2-40B4-BE49-F238E27FC236}">
-                  <a16:creationId xmlns:a16="http://schemas.microsoft.com/office/drawing/2014/main" id="{E4D9BF8E-CB10-CAD2-7648-4939A5B564E5}"/>
-                </a:ext>
-              </a:extLst>
-            </p:cNvPr>
-            <p:cNvSpPr/>
-            <p:nvPr/>
-          </p:nvSpPr>
-          <p:spPr>
-            <a:xfrm>
-              <a:off x="9196390" y="6601537"/>
-              <a:ext cx="70446" cy="70446"/>
-            </a:xfrm>
-            <a:prstGeom prst="ellipse">
-              <a:avLst/>
-            </a:prstGeom>
-            <a:solidFill>
-              <a:srgbClr val="13294B"/>
-            </a:solidFill>
-            <a:ln>
-              <a:noFill/>
-            </a:ln>
-          </p:spPr>
-          <p:txBody>
-            <a:bodyPr spcFirstLastPara="1" wrap="square" lIns="91425" tIns="45700" rIns="91425" bIns="45700" anchor="ctr" anchorCtr="0">
-              <a:noAutofit/>
-            </a:bodyPr>
-            <a:lstStyle/>
-            <a:p>
-              <a:pPr marL="0" marR="0" lvl="0" indent="0" algn="ctr" rtl="0">
-                <a:lnSpc>
-                  <a:spcPct val="100000"/>
-                </a:lnSpc>
-                <a:spcBef>
-                  <a:spcPts val="0"/>
-                </a:spcBef>
-                <a:spcAft>
-                  <a:spcPts val="0"/>
-                </a:spcAft>
-                <a:buNone/>
-              </a:pPr>
-              <a:endParaRPr sz="1400" b="0" i="0" u="none" strike="noStrike" cap="none">
-                <a:solidFill>
-                  <a:srgbClr val="13294B"/>
-                </a:solidFill>
-                <a:latin typeface="Arial"/>
-                <a:ea typeface="Arial"/>
-                <a:cs typeface="Arial"/>
-                <a:sym typeface="Arial"/>
-              </a:endParaRPr>
-            </a:p>
-          </p:txBody>
-        </p:sp>
-      </p:grpSp>
-    </p:spTree>
-    <p:extLst>
-      <p:ext uri="{BB962C8B-B14F-4D97-AF65-F5344CB8AC3E}">
-        <p14:creationId xmlns:p14="http://schemas.microsoft.com/office/powerpoint/2010/main" val="1702080834"/>
-      </p:ext>
-    </p:extLst>
-  </p:cSld>
-  <p:clrMapOvr>
-    <a:masterClrMapping/>
-  </p:clrMapOvr>
-</p:sld>
-</file>
-
-<file path=ppt/slides/slide20.xml><?xml version="1.0" encoding="utf-8"?>
+<file path=ppt/slides/slide21.xml><?xml version="1.0" encoding="utf-8"?>
 <p:sld xmlns:a="http://schemas.openxmlformats.org/drawingml/2006/main" xmlns:r="http://schemas.openxmlformats.org/officeDocument/2006/relationships" xmlns:p="http://schemas.openxmlformats.org/presentationml/2006/main">
   <p:cSld>
     <p:bg>
@@ -23469,17 +24504,31 @@
                 <a:cs typeface="Arial"/>
                 <a:sym typeface="Arial"/>
               </a:rPr>
-              <a:t>Starting Lab X this week. This a X-week lab!</a:t>
+              <a:t>Starting Lab 6 this week. This a 3-week lab!</a:t>
             </a:r>
-            <a:endParaRPr lang="en-US" sz="1800" dirty="0">
-              <a:solidFill>
-                <a:srgbClr val="E84B36"/>
-              </a:solidFill>
-              <a:latin typeface="Arial"/>
-              <a:ea typeface="Arial"/>
-              <a:cs typeface="Arial"/>
-              <a:sym typeface="Arial"/>
-            </a:endParaRPr>
+          </a:p>
+          <a:p>
+            <a:pPr marL="285750" indent="-285750">
+              <a:lnSpc>
+                <a:spcPct val="100000"/>
+              </a:lnSpc>
+              <a:spcBef>
+                <a:spcPts val="0"/>
+              </a:spcBef>
+              <a:buSzPts val="3000"/>
+            </a:pPr>
+            <a:r>
+              <a:rPr lang="en-US" sz="1800" dirty="0">
+                <a:solidFill>
+                  <a:schemeClr val="tx1"/>
+                </a:solidFill>
+                <a:latin typeface="Arial"/>
+                <a:ea typeface="Arial"/>
+                <a:cs typeface="Arial"/>
+                <a:sym typeface="Arial"/>
+              </a:rPr>
+              <a:t>Don’t forget to have the Lab LabVIEW application implemented before lab.</a:t>
+            </a:r>
           </a:p>
           <a:p>
             <a:pPr marL="0" indent="0">
@@ -23555,14 +24604,156 @@
                 <a:cs typeface="Arial"/>
                 <a:sym typeface="Arial"/>
               </a:rPr>
-              <a:t>Check-offs for …</a:t>
+              <a:t>Check-offs for </a:t>
             </a:r>
-            <a:endParaRPr lang="en-US" sz="1800" b="1" dirty="0">
+            <a:r>
+              <a:rPr lang="en-US" sz="1800" dirty="0">
+                <a:latin typeface="Arial"/>
+                <a:ea typeface="Arial"/>
+                <a:cs typeface="Arial"/>
+                <a:sym typeface="Arial"/>
+                <a:hlinkClick r:id="rId3"/>
+              </a:rPr>
+              <a:t>homework 4</a:t>
+            </a:r>
+            <a:r>
+              <a:rPr lang="en-US" sz="1800" dirty="0">
+                <a:latin typeface="Arial"/>
+                <a:ea typeface="Arial"/>
+                <a:cs typeface="Arial"/>
+                <a:sym typeface="Arial"/>
+              </a:rPr>
+              <a:t> Ex 2 and 3 are due </a:t>
+            </a:r>
+            <a:r>
+              <a:rPr lang="en-US" sz="1800" b="1" dirty="0">
+                <a:latin typeface="Arial"/>
+                <a:ea typeface="Arial"/>
+                <a:cs typeface="Arial"/>
+                <a:sym typeface="Arial"/>
+              </a:rPr>
+              <a:t>March 31, 5PM (The end of office hours)</a:t>
+            </a:r>
+            <a:endParaRPr lang="en-US" sz="1800" dirty="0">
               <a:latin typeface="Arial"/>
               <a:ea typeface="Arial"/>
               <a:cs typeface="Arial"/>
               <a:sym typeface="Arial"/>
             </a:endParaRPr>
+          </a:p>
+          <a:p>
+            <a:pPr marL="285750" indent="-285750">
+              <a:lnSpc>
+                <a:spcPct val="100000"/>
+              </a:lnSpc>
+              <a:spcBef>
+                <a:spcPts val="0"/>
+              </a:spcBef>
+              <a:buSzPts val="3000"/>
+            </a:pPr>
+            <a:r>
+              <a:rPr lang="en-US" sz="1800" dirty="0">
+                <a:latin typeface="Arial"/>
+                <a:ea typeface="Arial"/>
+                <a:cs typeface="Arial"/>
+                <a:sym typeface="Arial"/>
+              </a:rPr>
+              <a:t>Check-offs for </a:t>
+            </a:r>
+            <a:r>
+              <a:rPr lang="en-US" sz="1800" dirty="0">
+                <a:latin typeface="Arial"/>
+                <a:ea typeface="Arial"/>
+                <a:cs typeface="Arial"/>
+                <a:sym typeface="Arial"/>
+                <a:hlinkClick r:id="rId3"/>
+              </a:rPr>
+              <a:t>homework 4</a:t>
+            </a:r>
+            <a:r>
+              <a:rPr lang="en-US" sz="1800" dirty="0">
+                <a:latin typeface="Arial"/>
+                <a:ea typeface="Arial"/>
+                <a:cs typeface="Arial"/>
+                <a:sym typeface="Arial"/>
+              </a:rPr>
+              <a:t> Ex 4 are due </a:t>
+            </a:r>
+            <a:r>
+              <a:rPr lang="en-US" sz="1800" b="1" dirty="0">
+                <a:latin typeface="Arial"/>
+                <a:ea typeface="Arial"/>
+                <a:cs typeface="Arial"/>
+                <a:sym typeface="Arial"/>
+              </a:rPr>
+              <a:t>April 7, 5PM (The end of office hours)</a:t>
+            </a:r>
+          </a:p>
+          <a:p>
+            <a:pPr marL="285750" indent="-285750">
+              <a:lnSpc>
+                <a:spcPct val="100000"/>
+              </a:lnSpc>
+              <a:spcBef>
+                <a:spcPts val="0"/>
+              </a:spcBef>
+              <a:buSzPts val="3000"/>
+            </a:pPr>
+            <a:r>
+              <a:rPr lang="en-US" sz="1800" dirty="0">
+                <a:latin typeface="Arial"/>
+                <a:ea typeface="Arial"/>
+                <a:cs typeface="Arial"/>
+                <a:sym typeface="Arial"/>
+              </a:rPr>
+              <a:t>Remainder of </a:t>
+            </a:r>
+            <a:r>
+              <a:rPr lang="en-US" sz="1800" dirty="0">
+                <a:latin typeface="Arial"/>
+                <a:ea typeface="Arial"/>
+                <a:cs typeface="Arial"/>
+                <a:sym typeface="Arial"/>
+                <a:hlinkClick r:id="rId3"/>
+              </a:rPr>
+              <a:t>homework 4</a:t>
+            </a:r>
+            <a:r>
+              <a:rPr lang="en-US" sz="1800" dirty="0">
+                <a:latin typeface="Arial"/>
+                <a:ea typeface="Arial"/>
+                <a:cs typeface="Arial"/>
+                <a:sym typeface="Arial"/>
+              </a:rPr>
+              <a:t> due on </a:t>
+            </a:r>
+            <a:r>
+              <a:rPr lang="en-US" sz="1800" dirty="0" err="1">
+                <a:latin typeface="Arial"/>
+                <a:ea typeface="Arial"/>
+                <a:cs typeface="Arial"/>
+                <a:sym typeface="Arial"/>
+              </a:rPr>
+              <a:t>Gradescope</a:t>
+            </a:r>
+            <a:r>
+              <a:rPr lang="en-US" sz="1800" dirty="0">
+                <a:latin typeface="Arial"/>
+                <a:ea typeface="Arial"/>
+                <a:cs typeface="Arial"/>
+                <a:sym typeface="Arial"/>
+              </a:rPr>
+              <a:t> on </a:t>
+            </a:r>
+            <a:r>
+              <a:rPr lang="en-US" sz="1800" b="1" dirty="0">
+                <a:latin typeface="Arial"/>
+                <a:ea typeface="Arial"/>
+                <a:cs typeface="Arial"/>
+                <a:sym typeface="Arial"/>
+              </a:rPr>
+              <a:t>April 8, 9AM</a:t>
+            </a:r>
           </a:p>
         </p:txBody>
       </p:sp>
@@ -23713,7 +24904,7 @@
           <p:nvPr/>
         </p:nvPicPr>
         <p:blipFill rotWithShape="1">
-          <a:blip r:embed="rId3">
+          <a:blip r:embed="rId4">
             <a:alphaModFix/>
           </a:blip>
           <a:srcRect/>
@@ -24543,8 +25734,8 @@
         </p:nvSpPr>
         <p:spPr>
           <a:xfrm>
-            <a:off x="1295400" y="2948490"/>
-            <a:ext cx="9601200" cy="1338788"/>
+            <a:off x="1295400" y="3225489"/>
+            <a:ext cx="9601200" cy="784790"/>
           </a:xfrm>
           <a:prstGeom prst="rect">
             <a:avLst/>
@@ -24578,7 +25769,7 @@
               <a:buNone/>
             </a:pPr>
             <a:r>
-              <a:rPr lang="en-US" sz="4500" b="1" i="0" u="none" strike="noStrike" cap="none">
+              <a:rPr lang="en-US" sz="4500" b="1" i="0" u="none" strike="noStrike" cap="none" dirty="0">
                 <a:solidFill>
                   <a:srgbClr val="15264B"/>
                 </a:solidFill>
@@ -24587,64 +25778,9 @@
                 <a:cs typeface="Arial"/>
                 <a:sym typeface="Arial"/>
               </a:rPr>
-              <a:t>Heading</a:t>
+              <a:t>Path planning</a:t>
             </a:r>
-            <a:endParaRPr/>
-          </a:p>
-          <a:p>
-            <a:pPr marL="0" marR="0" lvl="0" indent="0" algn="ctr" rtl="0">
-              <a:lnSpc>
-                <a:spcPct val="100000"/>
-              </a:lnSpc>
-              <a:spcBef>
-                <a:spcPts val="0"/>
-              </a:spcBef>
-              <a:spcAft>
-                <a:spcPts val="0"/>
-              </a:spcAft>
-              <a:buClr>
-                <a:srgbClr val="000000"/>
-              </a:buClr>
-              <a:buSzPts val="1800"/>
-              <a:buFont typeface="Arial"/>
-              <a:buNone/>
-            </a:pPr>
-            <a:endParaRPr sz="1800" b="1" i="0" u="none" strike="noStrike" cap="none">
-              <a:solidFill>
-                <a:srgbClr val="15264B"/>
-              </a:solidFill>
-              <a:latin typeface="Arial"/>
-              <a:ea typeface="Arial"/>
-              <a:cs typeface="Arial"/>
-              <a:sym typeface="Arial"/>
-            </a:endParaRPr>
-          </a:p>
-          <a:p>
-            <a:pPr marL="0" marR="0" lvl="0" indent="0" algn="ctr" rtl="0">
-              <a:lnSpc>
-                <a:spcPct val="100000"/>
-              </a:lnSpc>
-              <a:spcBef>
-                <a:spcPts val="0"/>
-              </a:spcBef>
-              <a:spcAft>
-                <a:spcPts val="0"/>
-              </a:spcAft>
-              <a:buNone/>
-            </a:pPr>
-            <a:r>
-              <a:rPr lang="en-US" sz="1800" b="0" i="0" u="none" strike="noStrike" cap="none">
-                <a:solidFill>
-                  <a:srgbClr val="15264B"/>
-                </a:solidFill>
-                <a:latin typeface="Arial"/>
-                <a:ea typeface="Arial"/>
-                <a:cs typeface="Arial"/>
-                <a:sym typeface="Arial"/>
-              </a:rPr>
-              <a:t>(Main section divider slide option two, or transition slide.)</a:t>
-            </a:r>
-            <a:endParaRPr sz="1800" b="0" i="0" u="none" strike="noStrike" cap="none">
+            <a:endParaRPr sz="1800" b="0" i="0" u="none" strike="noStrike" cap="none" dirty="0">
               <a:solidFill>
                 <a:srgbClr val="15264B"/>
               </a:solidFill>
@@ -25021,13 +26157,94 @@
               <a:buNone/>
             </a:pPr>
             <a:r>
-              <a:rPr lang="en-US" sz="2400">
+              <a:rPr lang="en-US" sz="2400" dirty="0">
                 <a:latin typeface="Arial"/>
                 <a:ea typeface="Arial"/>
                 <a:cs typeface="Arial"/>
                 <a:sym typeface="Arial"/>
               </a:rPr>
-              <a:t>Empt</a:t>
+              <a:t>I would HIGHLY recommend you looking at:</a:t>
+            </a:r>
+          </a:p>
+          <a:p>
+            <a:pPr marL="0" indent="0">
+              <a:lnSpc>
+                <a:spcPct val="100000"/>
+              </a:lnSpc>
+              <a:spcBef>
+                <a:spcPts val="0"/>
+              </a:spcBef>
+              <a:buSzPts val="3000"/>
+              <a:buNone/>
+            </a:pPr>
+            <a:endParaRPr lang="en-US" sz="2400" dirty="0">
+              <a:solidFill>
+                <a:schemeClr val="dk1"/>
+              </a:solidFill>
+              <a:latin typeface="Arial"/>
+              <a:ea typeface="Arial"/>
+              <a:cs typeface="Arial"/>
+              <a:sym typeface="Arial"/>
+            </a:endParaRPr>
+          </a:p>
+          <a:p>
+            <a:pPr marL="342900">
+              <a:lnSpc>
+                <a:spcPct val="100000"/>
+              </a:lnSpc>
+              <a:spcBef>
+                <a:spcPts val="0"/>
+              </a:spcBef>
+              <a:buSzPts val="3000"/>
+            </a:pPr>
+            <a:r>
+              <a:rPr lang="en-US" sz="2350" dirty="0">
+                <a:latin typeface="Arial"/>
+                <a:ea typeface="Arial"/>
+                <a:cs typeface="Arial"/>
+                <a:sym typeface="Arial"/>
+                <a:hlinkClick r:id="rId3"/>
+              </a:rPr>
+              <a:t>https://theory.stanford.edu/~amitp/GameProgramming/MapRepresentations.html</a:t>
+            </a:r>
+            <a:r>
+              <a:rPr lang="en-US" sz="2350" dirty="0">
+                <a:latin typeface="Arial"/>
+                <a:ea typeface="Arial"/>
+                <a:cs typeface="Arial"/>
+                <a:sym typeface="Arial"/>
+              </a:rPr>
+              <a:t> </a:t>
+            </a:r>
+            <a:endParaRPr lang="en-US" sz="2350" dirty="0">
+              <a:solidFill>
+                <a:schemeClr val="dk1"/>
+              </a:solidFill>
+              <a:latin typeface="Arial"/>
+              <a:ea typeface="Arial"/>
+              <a:cs typeface="Arial"/>
+              <a:sym typeface="Arial"/>
+            </a:endParaRPr>
+          </a:p>
+          <a:p>
+            <a:pPr marL="342900">
+              <a:lnSpc>
+                <a:spcPct val="100000"/>
+              </a:lnSpc>
+              <a:spcBef>
+                <a:spcPts val="0"/>
+              </a:spcBef>
+              <a:buSzPts val="3000"/>
+            </a:pPr>
+            <a:r>
+              <a:rPr lang="en-US" sz="2400" dirty="0">
+                <a:latin typeface="Arial"/>
+                <a:ea typeface="Arial"/>
+                <a:cs typeface="Arial"/>
+                <a:sym typeface="Arial"/>
+                <a:hlinkClick r:id="rId4"/>
+              </a:rPr>
+              <a:t>https://www.redblobgames.com/pathfinding/a-star/introduction.html</a:t>
             </a:r>
             <a:r>
               <a:rPr lang="en-US" sz="2400" dirty="0">
@@ -25036,7 +26253,49 @@
                 <a:cs typeface="Arial"/>
                 <a:sym typeface="Arial"/>
               </a:rPr>
-              <a:t>y</a:t>
+              <a:t> </a:t>
+            </a:r>
+          </a:p>
+          <a:p>
+            <a:pPr marL="0" indent="0">
+              <a:lnSpc>
+                <a:spcPct val="100000"/>
+              </a:lnSpc>
+              <a:spcBef>
+                <a:spcPts val="0"/>
+              </a:spcBef>
+              <a:buSzPts val="3000"/>
+              <a:buNone/>
+            </a:pPr>
+            <a:endParaRPr lang="en-US" sz="2400" dirty="0">
+              <a:solidFill>
+                <a:schemeClr val="dk1"/>
+              </a:solidFill>
+              <a:latin typeface="Arial"/>
+              <a:ea typeface="Arial"/>
+              <a:cs typeface="Arial"/>
+              <a:sym typeface="Arial"/>
+            </a:endParaRPr>
+          </a:p>
+          <a:p>
+            <a:pPr marL="0" indent="0">
+              <a:lnSpc>
+                <a:spcPct val="100000"/>
+              </a:lnSpc>
+              <a:spcBef>
+                <a:spcPts val="0"/>
+              </a:spcBef>
+              <a:buSzPts val="3000"/>
+              <a:buNone/>
+            </a:pPr>
+            <a:r>
+              <a:rPr lang="en-US" sz="2400" dirty="0">
+                <a:latin typeface="Arial"/>
+                <a:ea typeface="Arial"/>
+                <a:cs typeface="Arial"/>
+                <a:sym typeface="Arial"/>
+              </a:rPr>
+              <a:t>This is a series of interactable tutorial for path planning, it is very useful and goes through all the material in this lecture!</a:t>
             </a:r>
             <a:endParaRPr lang="en-US" sz="2400" dirty="0">
               <a:solidFill>
@@ -25161,12 +26420,16 @@
               <a:buNone/>
             </a:pPr>
             <a:r>
-              <a:rPr lang="en-US" sz="2400" dirty="0">
+              <a:rPr lang="en-US" sz="2400" b="0" i="0" u="none" strike="noStrike" cap="none" dirty="0">
                 <a:solidFill>
                   <a:schemeClr val="lt1"/>
                 </a:solidFill>
+                <a:latin typeface="Arial"/>
+                <a:ea typeface="Arial"/>
+                <a:cs typeface="Arial"/>
+                <a:sym typeface="Arial"/>
               </a:rPr>
-              <a:t>Empty</a:t>
+              <a:t>Preface</a:t>
             </a:r>
             <a:endParaRPr sz="2400" b="0" i="0" u="none" strike="noStrike" cap="none" dirty="0">
               <a:solidFill>
@@ -25193,7 +26456,7 @@
           <p:nvPr/>
         </p:nvPicPr>
         <p:blipFill rotWithShape="1">
-          <a:blip r:embed="rId3">
+          <a:blip r:embed="rId5">
             <a:alphaModFix/>
           </a:blip>
           <a:srcRect/>
@@ -25455,6 +26718,504 @@
   <p:cSld>
     <p:spTree>
       <p:nvGrpSpPr>
+        <p:cNvPr id="1" name="Shape 117">
+          <a:extLst>
+            <a:ext uri="{FF2B5EF4-FFF2-40B4-BE49-F238E27FC236}">
+              <a16:creationId xmlns:a16="http://schemas.microsoft.com/office/drawing/2014/main" id="{CAB31BED-0250-AE07-2DD3-6A6C2EB391E4}"/>
+            </a:ext>
+          </a:extLst>
+        </p:cNvPr>
+        <p:cNvGrpSpPr/>
+        <p:nvPr/>
+      </p:nvGrpSpPr>
+      <p:grpSpPr>
+        <a:xfrm>
+          <a:off x="0" y="0"/>
+          <a:ext cx="0" cy="0"/>
+          <a:chOff x="0" y="0"/>
+          <a:chExt cx="0" cy="0"/>
+        </a:xfrm>
+      </p:grpSpPr>
+      <p:sp>
+        <p:nvSpPr>
+          <p:cNvPr id="118" name="Google Shape;118;p29">
+            <a:extLst>
+              <a:ext uri="{FF2B5EF4-FFF2-40B4-BE49-F238E27FC236}">
+                <a16:creationId xmlns:a16="http://schemas.microsoft.com/office/drawing/2014/main" id="{2BE0E2B7-1369-7096-6138-7E551BF623EA}"/>
+              </a:ext>
+            </a:extLst>
+          </p:cNvPr>
+          <p:cNvSpPr txBox="1">
+            <a:spLocks noGrp="1"/>
+          </p:cNvSpPr>
+          <p:nvPr>
+            <p:ph type="body" idx="1"/>
+          </p:nvPr>
+        </p:nvSpPr>
+        <p:spPr>
+          <a:xfrm>
+            <a:off x="376809" y="1334279"/>
+            <a:ext cx="11177401" cy="4821102"/>
+          </a:xfrm>
+          <a:prstGeom prst="rect">
+            <a:avLst/>
+          </a:prstGeom>
+          <a:noFill/>
+          <a:ln>
+            <a:noFill/>
+          </a:ln>
+        </p:spPr>
+        <p:txBody>
+          <a:bodyPr spcFirstLastPara="1" wrap="square" lIns="91425" tIns="45700" rIns="91425" bIns="45700" anchor="t" anchorCtr="0">
+            <a:noAutofit/>
+          </a:bodyPr>
+          <a:lstStyle/>
+          <a:p>
+            <a:pPr marL="0" indent="0">
+              <a:lnSpc>
+                <a:spcPct val="100000"/>
+              </a:lnSpc>
+              <a:spcBef>
+                <a:spcPts val="0"/>
+              </a:spcBef>
+              <a:buSzPts val="3000"/>
+              <a:buNone/>
+            </a:pPr>
+            <a:r>
+              <a:rPr lang="en-US" sz="2400">
+                <a:latin typeface="Arial"/>
+                <a:ea typeface="Arial"/>
+                <a:cs typeface="Arial"/>
+                <a:sym typeface="Arial"/>
+              </a:rPr>
+              <a:t>Empt</a:t>
+            </a:r>
+            <a:r>
+              <a:rPr lang="en-US" sz="2400" dirty="0">
+                <a:latin typeface="Arial"/>
+                <a:ea typeface="Arial"/>
+                <a:cs typeface="Arial"/>
+                <a:sym typeface="Arial"/>
+              </a:rPr>
+              <a:t>y</a:t>
+            </a:r>
+            <a:endParaRPr lang="en-US" sz="2400" dirty="0">
+              <a:solidFill>
+                <a:schemeClr val="dk1"/>
+              </a:solidFill>
+              <a:latin typeface="Arial"/>
+              <a:ea typeface="Arial"/>
+              <a:cs typeface="Arial"/>
+              <a:sym typeface="Arial"/>
+            </a:endParaRPr>
+          </a:p>
+        </p:txBody>
+      </p:sp>
+      <p:sp>
+        <p:nvSpPr>
+          <p:cNvPr id="119" name="Google Shape;119;p29">
+            <a:extLst>
+              <a:ext uri="{FF2B5EF4-FFF2-40B4-BE49-F238E27FC236}">
+                <a16:creationId xmlns:a16="http://schemas.microsoft.com/office/drawing/2014/main" id="{2682A598-1CAE-743D-E80B-FC85664EA1D1}"/>
+              </a:ext>
+            </a:extLst>
+          </p:cNvPr>
+          <p:cNvSpPr/>
+          <p:nvPr/>
+        </p:nvSpPr>
+        <p:spPr>
+          <a:xfrm rot="10800000" flipH="1">
+            <a:off x="0" y="0"/>
+            <a:ext cx="12192000" cy="868220"/>
+          </a:xfrm>
+          <a:prstGeom prst="rect">
+            <a:avLst/>
+          </a:prstGeom>
+          <a:solidFill>
+            <a:srgbClr val="13294B"/>
+          </a:solidFill>
+          <a:ln>
+            <a:noFill/>
+          </a:ln>
+        </p:spPr>
+        <p:txBody>
+          <a:bodyPr spcFirstLastPara="1" wrap="square" lIns="91425" tIns="45700" rIns="91425" bIns="45700" anchor="ctr" anchorCtr="0">
+            <a:noAutofit/>
+          </a:bodyPr>
+          <a:lstStyle/>
+          <a:p>
+            <a:pPr marL="0" marR="0" lvl="0" indent="0" algn="ctr" rtl="0">
+              <a:lnSpc>
+                <a:spcPct val="100000"/>
+              </a:lnSpc>
+              <a:spcBef>
+                <a:spcPts val="0"/>
+              </a:spcBef>
+              <a:spcAft>
+                <a:spcPts val="0"/>
+              </a:spcAft>
+              <a:buClr>
+                <a:schemeClr val="lt1"/>
+              </a:buClr>
+              <a:buSzPts val="1800"/>
+              <a:buFont typeface="Calibri"/>
+              <a:buNone/>
+            </a:pPr>
+            <a:endParaRPr sz="1800" b="0" i="0" u="none" strike="noStrike" cap="none">
+              <a:solidFill>
+                <a:srgbClr val="13294B"/>
+              </a:solidFill>
+              <a:latin typeface="Calibri"/>
+              <a:ea typeface="Calibri"/>
+              <a:cs typeface="Calibri"/>
+              <a:sym typeface="Calibri"/>
+            </a:endParaRPr>
+          </a:p>
+        </p:txBody>
+      </p:sp>
+      <p:sp>
+        <p:nvSpPr>
+          <p:cNvPr id="120" name="Google Shape;120;p29">
+            <a:extLst>
+              <a:ext uri="{FF2B5EF4-FFF2-40B4-BE49-F238E27FC236}">
+                <a16:creationId xmlns:a16="http://schemas.microsoft.com/office/drawing/2014/main" id="{4B266D89-781E-9220-8AD5-217ECD89B6DF}"/>
+              </a:ext>
+            </a:extLst>
+          </p:cNvPr>
+          <p:cNvSpPr txBox="1"/>
+          <p:nvPr/>
+        </p:nvSpPr>
+        <p:spPr>
+          <a:xfrm>
+            <a:off x="376810" y="204051"/>
+            <a:ext cx="10910026" cy="461624"/>
+          </a:xfrm>
+          <a:prstGeom prst="rect">
+            <a:avLst/>
+          </a:prstGeom>
+          <a:noFill/>
+          <a:ln>
+            <a:noFill/>
+          </a:ln>
+        </p:spPr>
+        <p:txBody>
+          <a:bodyPr spcFirstLastPara="1" wrap="square" lIns="91425" tIns="45700" rIns="91425" bIns="45700" anchor="t" anchorCtr="0">
+            <a:spAutoFit/>
+          </a:bodyPr>
+          <a:lstStyle/>
+          <a:p>
+            <a:pPr marL="0" marR="0" lvl="0" indent="0" algn="l" rtl="0">
+              <a:lnSpc>
+                <a:spcPct val="100000"/>
+              </a:lnSpc>
+              <a:spcBef>
+                <a:spcPts val="0"/>
+              </a:spcBef>
+              <a:spcAft>
+                <a:spcPts val="0"/>
+              </a:spcAft>
+              <a:buClr>
+                <a:srgbClr val="000000"/>
+              </a:buClr>
+              <a:buSzPts val="2400"/>
+              <a:buFont typeface="Arial"/>
+              <a:buNone/>
+            </a:pPr>
+            <a:r>
+              <a:rPr lang="en-US" sz="2400" dirty="0">
+                <a:solidFill>
+                  <a:schemeClr val="lt1"/>
+                </a:solidFill>
+              </a:rPr>
+              <a:t>Empty</a:t>
+            </a:r>
+            <a:endParaRPr sz="2400" b="0" i="0" u="none" strike="noStrike" cap="none" dirty="0">
+              <a:solidFill>
+                <a:schemeClr val="lt1"/>
+              </a:solidFill>
+              <a:latin typeface="Arial"/>
+              <a:ea typeface="Arial"/>
+              <a:cs typeface="Arial"/>
+              <a:sym typeface="Arial"/>
+            </a:endParaRPr>
+          </a:p>
+        </p:txBody>
+      </p:sp>
+      <p:pic>
+        <p:nvPicPr>
+          <p:cNvPr id="121" name="Google Shape;121;p29">
+            <a:extLst>
+              <a:ext uri="{FF2B5EF4-FFF2-40B4-BE49-F238E27FC236}">
+                <a16:creationId xmlns:a16="http://schemas.microsoft.com/office/drawing/2014/main" id="{947035C2-EF7A-764A-381D-DBD204849F95}"/>
+              </a:ext>
+            </a:extLst>
+          </p:cNvPr>
+          <p:cNvPicPr preferRelativeResize="0"/>
+          <p:nvPr/>
+        </p:nvPicPr>
+        <p:blipFill rotWithShape="1">
+          <a:blip r:embed="rId3">
+            <a:alphaModFix/>
+          </a:blip>
+          <a:srcRect/>
+          <a:stretch/>
+        </p:blipFill>
+        <p:spPr>
+          <a:xfrm>
+            <a:off x="11557509" y="233819"/>
+            <a:ext cx="271308" cy="389810"/>
+          </a:xfrm>
+          <a:prstGeom prst="rect">
+            <a:avLst/>
+          </a:prstGeom>
+          <a:noFill/>
+          <a:ln>
+            <a:noFill/>
+          </a:ln>
+        </p:spPr>
+      </p:pic>
+      <p:sp>
+        <p:nvSpPr>
+          <p:cNvPr id="122" name="Google Shape;122;p29">
+            <a:extLst>
+              <a:ext uri="{FF2B5EF4-FFF2-40B4-BE49-F238E27FC236}">
+                <a16:creationId xmlns:a16="http://schemas.microsoft.com/office/drawing/2014/main" id="{72DBAF6A-A221-32E4-DB7D-538B0E127EA9}"/>
+              </a:ext>
+            </a:extLst>
+          </p:cNvPr>
+          <p:cNvSpPr txBox="1"/>
+          <p:nvPr/>
+        </p:nvSpPr>
+        <p:spPr>
+          <a:xfrm>
+            <a:off x="9335597" y="6524381"/>
+            <a:ext cx="2473415" cy="230792"/>
+          </a:xfrm>
+          <a:prstGeom prst="rect">
+            <a:avLst/>
+          </a:prstGeom>
+          <a:noFill/>
+          <a:ln>
+            <a:noFill/>
+          </a:ln>
+        </p:spPr>
+        <p:txBody>
+          <a:bodyPr spcFirstLastPara="1" wrap="square" lIns="91425" tIns="45700" rIns="91425" bIns="45700" anchor="t" anchorCtr="0">
+            <a:spAutoFit/>
+          </a:bodyPr>
+          <a:lstStyle/>
+          <a:p>
+            <a:pPr marL="0" marR="0" lvl="0" indent="0" algn="r" rtl="0">
+              <a:lnSpc>
+                <a:spcPct val="100000"/>
+              </a:lnSpc>
+              <a:spcBef>
+                <a:spcPts val="0"/>
+              </a:spcBef>
+              <a:spcAft>
+                <a:spcPts val="0"/>
+              </a:spcAft>
+              <a:buNone/>
+            </a:pPr>
+            <a:r>
+              <a:rPr lang="en-US" sz="900" b="0" i="0" u="none" strike="noStrike" cap="none">
+                <a:solidFill>
+                  <a:srgbClr val="13294B"/>
+                </a:solidFill>
+                <a:latin typeface="Arial"/>
+                <a:ea typeface="Arial"/>
+                <a:cs typeface="Arial"/>
+                <a:sym typeface="Arial"/>
+              </a:rPr>
+              <a:t>GRAINGER ENGINEERING</a:t>
+            </a:r>
+            <a:endParaRPr/>
+          </a:p>
+        </p:txBody>
+      </p:sp>
+      <p:sp>
+        <p:nvSpPr>
+          <p:cNvPr id="123" name="Google Shape;123;p29">
+            <a:extLst>
+              <a:ext uri="{FF2B5EF4-FFF2-40B4-BE49-F238E27FC236}">
+                <a16:creationId xmlns:a16="http://schemas.microsoft.com/office/drawing/2014/main" id="{8BD26DD5-03C4-3792-5F3C-BF6E15D1E434}"/>
+              </a:ext>
+            </a:extLst>
+          </p:cNvPr>
+          <p:cNvSpPr txBox="1"/>
+          <p:nvPr/>
+        </p:nvSpPr>
+        <p:spPr>
+          <a:xfrm>
+            <a:off x="376807" y="6524381"/>
+            <a:ext cx="7991337" cy="230792"/>
+          </a:xfrm>
+          <a:prstGeom prst="rect">
+            <a:avLst/>
+          </a:prstGeom>
+          <a:noFill/>
+          <a:ln>
+            <a:noFill/>
+          </a:ln>
+        </p:spPr>
+        <p:txBody>
+          <a:bodyPr spcFirstLastPara="1" wrap="square" lIns="91425" tIns="45700" rIns="91425" bIns="45700" anchor="t" anchorCtr="0">
+            <a:spAutoFit/>
+          </a:bodyPr>
+          <a:lstStyle/>
+          <a:p>
+            <a:pPr marL="0" marR="0" lvl="0" indent="0" algn="l" rtl="0">
+              <a:lnSpc>
+                <a:spcPct val="100000"/>
+              </a:lnSpc>
+              <a:spcBef>
+                <a:spcPts val="0"/>
+              </a:spcBef>
+              <a:spcAft>
+                <a:spcPts val="0"/>
+              </a:spcAft>
+              <a:buNone/>
+            </a:pPr>
+            <a:r>
+              <a:rPr lang="en-US" sz="900" dirty="0">
+                <a:solidFill>
+                  <a:srgbClr val="13294B"/>
+                </a:solidFill>
+              </a:rPr>
+              <a:t>SYSTEMS ENGINEERING </a:t>
+            </a:r>
+            <a:endParaRPr dirty="0"/>
+          </a:p>
+        </p:txBody>
+      </p:sp>
+      <p:grpSp>
+        <p:nvGrpSpPr>
+          <p:cNvPr id="124" name="Google Shape;124;p29">
+            <a:extLst>
+              <a:ext uri="{FF2B5EF4-FFF2-40B4-BE49-F238E27FC236}">
+                <a16:creationId xmlns:a16="http://schemas.microsoft.com/office/drawing/2014/main" id="{439EF623-249B-FF09-5496-3A302EDA9563}"/>
+              </a:ext>
+            </a:extLst>
+          </p:cNvPr>
+          <p:cNvGrpSpPr/>
+          <p:nvPr/>
+        </p:nvGrpSpPr>
+        <p:grpSpPr>
+          <a:xfrm>
+            <a:off x="4066674" y="6601537"/>
+            <a:ext cx="5233412" cy="70446"/>
+            <a:chOff x="4033424" y="6601537"/>
+            <a:chExt cx="5233412" cy="70446"/>
+          </a:xfrm>
+        </p:grpSpPr>
+        <p:cxnSp>
+          <p:nvCxnSpPr>
+            <p:cNvPr id="125" name="Google Shape;125;p29">
+              <a:extLst>
+                <a:ext uri="{FF2B5EF4-FFF2-40B4-BE49-F238E27FC236}">
+                  <a16:creationId xmlns:a16="http://schemas.microsoft.com/office/drawing/2014/main" id="{8A43F7AF-CE4D-F760-A14B-88E517C54735}"/>
+                </a:ext>
+              </a:extLst>
+            </p:cNvPr>
+            <p:cNvCxnSpPr/>
+            <p:nvPr/>
+          </p:nvCxnSpPr>
+          <p:spPr>
+            <a:xfrm rot="10800000">
+              <a:off x="4033424" y="6639606"/>
+              <a:ext cx="5164651" cy="0"/>
+            </a:xfrm>
+            <a:prstGeom prst="straightConnector1">
+              <a:avLst/>
+            </a:prstGeom>
+            <a:noFill/>
+            <a:ln w="9525" cap="flat" cmpd="sng">
+              <a:solidFill>
+                <a:srgbClr val="13294B"/>
+              </a:solidFill>
+              <a:prstDash val="solid"/>
+              <a:round/>
+              <a:headEnd type="none" w="sm" len="sm"/>
+              <a:tailEnd type="none" w="sm" len="sm"/>
+            </a:ln>
+          </p:spPr>
+        </p:cxnSp>
+        <p:sp>
+          <p:nvSpPr>
+            <p:cNvPr id="126" name="Google Shape;126;p29">
+              <a:extLst>
+                <a:ext uri="{FF2B5EF4-FFF2-40B4-BE49-F238E27FC236}">
+                  <a16:creationId xmlns:a16="http://schemas.microsoft.com/office/drawing/2014/main" id="{6EBD68D3-D381-E193-901B-DC322546F85C}"/>
+                </a:ext>
+              </a:extLst>
+            </p:cNvPr>
+            <p:cNvSpPr/>
+            <p:nvPr/>
+          </p:nvSpPr>
+          <p:spPr>
+            <a:xfrm>
+              <a:off x="9196390" y="6601537"/>
+              <a:ext cx="70446" cy="70446"/>
+            </a:xfrm>
+            <a:prstGeom prst="ellipse">
+              <a:avLst/>
+            </a:prstGeom>
+            <a:solidFill>
+              <a:srgbClr val="13294B"/>
+            </a:solidFill>
+            <a:ln>
+              <a:noFill/>
+            </a:ln>
+          </p:spPr>
+          <p:txBody>
+            <a:bodyPr spcFirstLastPara="1" wrap="square" lIns="91425" tIns="45700" rIns="91425" bIns="45700" anchor="ctr" anchorCtr="0">
+              <a:noAutofit/>
+            </a:bodyPr>
+            <a:lstStyle/>
+            <a:p>
+              <a:pPr marL="0" marR="0" lvl="0" indent="0" algn="ctr" rtl="0">
+                <a:lnSpc>
+                  <a:spcPct val="100000"/>
+                </a:lnSpc>
+                <a:spcBef>
+                  <a:spcPts val="0"/>
+                </a:spcBef>
+                <a:spcAft>
+                  <a:spcPts val="0"/>
+                </a:spcAft>
+                <a:buNone/>
+              </a:pPr>
+              <a:endParaRPr sz="1400" b="0" i="0" u="none" strike="noStrike" cap="none">
+                <a:solidFill>
+                  <a:srgbClr val="13294B"/>
+                </a:solidFill>
+                <a:latin typeface="Arial"/>
+                <a:ea typeface="Arial"/>
+                <a:cs typeface="Arial"/>
+                <a:sym typeface="Arial"/>
+              </a:endParaRPr>
+            </a:p>
+          </p:txBody>
+        </p:sp>
+      </p:grpSp>
+    </p:spTree>
+    <p:extLst>
+      <p:ext uri="{BB962C8B-B14F-4D97-AF65-F5344CB8AC3E}">
+        <p14:creationId xmlns:p14="http://schemas.microsoft.com/office/powerpoint/2010/main" val="2562259408"/>
+      </p:ext>
+    </p:extLst>
+  </p:cSld>
+  <p:clrMapOvr>
+    <a:masterClrMapping/>
+  </p:clrMapOvr>
+</p:sld>
+</file>
+
+<file path=ppt/slides/slide8.xml><?xml version="1.0" encoding="utf-8"?>
+<p:sld xmlns:a="http://schemas.openxmlformats.org/drawingml/2006/main" xmlns:r="http://schemas.openxmlformats.org/officeDocument/2006/relationships" xmlns:p="http://schemas.openxmlformats.org/presentationml/2006/main">
+  <p:cSld>
+    <p:spTree>
+      <p:nvGrpSpPr>
         <p:cNvPr id="1" name="Shape 117"/>
         <p:cNvGrpSpPr/>
         <p:nvPr/>
@@ -26050,7 +27811,7 @@
 </p:sld>
 </file>
 
-<file path=ppt/slides/slide8.xml><?xml version="1.0" encoding="utf-8"?>
+<file path=ppt/slides/slide9.xml><?xml version="1.0" encoding="utf-8"?>
 <p:sld xmlns:a="http://schemas.openxmlformats.org/drawingml/2006/main" xmlns:r="http://schemas.openxmlformats.org/officeDocument/2006/relationships" xmlns:p="http://schemas.openxmlformats.org/presentationml/2006/main">
   <p:cSld>
     <p:spTree>
@@ -26599,845 +28360,6 @@
         <p:sp>
           <p:nvSpPr>
             <p:cNvPr id="140" name="Google Shape;140;p30"/>
-            <p:cNvSpPr/>
-            <p:nvPr/>
-          </p:nvSpPr>
-          <p:spPr>
-            <a:xfrm>
-              <a:off x="9196390" y="6601537"/>
-              <a:ext cx="70446" cy="70446"/>
-            </a:xfrm>
-            <a:prstGeom prst="ellipse">
-              <a:avLst/>
-            </a:prstGeom>
-            <a:solidFill>
-              <a:srgbClr val="13294B"/>
-            </a:solidFill>
-            <a:ln>
-              <a:noFill/>
-            </a:ln>
-          </p:spPr>
-          <p:txBody>
-            <a:bodyPr spcFirstLastPara="1" wrap="square" lIns="91425" tIns="45700" rIns="91425" bIns="45700" anchor="ctr" anchorCtr="0">
-              <a:noAutofit/>
-            </a:bodyPr>
-            <a:lstStyle/>
-            <a:p>
-              <a:pPr marL="0" marR="0" lvl="0" indent="0" algn="ctr" rtl="0">
-                <a:lnSpc>
-                  <a:spcPct val="100000"/>
-                </a:lnSpc>
-                <a:spcBef>
-                  <a:spcPts val="0"/>
-                </a:spcBef>
-                <a:spcAft>
-                  <a:spcPts val="0"/>
-                </a:spcAft>
-                <a:buNone/>
-              </a:pPr>
-              <a:endParaRPr sz="1400" b="0" i="0" u="none" strike="noStrike" cap="none">
-                <a:solidFill>
-                  <a:srgbClr val="13294B"/>
-                </a:solidFill>
-                <a:latin typeface="Arial"/>
-                <a:ea typeface="Arial"/>
-                <a:cs typeface="Arial"/>
-                <a:sym typeface="Arial"/>
-              </a:endParaRPr>
-            </a:p>
-          </p:txBody>
-        </p:sp>
-      </p:grpSp>
-    </p:spTree>
-  </p:cSld>
-  <p:clrMapOvr>
-    <a:masterClrMapping/>
-  </p:clrMapOvr>
-</p:sld>
-</file>
-
-<file path=ppt/slides/slide9.xml><?xml version="1.0" encoding="utf-8"?>
-<p:sld xmlns:a="http://schemas.openxmlformats.org/drawingml/2006/main" xmlns:r="http://schemas.openxmlformats.org/officeDocument/2006/relationships" xmlns:p="http://schemas.openxmlformats.org/presentationml/2006/main">
-  <p:cSld>
-    <p:spTree>
-      <p:nvGrpSpPr>
-        <p:cNvPr id="1" name="Shape 144"/>
-        <p:cNvGrpSpPr/>
-        <p:nvPr/>
-      </p:nvGrpSpPr>
-      <p:grpSpPr>
-        <a:xfrm>
-          <a:off x="0" y="0"/>
-          <a:ext cx="0" cy="0"/>
-          <a:chOff x="0" y="0"/>
-          <a:chExt cx="0" cy="0"/>
-        </a:xfrm>
-      </p:grpSpPr>
-      <p:sp>
-        <p:nvSpPr>
-          <p:cNvPr id="145" name="Google Shape;145;p31"/>
-          <p:cNvSpPr/>
-          <p:nvPr/>
-        </p:nvSpPr>
-        <p:spPr>
-          <a:xfrm>
-            <a:off x="475566" y="1263717"/>
-            <a:ext cx="4356660" cy="2315647"/>
-          </a:xfrm>
-          <a:prstGeom prst="rect">
-            <a:avLst/>
-          </a:prstGeom>
-          <a:solidFill>
-            <a:srgbClr val="D8D8D8"/>
-          </a:solidFill>
-          <a:ln>
-            <a:noFill/>
-          </a:ln>
-        </p:spPr>
-        <p:txBody>
-          <a:bodyPr spcFirstLastPara="1" wrap="square" lIns="91425" tIns="45700" rIns="91425" bIns="45700" anchor="ctr" anchorCtr="0">
-            <a:noAutofit/>
-          </a:bodyPr>
-          <a:lstStyle/>
-          <a:p>
-            <a:pPr marL="0" marR="0" lvl="0" indent="0" algn="ctr" rtl="0">
-              <a:lnSpc>
-                <a:spcPct val="100000"/>
-              </a:lnSpc>
-              <a:spcBef>
-                <a:spcPts val="0"/>
-              </a:spcBef>
-              <a:spcAft>
-                <a:spcPts val="0"/>
-              </a:spcAft>
-              <a:buClr>
-                <a:srgbClr val="000000"/>
-              </a:buClr>
-              <a:buSzPts val="1800"/>
-              <a:buFont typeface="Arial"/>
-              <a:buNone/>
-            </a:pPr>
-            <a:endParaRPr sz="1800" b="0" i="0" u="none" strike="noStrike" cap="none">
-              <a:solidFill>
-                <a:schemeClr val="lt1"/>
-              </a:solidFill>
-              <a:latin typeface="Calibri"/>
-              <a:ea typeface="Calibri"/>
-              <a:cs typeface="Calibri"/>
-              <a:sym typeface="Calibri"/>
-            </a:endParaRPr>
-          </a:p>
-        </p:txBody>
-      </p:sp>
-      <p:sp>
-        <p:nvSpPr>
-          <p:cNvPr id="146" name="Google Shape;146;p31"/>
-          <p:cNvSpPr txBox="1"/>
-          <p:nvPr/>
-        </p:nvSpPr>
-        <p:spPr>
-          <a:xfrm>
-            <a:off x="1494115" y="2239572"/>
-            <a:ext cx="2280491" cy="369332"/>
-          </a:xfrm>
-          <a:prstGeom prst="rect">
-            <a:avLst/>
-          </a:prstGeom>
-          <a:noFill/>
-          <a:ln>
-            <a:noFill/>
-          </a:ln>
-        </p:spPr>
-        <p:txBody>
-          <a:bodyPr spcFirstLastPara="1" wrap="square" lIns="91425" tIns="45700" rIns="91425" bIns="45700" anchor="t" anchorCtr="0">
-            <a:spAutoFit/>
-          </a:bodyPr>
-          <a:lstStyle/>
-          <a:p>
-            <a:pPr marL="0" marR="0" lvl="0" indent="0" algn="ctr" rtl="0">
-              <a:lnSpc>
-                <a:spcPct val="100000"/>
-              </a:lnSpc>
-              <a:spcBef>
-                <a:spcPts val="0"/>
-              </a:spcBef>
-              <a:spcAft>
-                <a:spcPts val="0"/>
-              </a:spcAft>
-              <a:buClr>
-                <a:srgbClr val="000000"/>
-              </a:buClr>
-              <a:buSzPts val="1800"/>
-              <a:buFont typeface="Arial"/>
-              <a:buNone/>
-            </a:pPr>
-            <a:r>
-              <a:rPr lang="en-US" sz="1800" b="0" i="0" u="none" strike="noStrike" cap="none">
-                <a:solidFill>
-                  <a:srgbClr val="A5A5A5"/>
-                </a:solidFill>
-                <a:latin typeface="Arial"/>
-                <a:ea typeface="Arial"/>
-                <a:cs typeface="Arial"/>
-                <a:sym typeface="Arial"/>
-              </a:rPr>
-              <a:t>IMAGE / GRAPHIC</a:t>
-            </a:r>
-            <a:endParaRPr sz="1400" b="0" i="0" u="none" strike="noStrike" cap="none">
-              <a:solidFill>
-                <a:srgbClr val="000000"/>
-              </a:solidFill>
-              <a:latin typeface="Arial"/>
-              <a:ea typeface="Arial"/>
-              <a:cs typeface="Arial"/>
-              <a:sym typeface="Arial"/>
-            </a:endParaRPr>
-          </a:p>
-        </p:txBody>
-      </p:sp>
-      <p:sp>
-        <p:nvSpPr>
-          <p:cNvPr id="147" name="Google Shape;147;p31"/>
-          <p:cNvSpPr/>
-          <p:nvPr/>
-        </p:nvSpPr>
-        <p:spPr>
-          <a:xfrm>
-            <a:off x="475566" y="3774068"/>
-            <a:ext cx="4356660" cy="2315647"/>
-          </a:xfrm>
-          <a:prstGeom prst="rect">
-            <a:avLst/>
-          </a:prstGeom>
-          <a:solidFill>
-            <a:srgbClr val="D8D8D8"/>
-          </a:solidFill>
-          <a:ln>
-            <a:noFill/>
-          </a:ln>
-        </p:spPr>
-        <p:txBody>
-          <a:bodyPr spcFirstLastPara="1" wrap="square" lIns="91425" tIns="45700" rIns="91425" bIns="45700" anchor="ctr" anchorCtr="0">
-            <a:noAutofit/>
-          </a:bodyPr>
-          <a:lstStyle/>
-          <a:p>
-            <a:pPr marL="0" marR="0" lvl="0" indent="0" algn="ctr" rtl="0">
-              <a:lnSpc>
-                <a:spcPct val="100000"/>
-              </a:lnSpc>
-              <a:spcBef>
-                <a:spcPts val="0"/>
-              </a:spcBef>
-              <a:spcAft>
-                <a:spcPts val="0"/>
-              </a:spcAft>
-              <a:buClr>
-                <a:srgbClr val="000000"/>
-              </a:buClr>
-              <a:buSzPts val="1800"/>
-              <a:buFont typeface="Arial"/>
-              <a:buNone/>
-            </a:pPr>
-            <a:endParaRPr sz="1800" b="0" i="0" u="none" strike="noStrike" cap="none">
-              <a:solidFill>
-                <a:schemeClr val="lt1"/>
-              </a:solidFill>
-              <a:latin typeface="Calibri"/>
-              <a:ea typeface="Calibri"/>
-              <a:cs typeface="Calibri"/>
-              <a:sym typeface="Calibri"/>
-            </a:endParaRPr>
-          </a:p>
-        </p:txBody>
-      </p:sp>
-      <p:sp>
-        <p:nvSpPr>
-          <p:cNvPr id="148" name="Google Shape;148;p31"/>
-          <p:cNvSpPr txBox="1"/>
-          <p:nvPr/>
-        </p:nvSpPr>
-        <p:spPr>
-          <a:xfrm>
-            <a:off x="1494115" y="4747225"/>
-            <a:ext cx="2280491" cy="369332"/>
-          </a:xfrm>
-          <a:prstGeom prst="rect">
-            <a:avLst/>
-          </a:prstGeom>
-          <a:noFill/>
-          <a:ln>
-            <a:noFill/>
-          </a:ln>
-        </p:spPr>
-        <p:txBody>
-          <a:bodyPr spcFirstLastPara="1" wrap="square" lIns="91425" tIns="45700" rIns="91425" bIns="45700" anchor="t" anchorCtr="0">
-            <a:spAutoFit/>
-          </a:bodyPr>
-          <a:lstStyle/>
-          <a:p>
-            <a:pPr marL="0" marR="0" lvl="0" indent="0" algn="ctr" rtl="0">
-              <a:lnSpc>
-                <a:spcPct val="100000"/>
-              </a:lnSpc>
-              <a:spcBef>
-                <a:spcPts val="0"/>
-              </a:spcBef>
-              <a:spcAft>
-                <a:spcPts val="0"/>
-              </a:spcAft>
-              <a:buClr>
-                <a:srgbClr val="000000"/>
-              </a:buClr>
-              <a:buSzPts val="1800"/>
-              <a:buFont typeface="Arial"/>
-              <a:buNone/>
-            </a:pPr>
-            <a:r>
-              <a:rPr lang="en-US" sz="1800" b="0" i="0" u="none" strike="noStrike" cap="none">
-                <a:solidFill>
-                  <a:srgbClr val="A5A5A5"/>
-                </a:solidFill>
-                <a:latin typeface="Arial"/>
-                <a:ea typeface="Arial"/>
-                <a:cs typeface="Arial"/>
-                <a:sym typeface="Arial"/>
-              </a:rPr>
-              <a:t>IMAGE / GRAPHIC</a:t>
-            </a:r>
-            <a:endParaRPr sz="1400" b="0" i="0" u="none" strike="noStrike" cap="none">
-              <a:solidFill>
-                <a:srgbClr val="000000"/>
-              </a:solidFill>
-              <a:latin typeface="Arial"/>
-              <a:ea typeface="Arial"/>
-              <a:cs typeface="Arial"/>
-              <a:sym typeface="Arial"/>
-            </a:endParaRPr>
-          </a:p>
-        </p:txBody>
-      </p:sp>
-      <p:sp>
-        <p:nvSpPr>
-          <p:cNvPr id="149" name="Google Shape;149;p31"/>
-          <p:cNvSpPr txBox="1"/>
-          <p:nvPr/>
-        </p:nvSpPr>
-        <p:spPr>
-          <a:xfrm>
-            <a:off x="5122548" y="1334279"/>
-            <a:ext cx="6686464" cy="4821102"/>
-          </a:xfrm>
-          <a:prstGeom prst="rect">
-            <a:avLst/>
-          </a:prstGeom>
-          <a:noFill/>
-          <a:ln>
-            <a:noFill/>
-          </a:ln>
-        </p:spPr>
-        <p:txBody>
-          <a:bodyPr spcFirstLastPara="1" wrap="square" lIns="91425" tIns="45700" rIns="91425" bIns="45700" anchor="t" anchorCtr="0">
-            <a:noAutofit/>
-          </a:bodyPr>
-          <a:lstStyle/>
-          <a:p>
-            <a:pPr marL="0" marR="0" lvl="0" indent="0" algn="l" rtl="0">
-              <a:lnSpc>
-                <a:spcPct val="100000"/>
-              </a:lnSpc>
-              <a:spcBef>
-                <a:spcPts val="0"/>
-              </a:spcBef>
-              <a:spcAft>
-                <a:spcPts val="0"/>
-              </a:spcAft>
-              <a:buNone/>
-            </a:pPr>
-            <a:r>
-              <a:rPr lang="en-US" sz="2600" b="1" i="0" u="none" strike="noStrike" cap="none">
-                <a:solidFill>
-                  <a:srgbClr val="E84B36"/>
-                </a:solidFill>
-                <a:latin typeface="Arial"/>
-                <a:ea typeface="Arial"/>
-                <a:cs typeface="Arial"/>
-                <a:sym typeface="Arial"/>
-              </a:rPr>
-              <a:t>Lorem Ipsum Dolor Sit Amet Consectetur Adipiscing</a:t>
-            </a:r>
-            <a:endParaRPr sz="2600" b="1" i="0" u="none" strike="noStrike" cap="none">
-              <a:solidFill>
-                <a:srgbClr val="E84B36"/>
-              </a:solidFill>
-              <a:latin typeface="Arial"/>
-              <a:ea typeface="Arial"/>
-              <a:cs typeface="Arial"/>
-              <a:sym typeface="Arial"/>
-            </a:endParaRPr>
-          </a:p>
-          <a:p>
-            <a:pPr marL="0" marR="0" lvl="0" indent="0" algn="l" rtl="0">
-              <a:lnSpc>
-                <a:spcPct val="100000"/>
-              </a:lnSpc>
-              <a:spcBef>
-                <a:spcPts val="0"/>
-              </a:spcBef>
-              <a:spcAft>
-                <a:spcPts val="0"/>
-              </a:spcAft>
-              <a:buNone/>
-            </a:pPr>
-            <a:endParaRPr sz="1800" b="0" i="0" u="none" strike="noStrike" cap="none">
-              <a:solidFill>
-                <a:schemeClr val="dk1"/>
-              </a:solidFill>
-              <a:latin typeface="Arial"/>
-              <a:ea typeface="Arial"/>
-              <a:cs typeface="Arial"/>
-              <a:sym typeface="Arial"/>
-            </a:endParaRPr>
-          </a:p>
-          <a:p>
-            <a:pPr marL="0" marR="0" lvl="0" indent="0" algn="l" rtl="0">
-              <a:lnSpc>
-                <a:spcPct val="100000"/>
-              </a:lnSpc>
-              <a:spcBef>
-                <a:spcPts val="0"/>
-              </a:spcBef>
-              <a:spcAft>
-                <a:spcPts val="0"/>
-              </a:spcAft>
-              <a:buNone/>
-            </a:pPr>
-            <a:r>
-              <a:rPr lang="en-US" sz="1800" b="0" i="0" u="none" strike="noStrike" cap="none">
-                <a:solidFill>
-                  <a:srgbClr val="000000"/>
-                </a:solidFill>
-                <a:latin typeface="Arial"/>
-                <a:ea typeface="Arial"/>
-                <a:cs typeface="Arial"/>
-                <a:sym typeface="Arial"/>
-              </a:rPr>
-              <a:t>Lorem ipsum dolor sit amet, consectetur adipiscing elit, sed do eiusmod tempor incididunt ut labore et dolore magna aliqua. Ut enim ad minim veniam, quis nostrud exercitation ullamco laboris nisi ut aliquip ex ea commodo consequat. </a:t>
-            </a:r>
-            <a:endParaRPr/>
-          </a:p>
-          <a:p>
-            <a:pPr marL="0" marR="0" lvl="0" indent="0" algn="l" rtl="0">
-              <a:lnSpc>
-                <a:spcPct val="100000"/>
-              </a:lnSpc>
-              <a:spcBef>
-                <a:spcPts val="0"/>
-              </a:spcBef>
-              <a:spcAft>
-                <a:spcPts val="0"/>
-              </a:spcAft>
-              <a:buNone/>
-            </a:pPr>
-            <a:endParaRPr sz="1800" b="0" i="0" u="none" strike="noStrike" cap="none">
-              <a:solidFill>
-                <a:schemeClr val="dk1"/>
-              </a:solidFill>
-              <a:latin typeface="Arial"/>
-              <a:ea typeface="Arial"/>
-              <a:cs typeface="Arial"/>
-              <a:sym typeface="Arial"/>
-            </a:endParaRPr>
-          </a:p>
-          <a:p>
-            <a:pPr marL="0" marR="0" lvl="0" indent="0" algn="l" rtl="0">
-              <a:lnSpc>
-                <a:spcPct val="100000"/>
-              </a:lnSpc>
-              <a:spcBef>
-                <a:spcPts val="0"/>
-              </a:spcBef>
-              <a:spcAft>
-                <a:spcPts val="0"/>
-              </a:spcAft>
-              <a:buNone/>
-            </a:pPr>
-            <a:r>
-              <a:rPr lang="en-US" sz="2000" b="1" i="0" u="none" strike="noStrike" cap="none">
-                <a:solidFill>
-                  <a:srgbClr val="15264B"/>
-                </a:solidFill>
-                <a:latin typeface="Arial"/>
-                <a:ea typeface="Arial"/>
-                <a:cs typeface="Arial"/>
-                <a:sym typeface="Arial"/>
-              </a:rPr>
-              <a:t>Lorem Ipsum Dolor Sit Amet Consectetur Adipiscing</a:t>
-            </a:r>
-            <a:endParaRPr sz="2000" b="1" i="0" u="none" strike="noStrike" cap="none">
-              <a:solidFill>
-                <a:srgbClr val="15264B"/>
-              </a:solidFill>
-              <a:latin typeface="Arial"/>
-              <a:ea typeface="Arial"/>
-              <a:cs typeface="Arial"/>
-              <a:sym typeface="Arial"/>
-            </a:endParaRPr>
-          </a:p>
-          <a:p>
-            <a:pPr marL="0" marR="0" lvl="0" indent="0" algn="l" rtl="0">
-              <a:lnSpc>
-                <a:spcPct val="100000"/>
-              </a:lnSpc>
-              <a:spcBef>
-                <a:spcPts val="0"/>
-              </a:spcBef>
-              <a:spcAft>
-                <a:spcPts val="0"/>
-              </a:spcAft>
-              <a:buNone/>
-            </a:pPr>
-            <a:endParaRPr sz="1800" b="1" i="0" u="none" strike="noStrike" cap="none">
-              <a:solidFill>
-                <a:schemeClr val="dk1"/>
-              </a:solidFill>
-              <a:latin typeface="Arial"/>
-              <a:ea typeface="Arial"/>
-              <a:cs typeface="Arial"/>
-              <a:sym typeface="Arial"/>
-            </a:endParaRPr>
-          </a:p>
-          <a:p>
-            <a:pPr marL="0" marR="0" lvl="0" indent="0" algn="l" rtl="0">
-              <a:lnSpc>
-                <a:spcPct val="100000"/>
-              </a:lnSpc>
-              <a:spcBef>
-                <a:spcPts val="0"/>
-              </a:spcBef>
-              <a:spcAft>
-                <a:spcPts val="0"/>
-              </a:spcAft>
-              <a:buNone/>
-            </a:pPr>
-            <a:r>
-              <a:rPr lang="en-US" sz="1800" b="0" i="0" u="none" strike="noStrike" cap="none">
-                <a:solidFill>
-                  <a:srgbClr val="000000"/>
-                </a:solidFill>
-                <a:latin typeface="Arial"/>
-                <a:ea typeface="Arial"/>
-                <a:cs typeface="Arial"/>
-                <a:sym typeface="Arial"/>
-              </a:rPr>
-              <a:t>Lorem ipsum dolor sit amet, consectetur adipiscing elit, sed do eiusmod tempor incididunt ut labore et dolore magna aliqua.</a:t>
-            </a:r>
-            <a:endParaRPr sz="1800" b="1" i="0" u="none" strike="noStrike" cap="none">
-              <a:solidFill>
-                <a:schemeClr val="dk1"/>
-              </a:solidFill>
-              <a:latin typeface="Arial"/>
-              <a:ea typeface="Arial"/>
-              <a:cs typeface="Arial"/>
-              <a:sym typeface="Arial"/>
-            </a:endParaRPr>
-          </a:p>
-        </p:txBody>
-      </p:sp>
-      <p:sp>
-        <p:nvSpPr>
-          <p:cNvPr id="150" name="Google Shape;150;p31"/>
-          <p:cNvSpPr/>
-          <p:nvPr/>
-        </p:nvSpPr>
-        <p:spPr>
-          <a:xfrm rot="10800000" flipH="1">
-            <a:off x="0" y="0"/>
-            <a:ext cx="12192000" cy="868220"/>
-          </a:xfrm>
-          <a:prstGeom prst="rect">
-            <a:avLst/>
-          </a:prstGeom>
-          <a:solidFill>
-            <a:srgbClr val="13294B"/>
-          </a:solidFill>
-          <a:ln>
-            <a:noFill/>
-          </a:ln>
-        </p:spPr>
-        <p:txBody>
-          <a:bodyPr spcFirstLastPara="1" wrap="square" lIns="91425" tIns="45700" rIns="91425" bIns="45700" anchor="ctr" anchorCtr="0">
-            <a:noAutofit/>
-          </a:bodyPr>
-          <a:lstStyle/>
-          <a:p>
-            <a:pPr marL="0" marR="0" lvl="0" indent="0" algn="ctr" rtl="0">
-              <a:lnSpc>
-                <a:spcPct val="100000"/>
-              </a:lnSpc>
-              <a:spcBef>
-                <a:spcPts val="0"/>
-              </a:spcBef>
-              <a:spcAft>
-                <a:spcPts val="0"/>
-              </a:spcAft>
-              <a:buClr>
-                <a:schemeClr val="lt1"/>
-              </a:buClr>
-              <a:buSzPts val="1800"/>
-              <a:buFont typeface="Calibri"/>
-              <a:buNone/>
-            </a:pPr>
-            <a:endParaRPr sz="1800" b="0" i="0" u="none" strike="noStrike" cap="none">
-              <a:solidFill>
-                <a:srgbClr val="13294B"/>
-              </a:solidFill>
-              <a:latin typeface="Calibri"/>
-              <a:ea typeface="Calibri"/>
-              <a:cs typeface="Calibri"/>
-              <a:sym typeface="Calibri"/>
-            </a:endParaRPr>
-          </a:p>
-        </p:txBody>
-      </p:sp>
-      <p:sp>
-        <p:nvSpPr>
-          <p:cNvPr id="151" name="Google Shape;151;p31"/>
-          <p:cNvSpPr txBox="1"/>
-          <p:nvPr/>
-        </p:nvSpPr>
-        <p:spPr>
-          <a:xfrm>
-            <a:off x="376810" y="204051"/>
-            <a:ext cx="10910026" cy="461624"/>
-          </a:xfrm>
-          <a:prstGeom prst="rect">
-            <a:avLst/>
-          </a:prstGeom>
-          <a:noFill/>
-          <a:ln>
-            <a:noFill/>
-          </a:ln>
-        </p:spPr>
-        <p:txBody>
-          <a:bodyPr spcFirstLastPara="1" wrap="square" lIns="91425" tIns="45700" rIns="91425" bIns="45700" anchor="t" anchorCtr="0">
-            <a:spAutoFit/>
-          </a:bodyPr>
-          <a:lstStyle/>
-          <a:p>
-            <a:pPr marL="0" marR="0" lvl="0" indent="0" algn="l" rtl="0">
-              <a:lnSpc>
-                <a:spcPct val="100000"/>
-              </a:lnSpc>
-              <a:spcBef>
-                <a:spcPts val="0"/>
-              </a:spcBef>
-              <a:spcAft>
-                <a:spcPts val="0"/>
-              </a:spcAft>
-              <a:buClr>
-                <a:srgbClr val="000000"/>
-              </a:buClr>
-              <a:buSzPts val="2400"/>
-              <a:buFont typeface="Arial"/>
-              <a:buNone/>
-            </a:pPr>
-            <a:r>
-              <a:rPr lang="en-US" sz="2400" b="0" i="0" u="none" strike="noStrike" cap="none">
-                <a:solidFill>
-                  <a:schemeClr val="lt1"/>
-                </a:solidFill>
-                <a:latin typeface="Arial"/>
-                <a:ea typeface="Arial"/>
-                <a:cs typeface="Arial"/>
-                <a:sym typeface="Arial"/>
-              </a:rPr>
-              <a:t>Slide Title</a:t>
-            </a:r>
-            <a:endParaRPr sz="2400" b="0" i="0" u="none" strike="noStrike" cap="none">
-              <a:solidFill>
-                <a:schemeClr val="lt1"/>
-              </a:solidFill>
-              <a:latin typeface="Arial"/>
-              <a:ea typeface="Arial"/>
-              <a:cs typeface="Arial"/>
-              <a:sym typeface="Arial"/>
-            </a:endParaRPr>
-          </a:p>
-        </p:txBody>
-      </p:sp>
-      <p:pic>
-        <p:nvPicPr>
-          <p:cNvPr id="152" name="Google Shape;152;p31"/>
-          <p:cNvPicPr preferRelativeResize="0"/>
-          <p:nvPr/>
-        </p:nvPicPr>
-        <p:blipFill rotWithShape="1">
-          <a:blip r:embed="rId3">
-            <a:alphaModFix/>
-          </a:blip>
-          <a:srcRect/>
-          <a:stretch/>
-        </p:blipFill>
-        <p:spPr>
-          <a:xfrm>
-            <a:off x="11557509" y="233819"/>
-            <a:ext cx="271308" cy="389810"/>
-          </a:xfrm>
-          <a:prstGeom prst="rect">
-            <a:avLst/>
-          </a:prstGeom>
-          <a:noFill/>
-          <a:ln>
-            <a:noFill/>
-          </a:ln>
-        </p:spPr>
-      </p:pic>
-      <p:sp>
-        <p:nvSpPr>
-          <p:cNvPr id="153" name="Google Shape;153;p31"/>
-          <p:cNvSpPr txBox="1"/>
-          <p:nvPr/>
-        </p:nvSpPr>
-        <p:spPr>
-          <a:xfrm>
-            <a:off x="9335597" y="6524381"/>
-            <a:ext cx="2473415" cy="230792"/>
-          </a:xfrm>
-          <a:prstGeom prst="rect">
-            <a:avLst/>
-          </a:prstGeom>
-          <a:noFill/>
-          <a:ln>
-            <a:noFill/>
-          </a:ln>
-        </p:spPr>
-        <p:txBody>
-          <a:bodyPr spcFirstLastPara="1" wrap="square" lIns="91425" tIns="45700" rIns="91425" bIns="45700" anchor="t" anchorCtr="0">
-            <a:spAutoFit/>
-          </a:bodyPr>
-          <a:lstStyle/>
-          <a:p>
-            <a:pPr marL="0" marR="0" lvl="0" indent="0" algn="r" rtl="0">
-              <a:lnSpc>
-                <a:spcPct val="100000"/>
-              </a:lnSpc>
-              <a:spcBef>
-                <a:spcPts val="0"/>
-              </a:spcBef>
-              <a:spcAft>
-                <a:spcPts val="0"/>
-              </a:spcAft>
-              <a:buNone/>
-            </a:pPr>
-            <a:r>
-              <a:rPr lang="en-US" sz="900" b="0" i="0" u="none" strike="noStrike" cap="none">
-                <a:solidFill>
-                  <a:srgbClr val="13294B"/>
-                </a:solidFill>
-                <a:latin typeface="Arial"/>
-                <a:ea typeface="Arial"/>
-                <a:cs typeface="Arial"/>
-                <a:sym typeface="Arial"/>
-              </a:rPr>
-              <a:t>GRAINGER ENGINEERING</a:t>
-            </a:r>
-            <a:endParaRPr/>
-          </a:p>
-        </p:txBody>
-      </p:sp>
-      <p:sp>
-        <p:nvSpPr>
-          <p:cNvPr id="154" name="Google Shape;154;p31"/>
-          <p:cNvSpPr txBox="1"/>
-          <p:nvPr/>
-        </p:nvSpPr>
-        <p:spPr>
-          <a:xfrm>
-            <a:off x="376807" y="6524381"/>
-            <a:ext cx="7991400" cy="230700"/>
-          </a:xfrm>
-          <a:prstGeom prst="rect">
-            <a:avLst/>
-          </a:prstGeom>
-          <a:noFill/>
-          <a:ln>
-            <a:noFill/>
-          </a:ln>
-        </p:spPr>
-        <p:txBody>
-          <a:bodyPr spcFirstLastPara="1" wrap="square" lIns="91425" tIns="45700" rIns="91425" bIns="45700" anchor="t" anchorCtr="0">
-            <a:spAutoFit/>
-          </a:bodyPr>
-          <a:lstStyle/>
-          <a:p>
-            <a:pPr marL="0" marR="0" lvl="0" indent="0" algn="l" rtl="0">
-              <a:lnSpc>
-                <a:spcPct val="100000"/>
-              </a:lnSpc>
-              <a:spcBef>
-                <a:spcPts val="0"/>
-              </a:spcBef>
-              <a:spcAft>
-                <a:spcPts val="0"/>
-              </a:spcAft>
-              <a:buNone/>
-            </a:pPr>
-            <a:r>
-              <a:rPr lang="en-US" sz="900" dirty="0">
-                <a:solidFill>
-                  <a:srgbClr val="13294B"/>
-                </a:solidFill>
-              </a:rPr>
-              <a:t>SYSTEMS ENGINEERING</a:t>
-            </a:r>
-            <a:endParaRPr dirty="0"/>
-          </a:p>
-        </p:txBody>
-      </p:sp>
-      <p:grpSp>
-        <p:nvGrpSpPr>
-          <p:cNvPr id="155" name="Google Shape;155;p31"/>
-          <p:cNvGrpSpPr/>
-          <p:nvPr/>
-        </p:nvGrpSpPr>
-        <p:grpSpPr>
-          <a:xfrm>
-            <a:off x="4066674" y="6601537"/>
-            <a:ext cx="5233412" cy="70446"/>
-            <a:chOff x="4033424" y="6601537"/>
-            <a:chExt cx="5233412" cy="70446"/>
-          </a:xfrm>
-        </p:grpSpPr>
-        <p:cxnSp>
-          <p:nvCxnSpPr>
-            <p:cNvPr id="156" name="Google Shape;156;p31"/>
-            <p:cNvCxnSpPr/>
-            <p:nvPr/>
-          </p:nvCxnSpPr>
-          <p:spPr>
-            <a:xfrm rot="10800000">
-              <a:off x="4033424" y="6639606"/>
-              <a:ext cx="5164651" cy="0"/>
-            </a:xfrm>
-            <a:prstGeom prst="straightConnector1">
-              <a:avLst/>
-            </a:prstGeom>
-            <a:noFill/>
-            <a:ln w="9525" cap="flat" cmpd="sng">
-              <a:solidFill>
-                <a:srgbClr val="13294B"/>
-              </a:solidFill>
-              <a:prstDash val="solid"/>
-              <a:round/>
-              <a:headEnd type="none" w="sm" len="sm"/>
-              <a:tailEnd type="none" w="sm" len="sm"/>
-            </a:ln>
-          </p:spPr>
-        </p:cxnSp>
-        <p:sp>
-          <p:nvSpPr>
-            <p:cNvPr id="157" name="Google Shape;157;p31"/>
             <p:cNvSpPr/>
             <p:nvPr/>
           </p:nvSpPr>

</xml_diff>

<commit_message>
Incremental Build at 2026-03-25 21:26:59
</commit_message>
<xml_diff>
--- a/Lectures/Slides/L18.pptx
+++ b/Lectures/Slides/L18.pptx
@@ -5,7 +5,7 @@
     <p:sldMasterId id="2147483648" r:id="rId1"/>
   </p:sldMasterIdLst>
   <p:notesMasterIdLst>
-    <p:notesMasterId r:id="rId22"/>
+    <p:notesMasterId r:id="rId23"/>
   </p:notesMasterIdLst>
   <p:sldIdLst>
     <p:sldId id="256" r:id="rId2"/>
@@ -14,20 +14,21 @@
     <p:sldId id="272" r:id="rId5"/>
     <p:sldId id="258" r:id="rId6"/>
     <p:sldId id="418" r:id="rId7"/>
-    <p:sldId id="259" r:id="rId8"/>
-    <p:sldId id="260" r:id="rId9"/>
-    <p:sldId id="261" r:id="rId10"/>
-    <p:sldId id="262" r:id="rId11"/>
-    <p:sldId id="263" r:id="rId12"/>
-    <p:sldId id="264" r:id="rId13"/>
-    <p:sldId id="265" r:id="rId14"/>
-    <p:sldId id="266" r:id="rId15"/>
-    <p:sldId id="267" r:id="rId16"/>
-    <p:sldId id="268" r:id="rId17"/>
-    <p:sldId id="269" r:id="rId18"/>
-    <p:sldId id="257" r:id="rId19"/>
-    <p:sldId id="271" r:id="rId20"/>
-    <p:sldId id="270" r:id="rId21"/>
+    <p:sldId id="419" r:id="rId8"/>
+    <p:sldId id="259" r:id="rId9"/>
+    <p:sldId id="260" r:id="rId10"/>
+    <p:sldId id="261" r:id="rId11"/>
+    <p:sldId id="262" r:id="rId12"/>
+    <p:sldId id="263" r:id="rId13"/>
+    <p:sldId id="264" r:id="rId14"/>
+    <p:sldId id="265" r:id="rId15"/>
+    <p:sldId id="266" r:id="rId16"/>
+    <p:sldId id="267" r:id="rId17"/>
+    <p:sldId id="268" r:id="rId18"/>
+    <p:sldId id="269" r:id="rId19"/>
+    <p:sldId id="257" r:id="rId20"/>
+    <p:sldId id="271" r:id="rId21"/>
+    <p:sldId id="270" r:id="rId22"/>
   </p:sldIdLst>
   <p:sldSz cx="12192000" cy="6858000"/>
   <p:notesSz cx="6858000" cy="9144000"/>
@@ -265,7 +266,7 @@
       <p15:sldGuideLst xmlns:p15="http://schemas.microsoft.com/office/powerpoint/2012/main"/>
     </p:ext>
     <p:ext uri="http://customooxmlschemas.google.com/">
-      <go:slidesCustomData xmlns="" xmlns:mc="http://schemas.openxmlformats.org/markup-compatibility/2006" xmlns:mv="urn:schemas-microsoft-com:mac:vml" xmlns:c="http://schemas.openxmlformats.org/drawingml/2006/chart" xmlns:dgm="http://schemas.openxmlformats.org/drawingml/2006/diagram" xmlns:o="urn:schemas-microsoft-com:office:office" xmlns:v="urn:schemas-microsoft-com:vml" xmlns:pvml="urn:schemas-microsoft-com:office:powerpoint" xmlns:com="http://schemas.openxmlformats.org/drawingml/2006/compatibility" xmlns:p14="http://schemas.microsoft.com/office/powerpoint/2010/main" xmlns:p15="http://schemas.microsoft.com/office/powerpoint/2012/main" xmlns:ahyp="http://schemas.microsoft.com/office/drawing/2018/hyperlinkcolor" xmlns:go="http://customooxmlschemas.google.com/" r:id="rId23" roundtripDataSignature="AMtx7mjKkk5wOoQj6sDPPETbbKgHU96Dzg=="/>
+      <go:slidesCustomData xmlns:go="http://customooxmlschemas.google.com/" xmlns:ahyp="http://schemas.microsoft.com/office/drawing/2018/hyperlinkcolor" xmlns:p15="http://schemas.microsoft.com/office/powerpoint/2012/main" xmlns:p14="http://schemas.microsoft.com/office/powerpoint/2010/main" xmlns:com="http://schemas.openxmlformats.org/drawingml/2006/compatibility" xmlns:pvml="urn:schemas-microsoft-com:office:powerpoint" xmlns:v="urn:schemas-microsoft-com:vml" xmlns:o="urn:schemas-microsoft-com:office:office" xmlns:dgm="http://schemas.openxmlformats.org/drawingml/2006/diagram" xmlns:c="http://schemas.openxmlformats.org/drawingml/2006/chart" xmlns:mv="urn:schemas-microsoft-com:mac:vml" xmlns:mc="http://schemas.openxmlformats.org/markup-compatibility/2006" xmlns="" r:id="rId24" roundtripDataSignature="AMtx7mjKkk5wOoQj6sDPPETbbKgHU96Dzg=="/>
     </p:ext>
   </p:extLst>
 </p:presentation>
@@ -1833,6 +1834,110 @@
   <p:cSld>
     <p:spTree>
       <p:nvGrpSpPr>
+        <p:cNvPr id="1" name="Shape 141"/>
+        <p:cNvGrpSpPr/>
+        <p:nvPr/>
+      </p:nvGrpSpPr>
+      <p:grpSpPr>
+        <a:xfrm>
+          <a:off x="0" y="0"/>
+          <a:ext cx="0" cy="0"/>
+          <a:chOff x="0" y="0"/>
+          <a:chExt cx="0" cy="0"/>
+        </a:xfrm>
+      </p:grpSpPr>
+      <p:sp>
+        <p:nvSpPr>
+          <p:cNvPr id="142" name="Google Shape;142;p31:notes"/>
+          <p:cNvSpPr txBox="1">
+            <a:spLocks noGrp="1"/>
+          </p:cNvSpPr>
+          <p:nvPr>
+            <p:ph type="body" idx="1"/>
+          </p:nvPr>
+        </p:nvSpPr>
+        <p:spPr>
+          <a:xfrm>
+            <a:off x="685800" y="4400550"/>
+            <a:ext cx="5486400" cy="3600450"/>
+          </a:xfrm>
+          <a:prstGeom prst="rect">
+            <a:avLst/>
+          </a:prstGeom>
+        </p:spPr>
+        <p:txBody>
+          <a:bodyPr spcFirstLastPara="1" wrap="square" lIns="91425" tIns="45700" rIns="91425" bIns="45700" anchor="t" anchorCtr="0">
+            <a:noAutofit/>
+          </a:bodyPr>
+          <a:lstStyle/>
+          <a:p>
+            <a:pPr marL="0" lvl="0" indent="0" algn="l" rtl="0">
+              <a:spcBef>
+                <a:spcPts val="0"/>
+              </a:spcBef>
+              <a:spcAft>
+                <a:spcPts val="0"/>
+              </a:spcAft>
+              <a:buNone/>
+            </a:pPr>
+            <a:endParaRPr/>
+          </a:p>
+        </p:txBody>
+      </p:sp>
+      <p:sp>
+        <p:nvSpPr>
+          <p:cNvPr id="143" name="Google Shape;143;p31:notes"/>
+          <p:cNvSpPr>
+            <a:spLocks noGrp="1" noRot="1" noChangeAspect="1"/>
+          </p:cNvSpPr>
+          <p:nvPr>
+            <p:ph type="sldImg" idx="2"/>
+          </p:nvPr>
+        </p:nvSpPr>
+        <p:spPr>
+          <a:xfrm>
+            <a:off x="685800" y="1143000"/>
+            <a:ext cx="5486400" cy="3086100"/>
+          </a:xfrm>
+          <a:custGeom>
+            <a:avLst/>
+            <a:gdLst/>
+            <a:ahLst/>
+            <a:cxnLst/>
+            <a:rect l="l" t="t" r="r" b="b"/>
+            <a:pathLst>
+              <a:path w="120000" h="120000" extrusionOk="0">
+                <a:moveTo>
+                  <a:pt x="0" y="0"/>
+                </a:moveTo>
+                <a:lnTo>
+                  <a:pt x="120000" y="0"/>
+                </a:lnTo>
+                <a:lnTo>
+                  <a:pt x="120000" y="120000"/>
+                </a:lnTo>
+                <a:lnTo>
+                  <a:pt x="0" y="120000"/>
+                </a:lnTo>
+                <a:close/>
+              </a:path>
+            </a:pathLst>
+          </a:custGeom>
+        </p:spPr>
+      </p:sp>
+    </p:spTree>
+  </p:cSld>
+  <p:clrMapOvr>
+    <a:masterClrMapping/>
+  </p:clrMapOvr>
+</p:notes>
+</file>
+
+<file path=ppt/notesSlides/notesSlide11.xml><?xml version="1.0" encoding="utf-8"?>
+<p:notes xmlns:a="http://schemas.openxmlformats.org/drawingml/2006/main" xmlns:r="http://schemas.openxmlformats.org/officeDocument/2006/relationships" xmlns:p="http://schemas.openxmlformats.org/presentationml/2006/main" showMasterSp="0" showMasterPhAnim="0">
+  <p:cSld>
+    <p:spTree>
+      <p:nvGrpSpPr>
         <p:cNvPr id="1" name="Shape 158"/>
         <p:cNvGrpSpPr/>
         <p:nvPr/>
@@ -1950,7 +2055,7 @@
 </p:notes>
 </file>
 
-<file path=ppt/notesSlides/notesSlide11.xml><?xml version="1.0" encoding="utf-8"?>
+<file path=ppt/notesSlides/notesSlide12.xml><?xml version="1.0" encoding="utf-8"?>
 <p:notes xmlns:a="http://schemas.openxmlformats.org/drawingml/2006/main" xmlns:r="http://schemas.openxmlformats.org/officeDocument/2006/relationships" xmlns:p="http://schemas.openxmlformats.org/presentationml/2006/main" showMasterSp="0" showMasterPhAnim="0">
   <p:cSld>
     <p:spTree>
@@ -2054,7 +2159,7 @@
 </p:notes>
 </file>
 
-<file path=ppt/notesSlides/notesSlide12.xml><?xml version="1.0" encoding="utf-8"?>
+<file path=ppt/notesSlides/notesSlide13.xml><?xml version="1.0" encoding="utf-8"?>
 <p:notes xmlns:a="http://schemas.openxmlformats.org/drawingml/2006/main" xmlns:r="http://schemas.openxmlformats.org/officeDocument/2006/relationships" xmlns:p="http://schemas.openxmlformats.org/presentationml/2006/main" showMasterSp="0" showMasterPhAnim="0">
   <p:cSld>
     <p:spTree>
@@ -2158,7 +2263,7 @@
 </p:notes>
 </file>
 
-<file path=ppt/notesSlides/notesSlide13.xml><?xml version="1.0" encoding="utf-8"?>
+<file path=ppt/notesSlides/notesSlide14.xml><?xml version="1.0" encoding="utf-8"?>
 <p:notes xmlns:a="http://schemas.openxmlformats.org/drawingml/2006/main" xmlns:r="http://schemas.openxmlformats.org/officeDocument/2006/relationships" xmlns:p="http://schemas.openxmlformats.org/presentationml/2006/main" showMasterSp="0" showMasterPhAnim="0">
   <p:cSld>
     <p:spTree>
@@ -2280,7 +2385,7 @@
 </p:notes>
 </file>
 
-<file path=ppt/notesSlides/notesSlide14.xml><?xml version="1.0" encoding="utf-8"?>
+<file path=ppt/notesSlides/notesSlide15.xml><?xml version="1.0" encoding="utf-8"?>
 <p:notes xmlns:a="http://schemas.openxmlformats.org/drawingml/2006/main" xmlns:r="http://schemas.openxmlformats.org/officeDocument/2006/relationships" xmlns:p="http://schemas.openxmlformats.org/presentationml/2006/main" showMasterSp="0" showMasterPhAnim="0">
   <p:cSld>
     <p:spTree>
@@ -2384,7 +2489,7 @@
 </p:notes>
 </file>
 
-<file path=ppt/notesSlides/notesSlide15.xml><?xml version="1.0" encoding="utf-8"?>
+<file path=ppt/notesSlides/notesSlide16.xml><?xml version="1.0" encoding="utf-8"?>
 <p:notes xmlns:a="http://schemas.openxmlformats.org/drawingml/2006/main" xmlns:r="http://schemas.openxmlformats.org/officeDocument/2006/relationships" xmlns:p="http://schemas.openxmlformats.org/presentationml/2006/main" showMasterSp="0" showMasterPhAnim="0">
   <p:cSld>
     <p:spTree>
@@ -2488,7 +2593,7 @@
 </p:notes>
 </file>
 
-<file path=ppt/notesSlides/notesSlide16.xml><?xml version="1.0" encoding="utf-8"?>
+<file path=ppt/notesSlides/notesSlide17.xml><?xml version="1.0" encoding="utf-8"?>
 <p:notes xmlns:a="http://schemas.openxmlformats.org/drawingml/2006/main" xmlns:r="http://schemas.openxmlformats.org/officeDocument/2006/relationships" xmlns:p="http://schemas.openxmlformats.org/presentationml/2006/main" showMasterSp="0" showMasterPhAnim="0">
   <p:cSld>
     <p:spTree>
@@ -2592,7 +2697,7 @@
 </p:notes>
 </file>
 
-<file path=ppt/notesSlides/notesSlide17.xml><?xml version="1.0" encoding="utf-8"?>
+<file path=ppt/notesSlides/notesSlide18.xml><?xml version="1.0" encoding="utf-8"?>
 <p:notes xmlns:a="http://schemas.openxmlformats.org/drawingml/2006/main" xmlns:r="http://schemas.openxmlformats.org/officeDocument/2006/relationships" xmlns:p="http://schemas.openxmlformats.org/presentationml/2006/main" showMasterSp="0" showMasterPhAnim="0">
   <p:cSld>
     <p:spTree>
@@ -2696,7 +2801,7 @@
 </p:notes>
 </file>
 
-<file path=ppt/notesSlides/notesSlide18.xml><?xml version="1.0" encoding="utf-8"?>
+<file path=ppt/notesSlides/notesSlide19.xml><?xml version="1.0" encoding="utf-8"?>
 <p:notes xmlns:a="http://schemas.openxmlformats.org/drawingml/2006/main" xmlns:r="http://schemas.openxmlformats.org/officeDocument/2006/relationships" xmlns:p="http://schemas.openxmlformats.org/presentationml/2006/main" showMasterSp="0" showMasterPhAnim="0">
   <p:cSld>
     <p:spTree>
@@ -2793,133 +2898,6 @@
         </p:spPr>
       </p:sp>
     </p:spTree>
-  </p:cSld>
-  <p:clrMapOvr>
-    <a:masterClrMapping/>
-  </p:clrMapOvr>
-</p:notes>
-</file>
-
-<file path=ppt/notesSlides/notesSlide19.xml><?xml version="1.0" encoding="utf-8"?>
-<p:notes xmlns:a="http://schemas.openxmlformats.org/drawingml/2006/main" xmlns:r="http://schemas.openxmlformats.org/officeDocument/2006/relationships" xmlns:p="http://schemas.openxmlformats.org/presentationml/2006/main" showMasterSp="0" showMasterPhAnim="0">
-  <p:cSld>
-    <p:spTree>
-      <p:nvGrpSpPr>
-        <p:cNvPr id="1" name="Shape 260">
-          <a:extLst>
-            <a:ext uri="{FF2B5EF4-FFF2-40B4-BE49-F238E27FC236}">
-              <a16:creationId xmlns:a16="http://schemas.microsoft.com/office/drawing/2014/main" id="{ED6D95D0-49C4-BE65-6DB0-A8408AD9A1A2}"/>
-            </a:ext>
-          </a:extLst>
-        </p:cNvPr>
-        <p:cNvGrpSpPr/>
-        <p:nvPr/>
-      </p:nvGrpSpPr>
-      <p:grpSpPr>
-        <a:xfrm>
-          <a:off x="0" y="0"/>
-          <a:ext cx="0" cy="0"/>
-          <a:chOff x="0" y="0"/>
-          <a:chExt cx="0" cy="0"/>
-        </a:xfrm>
-      </p:grpSpPr>
-      <p:sp>
-        <p:nvSpPr>
-          <p:cNvPr id="261" name="Google Shape;261;p37:notes">
-            <a:extLst>
-              <a:ext uri="{FF2B5EF4-FFF2-40B4-BE49-F238E27FC236}">
-                <a16:creationId xmlns:a16="http://schemas.microsoft.com/office/drawing/2014/main" id="{D5BF9D20-A937-E031-5ACD-4B566F245A56}"/>
-              </a:ext>
-            </a:extLst>
-          </p:cNvPr>
-          <p:cNvSpPr txBox="1">
-            <a:spLocks noGrp="1"/>
-          </p:cNvSpPr>
-          <p:nvPr>
-            <p:ph type="body" idx="1"/>
-          </p:nvPr>
-        </p:nvSpPr>
-        <p:spPr>
-          <a:xfrm>
-            <a:off x="685800" y="4400550"/>
-            <a:ext cx="5486400" cy="3600450"/>
-          </a:xfrm>
-          <a:prstGeom prst="rect">
-            <a:avLst/>
-          </a:prstGeom>
-        </p:spPr>
-        <p:txBody>
-          <a:bodyPr spcFirstLastPara="1" wrap="square" lIns="91425" tIns="45700" rIns="91425" bIns="45700" anchor="t" anchorCtr="0">
-            <a:noAutofit/>
-          </a:bodyPr>
-          <a:lstStyle/>
-          <a:p>
-            <a:pPr marL="0" lvl="0" indent="0" algn="l" rtl="0">
-              <a:spcBef>
-                <a:spcPts val="0"/>
-              </a:spcBef>
-              <a:spcAft>
-                <a:spcPts val="0"/>
-              </a:spcAft>
-              <a:buNone/>
-            </a:pPr>
-            <a:endParaRPr/>
-          </a:p>
-        </p:txBody>
-      </p:sp>
-      <p:sp>
-        <p:nvSpPr>
-          <p:cNvPr id="262" name="Google Shape;262;p37:notes">
-            <a:extLst>
-              <a:ext uri="{FF2B5EF4-FFF2-40B4-BE49-F238E27FC236}">
-                <a16:creationId xmlns:a16="http://schemas.microsoft.com/office/drawing/2014/main" id="{1666A96F-D523-1F0C-00D5-14D5F35E2C2F}"/>
-              </a:ext>
-            </a:extLst>
-          </p:cNvPr>
-          <p:cNvSpPr>
-            <a:spLocks noGrp="1" noRot="1" noChangeAspect="1"/>
-          </p:cNvSpPr>
-          <p:nvPr>
-            <p:ph type="sldImg" idx="2"/>
-          </p:nvPr>
-        </p:nvSpPr>
-        <p:spPr>
-          <a:xfrm>
-            <a:off x="685800" y="1143000"/>
-            <a:ext cx="5486400" cy="3086100"/>
-          </a:xfrm>
-          <a:custGeom>
-            <a:avLst/>
-            <a:gdLst/>
-            <a:ahLst/>
-            <a:cxnLst/>
-            <a:rect l="l" t="t" r="r" b="b"/>
-            <a:pathLst>
-              <a:path w="120000" h="120000" extrusionOk="0">
-                <a:moveTo>
-                  <a:pt x="0" y="0"/>
-                </a:moveTo>
-                <a:lnTo>
-                  <a:pt x="120000" y="0"/>
-                </a:lnTo>
-                <a:lnTo>
-                  <a:pt x="120000" y="120000"/>
-                </a:lnTo>
-                <a:lnTo>
-                  <a:pt x="0" y="120000"/>
-                </a:lnTo>
-                <a:close/>
-              </a:path>
-            </a:pathLst>
-          </a:custGeom>
-        </p:spPr>
-      </p:sp>
-    </p:spTree>
-    <p:extLst>
-      <p:ext uri="{BB962C8B-B14F-4D97-AF65-F5344CB8AC3E}">
-        <p14:creationId xmlns:p14="http://schemas.microsoft.com/office/powerpoint/2010/main" val="3888823651"/>
-      </p:ext>
-    </p:extLst>
   </p:cSld>
   <p:clrMapOvr>
     <a:masterClrMapping/>
@@ -3073,6 +3051,133 @@
 </file>
 
 <file path=ppt/notesSlides/notesSlide20.xml><?xml version="1.0" encoding="utf-8"?>
+<p:notes xmlns:a="http://schemas.openxmlformats.org/drawingml/2006/main" xmlns:r="http://schemas.openxmlformats.org/officeDocument/2006/relationships" xmlns:p="http://schemas.openxmlformats.org/presentationml/2006/main" showMasterSp="0" showMasterPhAnim="0">
+  <p:cSld>
+    <p:spTree>
+      <p:nvGrpSpPr>
+        <p:cNvPr id="1" name="Shape 260">
+          <a:extLst>
+            <a:ext uri="{FF2B5EF4-FFF2-40B4-BE49-F238E27FC236}">
+              <a16:creationId xmlns:a16="http://schemas.microsoft.com/office/drawing/2014/main" id="{ED6D95D0-49C4-BE65-6DB0-A8408AD9A1A2}"/>
+            </a:ext>
+          </a:extLst>
+        </p:cNvPr>
+        <p:cNvGrpSpPr/>
+        <p:nvPr/>
+      </p:nvGrpSpPr>
+      <p:grpSpPr>
+        <a:xfrm>
+          <a:off x="0" y="0"/>
+          <a:ext cx="0" cy="0"/>
+          <a:chOff x="0" y="0"/>
+          <a:chExt cx="0" cy="0"/>
+        </a:xfrm>
+      </p:grpSpPr>
+      <p:sp>
+        <p:nvSpPr>
+          <p:cNvPr id="261" name="Google Shape;261;p37:notes">
+            <a:extLst>
+              <a:ext uri="{FF2B5EF4-FFF2-40B4-BE49-F238E27FC236}">
+                <a16:creationId xmlns:a16="http://schemas.microsoft.com/office/drawing/2014/main" id="{D5BF9D20-A937-E031-5ACD-4B566F245A56}"/>
+              </a:ext>
+            </a:extLst>
+          </p:cNvPr>
+          <p:cNvSpPr txBox="1">
+            <a:spLocks noGrp="1"/>
+          </p:cNvSpPr>
+          <p:nvPr>
+            <p:ph type="body" idx="1"/>
+          </p:nvPr>
+        </p:nvSpPr>
+        <p:spPr>
+          <a:xfrm>
+            <a:off x="685800" y="4400550"/>
+            <a:ext cx="5486400" cy="3600450"/>
+          </a:xfrm>
+          <a:prstGeom prst="rect">
+            <a:avLst/>
+          </a:prstGeom>
+        </p:spPr>
+        <p:txBody>
+          <a:bodyPr spcFirstLastPara="1" wrap="square" lIns="91425" tIns="45700" rIns="91425" bIns="45700" anchor="t" anchorCtr="0">
+            <a:noAutofit/>
+          </a:bodyPr>
+          <a:lstStyle/>
+          <a:p>
+            <a:pPr marL="0" lvl="0" indent="0" algn="l" rtl="0">
+              <a:spcBef>
+                <a:spcPts val="0"/>
+              </a:spcBef>
+              <a:spcAft>
+                <a:spcPts val="0"/>
+              </a:spcAft>
+              <a:buNone/>
+            </a:pPr>
+            <a:endParaRPr/>
+          </a:p>
+        </p:txBody>
+      </p:sp>
+      <p:sp>
+        <p:nvSpPr>
+          <p:cNvPr id="262" name="Google Shape;262;p37:notes">
+            <a:extLst>
+              <a:ext uri="{FF2B5EF4-FFF2-40B4-BE49-F238E27FC236}">
+                <a16:creationId xmlns:a16="http://schemas.microsoft.com/office/drawing/2014/main" id="{1666A96F-D523-1F0C-00D5-14D5F35E2C2F}"/>
+              </a:ext>
+            </a:extLst>
+          </p:cNvPr>
+          <p:cNvSpPr>
+            <a:spLocks noGrp="1" noRot="1" noChangeAspect="1"/>
+          </p:cNvSpPr>
+          <p:nvPr>
+            <p:ph type="sldImg" idx="2"/>
+          </p:nvPr>
+        </p:nvSpPr>
+        <p:spPr>
+          <a:xfrm>
+            <a:off x="685800" y="1143000"/>
+            <a:ext cx="5486400" cy="3086100"/>
+          </a:xfrm>
+          <a:custGeom>
+            <a:avLst/>
+            <a:gdLst/>
+            <a:ahLst/>
+            <a:cxnLst/>
+            <a:rect l="l" t="t" r="r" b="b"/>
+            <a:pathLst>
+              <a:path w="120000" h="120000" extrusionOk="0">
+                <a:moveTo>
+                  <a:pt x="0" y="0"/>
+                </a:moveTo>
+                <a:lnTo>
+                  <a:pt x="120000" y="0"/>
+                </a:lnTo>
+                <a:lnTo>
+                  <a:pt x="120000" y="120000"/>
+                </a:lnTo>
+                <a:lnTo>
+                  <a:pt x="0" y="120000"/>
+                </a:lnTo>
+                <a:close/>
+              </a:path>
+            </a:pathLst>
+          </a:custGeom>
+        </p:spPr>
+      </p:sp>
+    </p:spTree>
+    <p:extLst>
+      <p:ext uri="{BB962C8B-B14F-4D97-AF65-F5344CB8AC3E}">
+        <p14:creationId xmlns:p14="http://schemas.microsoft.com/office/powerpoint/2010/main" val="3888823651"/>
+      </p:ext>
+    </p:extLst>
+  </p:cSld>
+  <p:clrMapOvr>
+    <a:masterClrMapping/>
+  </p:clrMapOvr>
+</p:notes>
+</file>
+
+<file path=ppt/notesSlides/notesSlide21.xml><?xml version="1.0" encoding="utf-8"?>
 <p:notes xmlns:a="http://schemas.openxmlformats.org/drawingml/2006/main" xmlns:r="http://schemas.openxmlformats.org/officeDocument/2006/relationships" xmlns:p="http://schemas.openxmlformats.org/presentationml/2006/main" showMasterSp="0" showMasterPhAnim="0">
   <p:cSld>
     <p:spTree>
@@ -3702,6 +3807,151 @@
   <p:cSld>
     <p:spTree>
       <p:nvGrpSpPr>
+        <p:cNvPr id="1" name="Shape 114">
+          <a:extLst>
+            <a:ext uri="{FF2B5EF4-FFF2-40B4-BE49-F238E27FC236}">
+              <a16:creationId xmlns:a16="http://schemas.microsoft.com/office/drawing/2014/main" id="{9550EDD1-52CE-344C-711B-8FF6DF309E6C}"/>
+            </a:ext>
+          </a:extLst>
+        </p:cNvPr>
+        <p:cNvGrpSpPr/>
+        <p:nvPr/>
+      </p:nvGrpSpPr>
+      <p:grpSpPr>
+        <a:xfrm>
+          <a:off x="0" y="0"/>
+          <a:ext cx="0" cy="0"/>
+          <a:chOff x="0" y="0"/>
+          <a:chExt cx="0" cy="0"/>
+        </a:xfrm>
+      </p:grpSpPr>
+      <p:sp>
+        <p:nvSpPr>
+          <p:cNvPr id="115" name="Google Shape;115;p29:notes">
+            <a:extLst>
+              <a:ext uri="{FF2B5EF4-FFF2-40B4-BE49-F238E27FC236}">
+                <a16:creationId xmlns:a16="http://schemas.microsoft.com/office/drawing/2014/main" id="{6902D2D7-EFD8-0EDC-0AEB-B8C2846146F8}"/>
+              </a:ext>
+            </a:extLst>
+          </p:cNvPr>
+          <p:cNvSpPr txBox="1">
+            <a:spLocks noGrp="1"/>
+          </p:cNvSpPr>
+          <p:nvPr>
+            <p:ph type="body" idx="1"/>
+          </p:nvPr>
+        </p:nvSpPr>
+        <p:spPr>
+          <a:xfrm>
+            <a:off x="685800" y="4400550"/>
+            <a:ext cx="5486400" cy="3600450"/>
+          </a:xfrm>
+          <a:prstGeom prst="rect">
+            <a:avLst/>
+          </a:prstGeom>
+          <a:noFill/>
+          <a:ln>
+            <a:noFill/>
+          </a:ln>
+        </p:spPr>
+        <p:txBody>
+          <a:bodyPr spcFirstLastPara="1" wrap="square" lIns="91425" tIns="45700" rIns="91425" bIns="45700" anchor="t" anchorCtr="0">
+            <a:noAutofit/>
+          </a:bodyPr>
+          <a:lstStyle/>
+          <a:p>
+            <a:pPr marL="0" lvl="0" indent="0" algn="l" rtl="0">
+              <a:lnSpc>
+                <a:spcPct val="100000"/>
+              </a:lnSpc>
+              <a:spcBef>
+                <a:spcPts val="0"/>
+              </a:spcBef>
+              <a:spcAft>
+                <a:spcPts val="0"/>
+              </a:spcAft>
+              <a:buSzPts val="1400"/>
+              <a:buNone/>
+            </a:pPr>
+            <a:endParaRPr/>
+          </a:p>
+        </p:txBody>
+      </p:sp>
+      <p:sp>
+        <p:nvSpPr>
+          <p:cNvPr id="116" name="Google Shape;116;p29:notes">
+            <a:extLst>
+              <a:ext uri="{FF2B5EF4-FFF2-40B4-BE49-F238E27FC236}">
+                <a16:creationId xmlns:a16="http://schemas.microsoft.com/office/drawing/2014/main" id="{B6B1CB7C-3314-95B9-DC5D-93CAEF8FADAF}"/>
+              </a:ext>
+            </a:extLst>
+          </p:cNvPr>
+          <p:cNvSpPr>
+            <a:spLocks noGrp="1" noRot="1" noChangeAspect="1"/>
+          </p:cNvSpPr>
+          <p:nvPr>
+            <p:ph type="sldImg" idx="2"/>
+          </p:nvPr>
+        </p:nvSpPr>
+        <p:spPr>
+          <a:xfrm>
+            <a:off x="685800" y="1143000"/>
+            <a:ext cx="5486400" cy="3086100"/>
+          </a:xfrm>
+          <a:custGeom>
+            <a:avLst/>
+            <a:gdLst/>
+            <a:ahLst/>
+            <a:cxnLst/>
+            <a:rect l="l" t="t" r="r" b="b"/>
+            <a:pathLst>
+              <a:path w="120000" h="120000" extrusionOk="0">
+                <a:moveTo>
+                  <a:pt x="0" y="0"/>
+                </a:moveTo>
+                <a:lnTo>
+                  <a:pt x="120000" y="0"/>
+                </a:lnTo>
+                <a:lnTo>
+                  <a:pt x="120000" y="120000"/>
+                </a:lnTo>
+                <a:lnTo>
+                  <a:pt x="0" y="120000"/>
+                </a:lnTo>
+                <a:close/>
+              </a:path>
+            </a:pathLst>
+          </a:custGeom>
+          <a:noFill/>
+          <a:ln w="12700" cap="flat" cmpd="sng">
+            <a:solidFill>
+              <a:srgbClr val="000000"/>
+            </a:solidFill>
+            <a:prstDash val="solid"/>
+            <a:round/>
+            <a:headEnd type="none" w="sm" len="sm"/>
+            <a:tailEnd type="none" w="sm" len="sm"/>
+          </a:ln>
+        </p:spPr>
+      </p:sp>
+    </p:spTree>
+    <p:extLst>
+      <p:ext uri="{BB962C8B-B14F-4D97-AF65-F5344CB8AC3E}">
+        <p14:creationId xmlns:p14="http://schemas.microsoft.com/office/powerpoint/2010/main" val="2658891594"/>
+      </p:ext>
+    </p:extLst>
+  </p:cSld>
+  <p:clrMapOvr>
+    <a:masterClrMapping/>
+  </p:clrMapOvr>
+</p:notes>
+</file>
+
+<file path=ppt/notesSlides/notesSlide8.xml><?xml version="1.0" encoding="utf-8"?>
+<p:notes xmlns:a="http://schemas.openxmlformats.org/drawingml/2006/main" xmlns:r="http://schemas.openxmlformats.org/officeDocument/2006/relationships" xmlns:p="http://schemas.openxmlformats.org/presentationml/2006/main" showMasterSp="0" showMasterPhAnim="0">
+  <p:cSld>
+    <p:spTree>
+      <p:nvGrpSpPr>
         <p:cNvPr id="1" name="Shape 114"/>
         <p:cNvGrpSpPr/>
         <p:nvPr/>
@@ -3819,7 +4069,7 @@
 </p:notes>
 </file>
 
-<file path=ppt/notesSlides/notesSlide8.xml><?xml version="1.0" encoding="utf-8"?>
+<file path=ppt/notesSlides/notesSlide9.xml><?xml version="1.0" encoding="utf-8"?>
 <p:notes xmlns:a="http://schemas.openxmlformats.org/drawingml/2006/main" xmlns:r="http://schemas.openxmlformats.org/officeDocument/2006/relationships" xmlns:p="http://schemas.openxmlformats.org/presentationml/2006/main" showMasterSp="0" showMasterPhAnim="0">
   <p:cSld>
     <p:spTree>
@@ -3877,110 +4127,6 @@
       <p:sp>
         <p:nvSpPr>
           <p:cNvPr id="129" name="Google Shape;129;p30:notes"/>
-          <p:cNvSpPr>
-            <a:spLocks noGrp="1" noRot="1" noChangeAspect="1"/>
-          </p:cNvSpPr>
-          <p:nvPr>
-            <p:ph type="sldImg" idx="2"/>
-          </p:nvPr>
-        </p:nvSpPr>
-        <p:spPr>
-          <a:xfrm>
-            <a:off x="685800" y="1143000"/>
-            <a:ext cx="5486400" cy="3086100"/>
-          </a:xfrm>
-          <a:custGeom>
-            <a:avLst/>
-            <a:gdLst/>
-            <a:ahLst/>
-            <a:cxnLst/>
-            <a:rect l="l" t="t" r="r" b="b"/>
-            <a:pathLst>
-              <a:path w="120000" h="120000" extrusionOk="0">
-                <a:moveTo>
-                  <a:pt x="0" y="0"/>
-                </a:moveTo>
-                <a:lnTo>
-                  <a:pt x="120000" y="0"/>
-                </a:lnTo>
-                <a:lnTo>
-                  <a:pt x="120000" y="120000"/>
-                </a:lnTo>
-                <a:lnTo>
-                  <a:pt x="0" y="120000"/>
-                </a:lnTo>
-                <a:close/>
-              </a:path>
-            </a:pathLst>
-          </a:custGeom>
-        </p:spPr>
-      </p:sp>
-    </p:spTree>
-  </p:cSld>
-  <p:clrMapOvr>
-    <a:masterClrMapping/>
-  </p:clrMapOvr>
-</p:notes>
-</file>
-
-<file path=ppt/notesSlides/notesSlide9.xml><?xml version="1.0" encoding="utf-8"?>
-<p:notes xmlns:a="http://schemas.openxmlformats.org/drawingml/2006/main" xmlns:r="http://schemas.openxmlformats.org/officeDocument/2006/relationships" xmlns:p="http://schemas.openxmlformats.org/presentationml/2006/main" showMasterSp="0" showMasterPhAnim="0">
-  <p:cSld>
-    <p:spTree>
-      <p:nvGrpSpPr>
-        <p:cNvPr id="1" name="Shape 141"/>
-        <p:cNvGrpSpPr/>
-        <p:nvPr/>
-      </p:nvGrpSpPr>
-      <p:grpSpPr>
-        <a:xfrm>
-          <a:off x="0" y="0"/>
-          <a:ext cx="0" cy="0"/>
-          <a:chOff x="0" y="0"/>
-          <a:chExt cx="0" cy="0"/>
-        </a:xfrm>
-      </p:grpSpPr>
-      <p:sp>
-        <p:nvSpPr>
-          <p:cNvPr id="142" name="Google Shape;142;p31:notes"/>
-          <p:cNvSpPr txBox="1">
-            <a:spLocks noGrp="1"/>
-          </p:cNvSpPr>
-          <p:nvPr>
-            <p:ph type="body" idx="1"/>
-          </p:nvPr>
-        </p:nvSpPr>
-        <p:spPr>
-          <a:xfrm>
-            <a:off x="685800" y="4400550"/>
-            <a:ext cx="5486400" cy="3600450"/>
-          </a:xfrm>
-          <a:prstGeom prst="rect">
-            <a:avLst/>
-          </a:prstGeom>
-        </p:spPr>
-        <p:txBody>
-          <a:bodyPr spcFirstLastPara="1" wrap="square" lIns="91425" tIns="45700" rIns="91425" bIns="45700" anchor="t" anchorCtr="0">
-            <a:noAutofit/>
-          </a:bodyPr>
-          <a:lstStyle/>
-          <a:p>
-            <a:pPr marL="0" lvl="0" indent="0" algn="l" rtl="0">
-              <a:spcBef>
-                <a:spcPts val="0"/>
-              </a:spcBef>
-              <a:spcAft>
-                <a:spcPts val="0"/>
-              </a:spcAft>
-              <a:buNone/>
-            </a:pPr>
-            <a:endParaRPr/>
-          </a:p>
-        </p:txBody>
-      </p:sp>
-      <p:sp>
-        <p:nvSpPr>
-          <p:cNvPr id="143" name="Google Shape;143;p31:notes"/>
           <p:cNvSpPr>
             <a:spLocks noGrp="1" noRot="1" noChangeAspect="1"/>
           </p:cNvSpPr>
@@ -16594,6 +16740,845 @@
   <p:cSld>
     <p:spTree>
       <p:nvGrpSpPr>
+        <p:cNvPr id="1" name="Shape 144"/>
+        <p:cNvGrpSpPr/>
+        <p:nvPr/>
+      </p:nvGrpSpPr>
+      <p:grpSpPr>
+        <a:xfrm>
+          <a:off x="0" y="0"/>
+          <a:ext cx="0" cy="0"/>
+          <a:chOff x="0" y="0"/>
+          <a:chExt cx="0" cy="0"/>
+        </a:xfrm>
+      </p:grpSpPr>
+      <p:sp>
+        <p:nvSpPr>
+          <p:cNvPr id="145" name="Google Shape;145;p31"/>
+          <p:cNvSpPr/>
+          <p:nvPr/>
+        </p:nvSpPr>
+        <p:spPr>
+          <a:xfrm>
+            <a:off x="475566" y="1263717"/>
+            <a:ext cx="4356660" cy="2315647"/>
+          </a:xfrm>
+          <a:prstGeom prst="rect">
+            <a:avLst/>
+          </a:prstGeom>
+          <a:solidFill>
+            <a:srgbClr val="D8D8D8"/>
+          </a:solidFill>
+          <a:ln>
+            <a:noFill/>
+          </a:ln>
+        </p:spPr>
+        <p:txBody>
+          <a:bodyPr spcFirstLastPara="1" wrap="square" lIns="91425" tIns="45700" rIns="91425" bIns="45700" anchor="ctr" anchorCtr="0">
+            <a:noAutofit/>
+          </a:bodyPr>
+          <a:lstStyle/>
+          <a:p>
+            <a:pPr marL="0" marR="0" lvl="0" indent="0" algn="ctr" rtl="0">
+              <a:lnSpc>
+                <a:spcPct val="100000"/>
+              </a:lnSpc>
+              <a:spcBef>
+                <a:spcPts val="0"/>
+              </a:spcBef>
+              <a:spcAft>
+                <a:spcPts val="0"/>
+              </a:spcAft>
+              <a:buClr>
+                <a:srgbClr val="000000"/>
+              </a:buClr>
+              <a:buSzPts val="1800"/>
+              <a:buFont typeface="Arial"/>
+              <a:buNone/>
+            </a:pPr>
+            <a:endParaRPr sz="1800" b="0" i="0" u="none" strike="noStrike" cap="none">
+              <a:solidFill>
+                <a:schemeClr val="lt1"/>
+              </a:solidFill>
+              <a:latin typeface="Calibri"/>
+              <a:ea typeface="Calibri"/>
+              <a:cs typeface="Calibri"/>
+              <a:sym typeface="Calibri"/>
+            </a:endParaRPr>
+          </a:p>
+        </p:txBody>
+      </p:sp>
+      <p:sp>
+        <p:nvSpPr>
+          <p:cNvPr id="146" name="Google Shape;146;p31"/>
+          <p:cNvSpPr txBox="1"/>
+          <p:nvPr/>
+        </p:nvSpPr>
+        <p:spPr>
+          <a:xfrm>
+            <a:off x="1494115" y="2239572"/>
+            <a:ext cx="2280491" cy="369332"/>
+          </a:xfrm>
+          <a:prstGeom prst="rect">
+            <a:avLst/>
+          </a:prstGeom>
+          <a:noFill/>
+          <a:ln>
+            <a:noFill/>
+          </a:ln>
+        </p:spPr>
+        <p:txBody>
+          <a:bodyPr spcFirstLastPara="1" wrap="square" lIns="91425" tIns="45700" rIns="91425" bIns="45700" anchor="t" anchorCtr="0">
+            <a:spAutoFit/>
+          </a:bodyPr>
+          <a:lstStyle/>
+          <a:p>
+            <a:pPr marL="0" marR="0" lvl="0" indent="0" algn="ctr" rtl="0">
+              <a:lnSpc>
+                <a:spcPct val="100000"/>
+              </a:lnSpc>
+              <a:spcBef>
+                <a:spcPts val="0"/>
+              </a:spcBef>
+              <a:spcAft>
+                <a:spcPts val="0"/>
+              </a:spcAft>
+              <a:buClr>
+                <a:srgbClr val="000000"/>
+              </a:buClr>
+              <a:buSzPts val="1800"/>
+              <a:buFont typeface="Arial"/>
+              <a:buNone/>
+            </a:pPr>
+            <a:r>
+              <a:rPr lang="en-US" sz="1800" b="0" i="0" u="none" strike="noStrike" cap="none">
+                <a:solidFill>
+                  <a:srgbClr val="A5A5A5"/>
+                </a:solidFill>
+                <a:latin typeface="Arial"/>
+                <a:ea typeface="Arial"/>
+                <a:cs typeface="Arial"/>
+                <a:sym typeface="Arial"/>
+              </a:rPr>
+              <a:t>IMAGE / GRAPHIC</a:t>
+            </a:r>
+            <a:endParaRPr sz="1400" b="0" i="0" u="none" strike="noStrike" cap="none">
+              <a:solidFill>
+                <a:srgbClr val="000000"/>
+              </a:solidFill>
+              <a:latin typeface="Arial"/>
+              <a:ea typeface="Arial"/>
+              <a:cs typeface="Arial"/>
+              <a:sym typeface="Arial"/>
+            </a:endParaRPr>
+          </a:p>
+        </p:txBody>
+      </p:sp>
+      <p:sp>
+        <p:nvSpPr>
+          <p:cNvPr id="147" name="Google Shape;147;p31"/>
+          <p:cNvSpPr/>
+          <p:nvPr/>
+        </p:nvSpPr>
+        <p:spPr>
+          <a:xfrm>
+            <a:off x="475566" y="3774068"/>
+            <a:ext cx="4356660" cy="2315647"/>
+          </a:xfrm>
+          <a:prstGeom prst="rect">
+            <a:avLst/>
+          </a:prstGeom>
+          <a:solidFill>
+            <a:srgbClr val="D8D8D8"/>
+          </a:solidFill>
+          <a:ln>
+            <a:noFill/>
+          </a:ln>
+        </p:spPr>
+        <p:txBody>
+          <a:bodyPr spcFirstLastPara="1" wrap="square" lIns="91425" tIns="45700" rIns="91425" bIns="45700" anchor="ctr" anchorCtr="0">
+            <a:noAutofit/>
+          </a:bodyPr>
+          <a:lstStyle/>
+          <a:p>
+            <a:pPr marL="0" marR="0" lvl="0" indent="0" algn="ctr" rtl="0">
+              <a:lnSpc>
+                <a:spcPct val="100000"/>
+              </a:lnSpc>
+              <a:spcBef>
+                <a:spcPts val="0"/>
+              </a:spcBef>
+              <a:spcAft>
+                <a:spcPts val="0"/>
+              </a:spcAft>
+              <a:buClr>
+                <a:srgbClr val="000000"/>
+              </a:buClr>
+              <a:buSzPts val="1800"/>
+              <a:buFont typeface="Arial"/>
+              <a:buNone/>
+            </a:pPr>
+            <a:endParaRPr sz="1800" b="0" i="0" u="none" strike="noStrike" cap="none">
+              <a:solidFill>
+                <a:schemeClr val="lt1"/>
+              </a:solidFill>
+              <a:latin typeface="Calibri"/>
+              <a:ea typeface="Calibri"/>
+              <a:cs typeface="Calibri"/>
+              <a:sym typeface="Calibri"/>
+            </a:endParaRPr>
+          </a:p>
+        </p:txBody>
+      </p:sp>
+      <p:sp>
+        <p:nvSpPr>
+          <p:cNvPr id="148" name="Google Shape;148;p31"/>
+          <p:cNvSpPr txBox="1"/>
+          <p:nvPr/>
+        </p:nvSpPr>
+        <p:spPr>
+          <a:xfrm>
+            <a:off x="1494115" y="4747225"/>
+            <a:ext cx="2280491" cy="369332"/>
+          </a:xfrm>
+          <a:prstGeom prst="rect">
+            <a:avLst/>
+          </a:prstGeom>
+          <a:noFill/>
+          <a:ln>
+            <a:noFill/>
+          </a:ln>
+        </p:spPr>
+        <p:txBody>
+          <a:bodyPr spcFirstLastPara="1" wrap="square" lIns="91425" tIns="45700" rIns="91425" bIns="45700" anchor="t" anchorCtr="0">
+            <a:spAutoFit/>
+          </a:bodyPr>
+          <a:lstStyle/>
+          <a:p>
+            <a:pPr marL="0" marR="0" lvl="0" indent="0" algn="ctr" rtl="0">
+              <a:lnSpc>
+                <a:spcPct val="100000"/>
+              </a:lnSpc>
+              <a:spcBef>
+                <a:spcPts val="0"/>
+              </a:spcBef>
+              <a:spcAft>
+                <a:spcPts val="0"/>
+              </a:spcAft>
+              <a:buClr>
+                <a:srgbClr val="000000"/>
+              </a:buClr>
+              <a:buSzPts val="1800"/>
+              <a:buFont typeface="Arial"/>
+              <a:buNone/>
+            </a:pPr>
+            <a:r>
+              <a:rPr lang="en-US" sz="1800" b="0" i="0" u="none" strike="noStrike" cap="none">
+                <a:solidFill>
+                  <a:srgbClr val="A5A5A5"/>
+                </a:solidFill>
+                <a:latin typeface="Arial"/>
+                <a:ea typeface="Arial"/>
+                <a:cs typeface="Arial"/>
+                <a:sym typeface="Arial"/>
+              </a:rPr>
+              <a:t>IMAGE / GRAPHIC</a:t>
+            </a:r>
+            <a:endParaRPr sz="1400" b="0" i="0" u="none" strike="noStrike" cap="none">
+              <a:solidFill>
+                <a:srgbClr val="000000"/>
+              </a:solidFill>
+              <a:latin typeface="Arial"/>
+              <a:ea typeface="Arial"/>
+              <a:cs typeface="Arial"/>
+              <a:sym typeface="Arial"/>
+            </a:endParaRPr>
+          </a:p>
+        </p:txBody>
+      </p:sp>
+      <p:sp>
+        <p:nvSpPr>
+          <p:cNvPr id="149" name="Google Shape;149;p31"/>
+          <p:cNvSpPr txBox="1"/>
+          <p:nvPr/>
+        </p:nvSpPr>
+        <p:spPr>
+          <a:xfrm>
+            <a:off x="5122548" y="1334279"/>
+            <a:ext cx="6686464" cy="4821102"/>
+          </a:xfrm>
+          <a:prstGeom prst="rect">
+            <a:avLst/>
+          </a:prstGeom>
+          <a:noFill/>
+          <a:ln>
+            <a:noFill/>
+          </a:ln>
+        </p:spPr>
+        <p:txBody>
+          <a:bodyPr spcFirstLastPara="1" wrap="square" lIns="91425" tIns="45700" rIns="91425" bIns="45700" anchor="t" anchorCtr="0">
+            <a:noAutofit/>
+          </a:bodyPr>
+          <a:lstStyle/>
+          <a:p>
+            <a:pPr marL="0" marR="0" lvl="0" indent="0" algn="l" rtl="0">
+              <a:lnSpc>
+                <a:spcPct val="100000"/>
+              </a:lnSpc>
+              <a:spcBef>
+                <a:spcPts val="0"/>
+              </a:spcBef>
+              <a:spcAft>
+                <a:spcPts val="0"/>
+              </a:spcAft>
+              <a:buNone/>
+            </a:pPr>
+            <a:r>
+              <a:rPr lang="en-US" sz="2600" b="1" i="0" u="none" strike="noStrike" cap="none">
+                <a:solidFill>
+                  <a:srgbClr val="E84B36"/>
+                </a:solidFill>
+                <a:latin typeface="Arial"/>
+                <a:ea typeface="Arial"/>
+                <a:cs typeface="Arial"/>
+                <a:sym typeface="Arial"/>
+              </a:rPr>
+              <a:t>Lorem Ipsum Dolor Sit Amet Consectetur Adipiscing</a:t>
+            </a:r>
+            <a:endParaRPr sz="2600" b="1" i="0" u="none" strike="noStrike" cap="none">
+              <a:solidFill>
+                <a:srgbClr val="E84B36"/>
+              </a:solidFill>
+              <a:latin typeface="Arial"/>
+              <a:ea typeface="Arial"/>
+              <a:cs typeface="Arial"/>
+              <a:sym typeface="Arial"/>
+            </a:endParaRPr>
+          </a:p>
+          <a:p>
+            <a:pPr marL="0" marR="0" lvl="0" indent="0" algn="l" rtl="0">
+              <a:lnSpc>
+                <a:spcPct val="100000"/>
+              </a:lnSpc>
+              <a:spcBef>
+                <a:spcPts val="0"/>
+              </a:spcBef>
+              <a:spcAft>
+                <a:spcPts val="0"/>
+              </a:spcAft>
+              <a:buNone/>
+            </a:pPr>
+            <a:endParaRPr sz="1800" b="0" i="0" u="none" strike="noStrike" cap="none">
+              <a:solidFill>
+                <a:schemeClr val="dk1"/>
+              </a:solidFill>
+              <a:latin typeface="Arial"/>
+              <a:ea typeface="Arial"/>
+              <a:cs typeface="Arial"/>
+              <a:sym typeface="Arial"/>
+            </a:endParaRPr>
+          </a:p>
+          <a:p>
+            <a:pPr marL="0" marR="0" lvl="0" indent="0" algn="l" rtl="0">
+              <a:lnSpc>
+                <a:spcPct val="100000"/>
+              </a:lnSpc>
+              <a:spcBef>
+                <a:spcPts val="0"/>
+              </a:spcBef>
+              <a:spcAft>
+                <a:spcPts val="0"/>
+              </a:spcAft>
+              <a:buNone/>
+            </a:pPr>
+            <a:r>
+              <a:rPr lang="en-US" sz="1800" b="0" i="0" u="none" strike="noStrike" cap="none">
+                <a:solidFill>
+                  <a:srgbClr val="000000"/>
+                </a:solidFill>
+                <a:latin typeface="Arial"/>
+                <a:ea typeface="Arial"/>
+                <a:cs typeface="Arial"/>
+                <a:sym typeface="Arial"/>
+              </a:rPr>
+              <a:t>Lorem ipsum dolor sit amet, consectetur adipiscing elit, sed do eiusmod tempor incididunt ut labore et dolore magna aliqua. Ut enim ad minim veniam, quis nostrud exercitation ullamco laboris nisi ut aliquip ex ea commodo consequat. </a:t>
+            </a:r>
+            <a:endParaRPr/>
+          </a:p>
+          <a:p>
+            <a:pPr marL="0" marR="0" lvl="0" indent="0" algn="l" rtl="0">
+              <a:lnSpc>
+                <a:spcPct val="100000"/>
+              </a:lnSpc>
+              <a:spcBef>
+                <a:spcPts val="0"/>
+              </a:spcBef>
+              <a:spcAft>
+                <a:spcPts val="0"/>
+              </a:spcAft>
+              <a:buNone/>
+            </a:pPr>
+            <a:endParaRPr sz="1800" b="0" i="0" u="none" strike="noStrike" cap="none">
+              <a:solidFill>
+                <a:schemeClr val="dk1"/>
+              </a:solidFill>
+              <a:latin typeface="Arial"/>
+              <a:ea typeface="Arial"/>
+              <a:cs typeface="Arial"/>
+              <a:sym typeface="Arial"/>
+            </a:endParaRPr>
+          </a:p>
+          <a:p>
+            <a:pPr marL="0" marR="0" lvl="0" indent="0" algn="l" rtl="0">
+              <a:lnSpc>
+                <a:spcPct val="100000"/>
+              </a:lnSpc>
+              <a:spcBef>
+                <a:spcPts val="0"/>
+              </a:spcBef>
+              <a:spcAft>
+                <a:spcPts val="0"/>
+              </a:spcAft>
+              <a:buNone/>
+            </a:pPr>
+            <a:r>
+              <a:rPr lang="en-US" sz="2000" b="1" i="0" u="none" strike="noStrike" cap="none">
+                <a:solidFill>
+                  <a:srgbClr val="15264B"/>
+                </a:solidFill>
+                <a:latin typeface="Arial"/>
+                <a:ea typeface="Arial"/>
+                <a:cs typeface="Arial"/>
+                <a:sym typeface="Arial"/>
+              </a:rPr>
+              <a:t>Lorem Ipsum Dolor Sit Amet Consectetur Adipiscing</a:t>
+            </a:r>
+            <a:endParaRPr sz="2000" b="1" i="0" u="none" strike="noStrike" cap="none">
+              <a:solidFill>
+                <a:srgbClr val="15264B"/>
+              </a:solidFill>
+              <a:latin typeface="Arial"/>
+              <a:ea typeface="Arial"/>
+              <a:cs typeface="Arial"/>
+              <a:sym typeface="Arial"/>
+            </a:endParaRPr>
+          </a:p>
+          <a:p>
+            <a:pPr marL="0" marR="0" lvl="0" indent="0" algn="l" rtl="0">
+              <a:lnSpc>
+                <a:spcPct val="100000"/>
+              </a:lnSpc>
+              <a:spcBef>
+                <a:spcPts val="0"/>
+              </a:spcBef>
+              <a:spcAft>
+                <a:spcPts val="0"/>
+              </a:spcAft>
+              <a:buNone/>
+            </a:pPr>
+            <a:endParaRPr sz="1800" b="1" i="0" u="none" strike="noStrike" cap="none">
+              <a:solidFill>
+                <a:schemeClr val="dk1"/>
+              </a:solidFill>
+              <a:latin typeface="Arial"/>
+              <a:ea typeface="Arial"/>
+              <a:cs typeface="Arial"/>
+              <a:sym typeface="Arial"/>
+            </a:endParaRPr>
+          </a:p>
+          <a:p>
+            <a:pPr marL="0" marR="0" lvl="0" indent="0" algn="l" rtl="0">
+              <a:lnSpc>
+                <a:spcPct val="100000"/>
+              </a:lnSpc>
+              <a:spcBef>
+                <a:spcPts val="0"/>
+              </a:spcBef>
+              <a:spcAft>
+                <a:spcPts val="0"/>
+              </a:spcAft>
+              <a:buNone/>
+            </a:pPr>
+            <a:r>
+              <a:rPr lang="en-US" sz="1800" b="0" i="0" u="none" strike="noStrike" cap="none">
+                <a:solidFill>
+                  <a:srgbClr val="000000"/>
+                </a:solidFill>
+                <a:latin typeface="Arial"/>
+                <a:ea typeface="Arial"/>
+                <a:cs typeface="Arial"/>
+                <a:sym typeface="Arial"/>
+              </a:rPr>
+              <a:t>Lorem ipsum dolor sit amet, consectetur adipiscing elit, sed do eiusmod tempor incididunt ut labore et dolore magna aliqua.</a:t>
+            </a:r>
+            <a:endParaRPr sz="1800" b="1" i="0" u="none" strike="noStrike" cap="none">
+              <a:solidFill>
+                <a:schemeClr val="dk1"/>
+              </a:solidFill>
+              <a:latin typeface="Arial"/>
+              <a:ea typeface="Arial"/>
+              <a:cs typeface="Arial"/>
+              <a:sym typeface="Arial"/>
+            </a:endParaRPr>
+          </a:p>
+        </p:txBody>
+      </p:sp>
+      <p:sp>
+        <p:nvSpPr>
+          <p:cNvPr id="150" name="Google Shape;150;p31"/>
+          <p:cNvSpPr/>
+          <p:nvPr/>
+        </p:nvSpPr>
+        <p:spPr>
+          <a:xfrm rot="10800000" flipH="1">
+            <a:off x="0" y="0"/>
+            <a:ext cx="12192000" cy="868220"/>
+          </a:xfrm>
+          <a:prstGeom prst="rect">
+            <a:avLst/>
+          </a:prstGeom>
+          <a:solidFill>
+            <a:srgbClr val="13294B"/>
+          </a:solidFill>
+          <a:ln>
+            <a:noFill/>
+          </a:ln>
+        </p:spPr>
+        <p:txBody>
+          <a:bodyPr spcFirstLastPara="1" wrap="square" lIns="91425" tIns="45700" rIns="91425" bIns="45700" anchor="ctr" anchorCtr="0">
+            <a:noAutofit/>
+          </a:bodyPr>
+          <a:lstStyle/>
+          <a:p>
+            <a:pPr marL="0" marR="0" lvl="0" indent="0" algn="ctr" rtl="0">
+              <a:lnSpc>
+                <a:spcPct val="100000"/>
+              </a:lnSpc>
+              <a:spcBef>
+                <a:spcPts val="0"/>
+              </a:spcBef>
+              <a:spcAft>
+                <a:spcPts val="0"/>
+              </a:spcAft>
+              <a:buClr>
+                <a:schemeClr val="lt1"/>
+              </a:buClr>
+              <a:buSzPts val="1800"/>
+              <a:buFont typeface="Calibri"/>
+              <a:buNone/>
+            </a:pPr>
+            <a:endParaRPr sz="1800" b="0" i="0" u="none" strike="noStrike" cap="none">
+              <a:solidFill>
+                <a:srgbClr val="13294B"/>
+              </a:solidFill>
+              <a:latin typeface="Calibri"/>
+              <a:ea typeface="Calibri"/>
+              <a:cs typeface="Calibri"/>
+              <a:sym typeface="Calibri"/>
+            </a:endParaRPr>
+          </a:p>
+        </p:txBody>
+      </p:sp>
+      <p:sp>
+        <p:nvSpPr>
+          <p:cNvPr id="151" name="Google Shape;151;p31"/>
+          <p:cNvSpPr txBox="1"/>
+          <p:nvPr/>
+        </p:nvSpPr>
+        <p:spPr>
+          <a:xfrm>
+            <a:off x="376810" y="204051"/>
+            <a:ext cx="10910026" cy="461624"/>
+          </a:xfrm>
+          <a:prstGeom prst="rect">
+            <a:avLst/>
+          </a:prstGeom>
+          <a:noFill/>
+          <a:ln>
+            <a:noFill/>
+          </a:ln>
+        </p:spPr>
+        <p:txBody>
+          <a:bodyPr spcFirstLastPara="1" wrap="square" lIns="91425" tIns="45700" rIns="91425" bIns="45700" anchor="t" anchorCtr="0">
+            <a:spAutoFit/>
+          </a:bodyPr>
+          <a:lstStyle/>
+          <a:p>
+            <a:pPr marL="0" marR="0" lvl="0" indent="0" algn="l" rtl="0">
+              <a:lnSpc>
+                <a:spcPct val="100000"/>
+              </a:lnSpc>
+              <a:spcBef>
+                <a:spcPts val="0"/>
+              </a:spcBef>
+              <a:spcAft>
+                <a:spcPts val="0"/>
+              </a:spcAft>
+              <a:buClr>
+                <a:srgbClr val="000000"/>
+              </a:buClr>
+              <a:buSzPts val="2400"/>
+              <a:buFont typeface="Arial"/>
+              <a:buNone/>
+            </a:pPr>
+            <a:r>
+              <a:rPr lang="en-US" sz="2400" b="0" i="0" u="none" strike="noStrike" cap="none">
+                <a:solidFill>
+                  <a:schemeClr val="lt1"/>
+                </a:solidFill>
+                <a:latin typeface="Arial"/>
+                <a:ea typeface="Arial"/>
+                <a:cs typeface="Arial"/>
+                <a:sym typeface="Arial"/>
+              </a:rPr>
+              <a:t>Slide Title</a:t>
+            </a:r>
+            <a:endParaRPr sz="2400" b="0" i="0" u="none" strike="noStrike" cap="none">
+              <a:solidFill>
+                <a:schemeClr val="lt1"/>
+              </a:solidFill>
+              <a:latin typeface="Arial"/>
+              <a:ea typeface="Arial"/>
+              <a:cs typeface="Arial"/>
+              <a:sym typeface="Arial"/>
+            </a:endParaRPr>
+          </a:p>
+        </p:txBody>
+      </p:sp>
+      <p:pic>
+        <p:nvPicPr>
+          <p:cNvPr id="152" name="Google Shape;152;p31"/>
+          <p:cNvPicPr preferRelativeResize="0"/>
+          <p:nvPr/>
+        </p:nvPicPr>
+        <p:blipFill rotWithShape="1">
+          <a:blip r:embed="rId3">
+            <a:alphaModFix/>
+          </a:blip>
+          <a:srcRect/>
+          <a:stretch/>
+        </p:blipFill>
+        <p:spPr>
+          <a:xfrm>
+            <a:off x="11557509" y="233819"/>
+            <a:ext cx="271308" cy="389810"/>
+          </a:xfrm>
+          <a:prstGeom prst="rect">
+            <a:avLst/>
+          </a:prstGeom>
+          <a:noFill/>
+          <a:ln>
+            <a:noFill/>
+          </a:ln>
+        </p:spPr>
+      </p:pic>
+      <p:sp>
+        <p:nvSpPr>
+          <p:cNvPr id="153" name="Google Shape;153;p31"/>
+          <p:cNvSpPr txBox="1"/>
+          <p:nvPr/>
+        </p:nvSpPr>
+        <p:spPr>
+          <a:xfrm>
+            <a:off x="9335597" y="6524381"/>
+            <a:ext cx="2473415" cy="230792"/>
+          </a:xfrm>
+          <a:prstGeom prst="rect">
+            <a:avLst/>
+          </a:prstGeom>
+          <a:noFill/>
+          <a:ln>
+            <a:noFill/>
+          </a:ln>
+        </p:spPr>
+        <p:txBody>
+          <a:bodyPr spcFirstLastPara="1" wrap="square" lIns="91425" tIns="45700" rIns="91425" bIns="45700" anchor="t" anchorCtr="0">
+            <a:spAutoFit/>
+          </a:bodyPr>
+          <a:lstStyle/>
+          <a:p>
+            <a:pPr marL="0" marR="0" lvl="0" indent="0" algn="r" rtl="0">
+              <a:lnSpc>
+                <a:spcPct val="100000"/>
+              </a:lnSpc>
+              <a:spcBef>
+                <a:spcPts val="0"/>
+              </a:spcBef>
+              <a:spcAft>
+                <a:spcPts val="0"/>
+              </a:spcAft>
+              <a:buNone/>
+            </a:pPr>
+            <a:r>
+              <a:rPr lang="en-US" sz="900" b="0" i="0" u="none" strike="noStrike" cap="none">
+                <a:solidFill>
+                  <a:srgbClr val="13294B"/>
+                </a:solidFill>
+                <a:latin typeface="Arial"/>
+                <a:ea typeface="Arial"/>
+                <a:cs typeface="Arial"/>
+                <a:sym typeface="Arial"/>
+              </a:rPr>
+              <a:t>GRAINGER ENGINEERING</a:t>
+            </a:r>
+            <a:endParaRPr/>
+          </a:p>
+        </p:txBody>
+      </p:sp>
+      <p:sp>
+        <p:nvSpPr>
+          <p:cNvPr id="154" name="Google Shape;154;p31"/>
+          <p:cNvSpPr txBox="1"/>
+          <p:nvPr/>
+        </p:nvSpPr>
+        <p:spPr>
+          <a:xfrm>
+            <a:off x="376807" y="6524381"/>
+            <a:ext cx="7991400" cy="230700"/>
+          </a:xfrm>
+          <a:prstGeom prst="rect">
+            <a:avLst/>
+          </a:prstGeom>
+          <a:noFill/>
+          <a:ln>
+            <a:noFill/>
+          </a:ln>
+        </p:spPr>
+        <p:txBody>
+          <a:bodyPr spcFirstLastPara="1" wrap="square" lIns="91425" tIns="45700" rIns="91425" bIns="45700" anchor="t" anchorCtr="0">
+            <a:spAutoFit/>
+          </a:bodyPr>
+          <a:lstStyle/>
+          <a:p>
+            <a:pPr marL="0" marR="0" lvl="0" indent="0" algn="l" rtl="0">
+              <a:lnSpc>
+                <a:spcPct val="100000"/>
+              </a:lnSpc>
+              <a:spcBef>
+                <a:spcPts val="0"/>
+              </a:spcBef>
+              <a:spcAft>
+                <a:spcPts val="0"/>
+              </a:spcAft>
+              <a:buNone/>
+            </a:pPr>
+            <a:r>
+              <a:rPr lang="en-US" sz="900" dirty="0">
+                <a:solidFill>
+                  <a:srgbClr val="13294B"/>
+                </a:solidFill>
+              </a:rPr>
+              <a:t>SYSTEMS ENGINEERING</a:t>
+            </a:r>
+            <a:endParaRPr dirty="0"/>
+          </a:p>
+        </p:txBody>
+      </p:sp>
+      <p:grpSp>
+        <p:nvGrpSpPr>
+          <p:cNvPr id="155" name="Google Shape;155;p31"/>
+          <p:cNvGrpSpPr/>
+          <p:nvPr/>
+        </p:nvGrpSpPr>
+        <p:grpSpPr>
+          <a:xfrm>
+            <a:off x="4066674" y="6601537"/>
+            <a:ext cx="5233412" cy="70446"/>
+            <a:chOff x="4033424" y="6601537"/>
+            <a:chExt cx="5233412" cy="70446"/>
+          </a:xfrm>
+        </p:grpSpPr>
+        <p:cxnSp>
+          <p:nvCxnSpPr>
+            <p:cNvPr id="156" name="Google Shape;156;p31"/>
+            <p:cNvCxnSpPr/>
+            <p:nvPr/>
+          </p:nvCxnSpPr>
+          <p:spPr>
+            <a:xfrm rot="10800000">
+              <a:off x="4033424" y="6639606"/>
+              <a:ext cx="5164651" cy="0"/>
+            </a:xfrm>
+            <a:prstGeom prst="straightConnector1">
+              <a:avLst/>
+            </a:prstGeom>
+            <a:noFill/>
+            <a:ln w="9525" cap="flat" cmpd="sng">
+              <a:solidFill>
+                <a:srgbClr val="13294B"/>
+              </a:solidFill>
+              <a:prstDash val="solid"/>
+              <a:round/>
+              <a:headEnd type="none" w="sm" len="sm"/>
+              <a:tailEnd type="none" w="sm" len="sm"/>
+            </a:ln>
+          </p:spPr>
+        </p:cxnSp>
+        <p:sp>
+          <p:nvSpPr>
+            <p:cNvPr id="157" name="Google Shape;157;p31"/>
+            <p:cNvSpPr/>
+            <p:nvPr/>
+          </p:nvSpPr>
+          <p:spPr>
+            <a:xfrm>
+              <a:off x="9196390" y="6601537"/>
+              <a:ext cx="70446" cy="70446"/>
+            </a:xfrm>
+            <a:prstGeom prst="ellipse">
+              <a:avLst/>
+            </a:prstGeom>
+            <a:solidFill>
+              <a:srgbClr val="13294B"/>
+            </a:solidFill>
+            <a:ln>
+              <a:noFill/>
+            </a:ln>
+          </p:spPr>
+          <p:txBody>
+            <a:bodyPr spcFirstLastPara="1" wrap="square" lIns="91425" tIns="45700" rIns="91425" bIns="45700" anchor="ctr" anchorCtr="0">
+              <a:noAutofit/>
+            </a:bodyPr>
+            <a:lstStyle/>
+            <a:p>
+              <a:pPr marL="0" marR="0" lvl="0" indent="0" algn="ctr" rtl="0">
+                <a:lnSpc>
+                  <a:spcPct val="100000"/>
+                </a:lnSpc>
+                <a:spcBef>
+                  <a:spcPts val="0"/>
+                </a:spcBef>
+                <a:spcAft>
+                  <a:spcPts val="0"/>
+                </a:spcAft>
+                <a:buNone/>
+              </a:pPr>
+              <a:endParaRPr sz="1400" b="0" i="0" u="none" strike="noStrike" cap="none">
+                <a:solidFill>
+                  <a:srgbClr val="13294B"/>
+                </a:solidFill>
+                <a:latin typeface="Arial"/>
+                <a:ea typeface="Arial"/>
+                <a:cs typeface="Arial"/>
+                <a:sym typeface="Arial"/>
+              </a:endParaRPr>
+            </a:p>
+          </p:txBody>
+        </p:sp>
+      </p:grpSp>
+    </p:spTree>
+  </p:cSld>
+  <p:clrMapOvr>
+    <a:masterClrMapping/>
+  </p:clrMapOvr>
+</p:sld>
+</file>
+
+<file path=ppt/slides/slide11.xml><?xml version="1.0" encoding="utf-8"?>
+<p:sld xmlns:a="http://schemas.openxmlformats.org/drawingml/2006/main" xmlns:r="http://schemas.openxmlformats.org/officeDocument/2006/relationships" xmlns:p="http://schemas.openxmlformats.org/presentationml/2006/main">
+  <p:cSld>
+    <p:spTree>
+      <p:nvGrpSpPr>
         <p:cNvPr id="1" name="Shape 161"/>
         <p:cNvGrpSpPr/>
         <p:nvPr/>
@@ -17429,7 +18414,7 @@
 </p:sld>
 </file>
 
-<file path=ppt/slides/slide11.xml><?xml version="1.0" encoding="utf-8"?>
+<file path=ppt/slides/slide12.xml><?xml version="1.0" encoding="utf-8"?>
 <p:sld xmlns:a="http://schemas.openxmlformats.org/drawingml/2006/main" xmlns:r="http://schemas.openxmlformats.org/officeDocument/2006/relationships" xmlns:p="http://schemas.openxmlformats.org/presentationml/2006/main">
   <p:cSld>
     <p:spTree>
@@ -18146,7 +19131,7 @@
 </p:sld>
 </file>
 
-<file path=ppt/slides/slide12.xml><?xml version="1.0" encoding="utf-8"?>
+<file path=ppt/slides/slide13.xml><?xml version="1.0" encoding="utf-8"?>
 <p:sld xmlns:a="http://schemas.openxmlformats.org/drawingml/2006/main" xmlns:r="http://schemas.openxmlformats.org/officeDocument/2006/relationships" xmlns:p="http://schemas.openxmlformats.org/presentationml/2006/main">
   <p:cSld>
     <p:spTree>
@@ -18863,7 +19848,7 @@
 </p:sld>
 </file>
 
-<file path=ppt/slides/slide13.xml><?xml version="1.0" encoding="utf-8"?>
+<file path=ppt/slides/slide14.xml><?xml version="1.0" encoding="utf-8"?>
 <p:sld xmlns:a="http://schemas.openxmlformats.org/drawingml/2006/main" xmlns:r="http://schemas.openxmlformats.org/officeDocument/2006/relationships" xmlns:p="http://schemas.openxmlformats.org/presentationml/2006/main">
   <p:cSld>
     <p:spTree>
@@ -19419,7 +20404,7 @@
 </p:sld>
 </file>
 
-<file path=ppt/slides/slide14.xml><?xml version="1.0" encoding="utf-8"?>
+<file path=ppt/slides/slide15.xml><?xml version="1.0" encoding="utf-8"?>
 <p:sld xmlns:a="http://schemas.openxmlformats.org/drawingml/2006/main" xmlns:r="http://schemas.openxmlformats.org/officeDocument/2006/relationships" xmlns:p="http://schemas.openxmlformats.org/presentationml/2006/main">
   <p:cSld>
     <p:spTree>
@@ -19885,7 +20870,7 @@
 </p:sld>
 </file>
 
-<file path=ppt/slides/slide15.xml><?xml version="1.0" encoding="utf-8"?>
+<file path=ppt/slides/slide16.xml><?xml version="1.0" encoding="utf-8"?>
 <p:sld xmlns:a="http://schemas.openxmlformats.org/drawingml/2006/main" xmlns:r="http://schemas.openxmlformats.org/officeDocument/2006/relationships" xmlns:p="http://schemas.openxmlformats.org/presentationml/2006/main">
   <p:cSld>
     <p:bg>
@@ -20488,7 +21473,7 @@
 </p:sld>
 </file>
 
-<file path=ppt/slides/slide16.xml><?xml version="1.0" encoding="utf-8"?>
+<file path=ppt/slides/slide17.xml><?xml version="1.0" encoding="utf-8"?>
 <p:sld xmlns:a="http://schemas.openxmlformats.org/drawingml/2006/main" xmlns:r="http://schemas.openxmlformats.org/officeDocument/2006/relationships" xmlns:p="http://schemas.openxmlformats.org/presentationml/2006/main">
   <p:cSld>
     <p:spTree>
@@ -21062,7 +22047,7 @@
 </p:sld>
 </file>
 
-<file path=ppt/slides/slide17.xml><?xml version="1.0" encoding="utf-8"?>
+<file path=ppt/slides/slide18.xml><?xml version="1.0" encoding="utf-8"?>
 <p:sld xmlns:a="http://schemas.openxmlformats.org/drawingml/2006/main" xmlns:r="http://schemas.openxmlformats.org/officeDocument/2006/relationships" xmlns:p="http://schemas.openxmlformats.org/presentationml/2006/main">
   <p:cSld>
     <p:bg>
@@ -21594,7 +22579,7 @@
 </p:sld>
 </file>
 
-<file path=ppt/slides/slide18.xml><?xml version="1.0" encoding="utf-8"?>
+<file path=ppt/slides/slide19.xml><?xml version="1.0" encoding="utf-8"?>
 <p:sld xmlns:a="http://schemas.openxmlformats.org/drawingml/2006/main" xmlns:r="http://schemas.openxmlformats.org/officeDocument/2006/relationships" xmlns:p="http://schemas.openxmlformats.org/presentationml/2006/main">
   <p:cSld>
     <p:bg>
@@ -22116,7 +23101,633 @@
 </p:sld>
 </file>
 
-<file path=ppt/slides/slide19.xml><?xml version="1.0" encoding="utf-8"?>
+<file path=ppt/slides/slide2.xml><?xml version="1.0" encoding="utf-8"?>
+<p:sld xmlns:a="http://schemas.openxmlformats.org/drawingml/2006/main" xmlns:r="http://schemas.openxmlformats.org/officeDocument/2006/relationships" xmlns:p="http://schemas.openxmlformats.org/presentationml/2006/main">
+  <p:cSld>
+    <p:spTree>
+      <p:nvGrpSpPr>
+        <p:cNvPr id="1" name="Shape 117">
+          <a:extLst>
+            <a:ext uri="{FF2B5EF4-FFF2-40B4-BE49-F238E27FC236}">
+              <a16:creationId xmlns:a16="http://schemas.microsoft.com/office/drawing/2014/main" id="{B787707C-0AB4-57C3-5639-B4BEF4389386}"/>
+            </a:ext>
+          </a:extLst>
+        </p:cNvPr>
+        <p:cNvGrpSpPr/>
+        <p:nvPr/>
+      </p:nvGrpSpPr>
+      <p:grpSpPr>
+        <a:xfrm>
+          <a:off x="0" y="0"/>
+          <a:ext cx="0" cy="0"/>
+          <a:chOff x="0" y="0"/>
+          <a:chExt cx="0" cy="0"/>
+        </a:xfrm>
+      </p:grpSpPr>
+      <p:sp>
+        <p:nvSpPr>
+          <p:cNvPr id="118" name="Google Shape;118;p29">
+            <a:extLst>
+              <a:ext uri="{FF2B5EF4-FFF2-40B4-BE49-F238E27FC236}">
+                <a16:creationId xmlns:a16="http://schemas.microsoft.com/office/drawing/2014/main" id="{E7EA1A55-2BAC-C6A5-ABC3-168138F62B6C}"/>
+              </a:ext>
+            </a:extLst>
+          </p:cNvPr>
+          <p:cNvSpPr txBox="1">
+            <a:spLocks noGrp="1"/>
+          </p:cNvSpPr>
+          <p:nvPr>
+            <p:ph type="body" idx="1"/>
+          </p:nvPr>
+        </p:nvSpPr>
+        <p:spPr>
+          <a:xfrm>
+            <a:off x="376809" y="1334279"/>
+            <a:ext cx="11177401" cy="4821102"/>
+          </a:xfrm>
+          <a:prstGeom prst="rect">
+            <a:avLst/>
+          </a:prstGeom>
+          <a:noFill/>
+          <a:ln>
+            <a:noFill/>
+          </a:ln>
+        </p:spPr>
+        <p:txBody>
+          <a:bodyPr spcFirstLastPara="1" wrap="square" lIns="91425" tIns="45700" rIns="91425" bIns="45700" anchor="t" anchorCtr="0">
+            <a:noAutofit/>
+          </a:bodyPr>
+          <a:lstStyle/>
+          <a:p>
+            <a:pPr marL="0" indent="0">
+              <a:lnSpc>
+                <a:spcPct val="100000"/>
+              </a:lnSpc>
+              <a:spcBef>
+                <a:spcPts val="0"/>
+              </a:spcBef>
+              <a:buSzPts val="3000"/>
+              <a:buNone/>
+            </a:pPr>
+            <a:r>
+              <a:rPr lang="en-US" sz="2400" dirty="0">
+                <a:solidFill>
+                  <a:schemeClr val="dk1"/>
+                </a:solidFill>
+                <a:latin typeface="Arial"/>
+                <a:ea typeface="Arial"/>
+                <a:cs typeface="Arial"/>
+                <a:sym typeface="Arial"/>
+              </a:rPr>
+              <a:t>Talk to the person next to you and answer these questions.</a:t>
+            </a:r>
+          </a:p>
+          <a:p>
+            <a:pPr marL="285750" indent="-285750">
+              <a:lnSpc>
+                <a:spcPct val="100000"/>
+              </a:lnSpc>
+              <a:spcBef>
+                <a:spcPts val="0"/>
+              </a:spcBef>
+              <a:buSzPts val="3000"/>
+            </a:pPr>
+            <a:endParaRPr lang="en-US" sz="2400" dirty="0">
+              <a:latin typeface="Arial"/>
+              <a:ea typeface="Arial"/>
+              <a:cs typeface="Arial"/>
+              <a:sym typeface="Arial"/>
+            </a:endParaRPr>
+          </a:p>
+          <a:p>
+            <a:pPr marL="285750" indent="-285750">
+              <a:lnSpc>
+                <a:spcPct val="100000"/>
+              </a:lnSpc>
+              <a:spcBef>
+                <a:spcPts val="0"/>
+              </a:spcBef>
+              <a:buSzPts val="3000"/>
+            </a:pPr>
+            <a:r>
+              <a:rPr lang="en-US" sz="2400" dirty="0">
+                <a:solidFill>
+                  <a:schemeClr val="dk1"/>
+                </a:solidFill>
+                <a:latin typeface="Arial"/>
+                <a:ea typeface="Arial"/>
+                <a:cs typeface="Arial"/>
+                <a:sym typeface="Arial"/>
+              </a:rPr>
+              <a:t>Last lecture we said we used “BFS”, what does it stand for? What type of data structure is this most commonly used?</a:t>
+            </a:r>
+          </a:p>
+          <a:p>
+            <a:pPr marL="285750" indent="-285750">
+              <a:lnSpc>
+                <a:spcPct val="100000"/>
+              </a:lnSpc>
+              <a:spcBef>
+                <a:spcPts val="0"/>
+              </a:spcBef>
+              <a:buSzPts val="3000"/>
+            </a:pPr>
+            <a:r>
+              <a:rPr lang="en-US" sz="2400" dirty="0">
+                <a:solidFill>
+                  <a:schemeClr val="dk1"/>
+                </a:solidFill>
+                <a:latin typeface="Arial"/>
+                <a:ea typeface="Arial"/>
+                <a:cs typeface="Arial"/>
+                <a:sym typeface="Arial"/>
+              </a:rPr>
+              <a:t>Open on the </a:t>
+            </a:r>
+            <a:r>
+              <a:rPr lang="en-US" sz="2400" dirty="0">
+                <a:latin typeface="Arial"/>
+                <a:ea typeface="Arial"/>
+                <a:cs typeface="Arial"/>
+                <a:sym typeface="Arial"/>
+              </a:rPr>
+              <a:t>lecture’s website the path planning visualization that was made for this lecture (</a:t>
+            </a:r>
+            <a:r>
+              <a:rPr lang="en-US" sz="2400" dirty="0">
+                <a:latin typeface="Arial"/>
+                <a:ea typeface="Arial"/>
+                <a:cs typeface="Arial"/>
+                <a:sym typeface="Arial"/>
+                <a:hlinkClick r:id="rId3"/>
+              </a:rPr>
+              <a:t>https://marius-juston.github.io/SE-423---Class-Material/path_planning.html</a:t>
+            </a:r>
+            <a:r>
+              <a:rPr lang="en-US" sz="2400" dirty="0">
+                <a:latin typeface="Arial"/>
+                <a:ea typeface="Arial"/>
+                <a:cs typeface="Arial"/>
+                <a:sym typeface="Arial"/>
+              </a:rPr>
+              <a:t>), play around and draw some things and press the run button. You don’t need to understand what A* Search, BFS, </a:t>
+            </a:r>
+            <a:r>
+              <a:rPr lang="en-US" sz="2400" dirty="0" err="1">
+                <a:latin typeface="Arial"/>
+                <a:ea typeface="Arial"/>
+                <a:cs typeface="Arial"/>
+                <a:sym typeface="Arial"/>
+              </a:rPr>
+              <a:t>Dijstras</a:t>
+            </a:r>
+            <a:r>
+              <a:rPr lang="en-US" sz="2400" dirty="0">
+                <a:latin typeface="Arial"/>
+                <a:ea typeface="Arial"/>
+                <a:cs typeface="Arial"/>
+                <a:sym typeface="Arial"/>
+              </a:rPr>
+              <a:t> is yet, but I would recommend having this up during lecture so that you can see the different algorithms and settings</a:t>
+            </a:r>
+            <a:endParaRPr lang="en-US" sz="2400" dirty="0">
+              <a:solidFill>
+                <a:schemeClr val="dk1"/>
+              </a:solidFill>
+              <a:latin typeface="Arial"/>
+              <a:ea typeface="Arial"/>
+              <a:cs typeface="Arial"/>
+              <a:sym typeface="Arial"/>
+            </a:endParaRPr>
+          </a:p>
+          <a:p>
+            <a:pPr marL="0" indent="0">
+              <a:lnSpc>
+                <a:spcPct val="100000"/>
+              </a:lnSpc>
+              <a:spcBef>
+                <a:spcPts val="0"/>
+              </a:spcBef>
+              <a:buSzPts val="3000"/>
+              <a:buNone/>
+            </a:pPr>
+            <a:endParaRPr lang="en-US" sz="2400" dirty="0">
+              <a:solidFill>
+                <a:schemeClr val="dk1"/>
+              </a:solidFill>
+              <a:latin typeface="Arial"/>
+              <a:ea typeface="Arial"/>
+              <a:cs typeface="Arial"/>
+              <a:sym typeface="Arial"/>
+            </a:endParaRPr>
+          </a:p>
+        </p:txBody>
+      </p:sp>
+      <p:sp>
+        <p:nvSpPr>
+          <p:cNvPr id="119" name="Google Shape;119;p29">
+            <a:extLst>
+              <a:ext uri="{FF2B5EF4-FFF2-40B4-BE49-F238E27FC236}">
+                <a16:creationId xmlns:a16="http://schemas.microsoft.com/office/drawing/2014/main" id="{AADDCC56-907C-FD39-6E34-87042D08FA2E}"/>
+              </a:ext>
+            </a:extLst>
+          </p:cNvPr>
+          <p:cNvSpPr/>
+          <p:nvPr/>
+        </p:nvSpPr>
+        <p:spPr>
+          <a:xfrm rot="10800000" flipH="1">
+            <a:off x="0" y="0"/>
+            <a:ext cx="12192000" cy="868220"/>
+          </a:xfrm>
+          <a:prstGeom prst="rect">
+            <a:avLst/>
+          </a:prstGeom>
+          <a:solidFill>
+            <a:srgbClr val="13294B"/>
+          </a:solidFill>
+          <a:ln>
+            <a:noFill/>
+          </a:ln>
+        </p:spPr>
+        <p:txBody>
+          <a:bodyPr spcFirstLastPara="1" wrap="square" lIns="91425" tIns="45700" rIns="91425" bIns="45700" anchor="ctr" anchorCtr="0">
+            <a:noAutofit/>
+          </a:bodyPr>
+          <a:lstStyle/>
+          <a:p>
+            <a:pPr marL="0" marR="0" lvl="0" indent="0" algn="ctr" rtl="0">
+              <a:lnSpc>
+                <a:spcPct val="100000"/>
+              </a:lnSpc>
+              <a:spcBef>
+                <a:spcPts val="0"/>
+              </a:spcBef>
+              <a:spcAft>
+                <a:spcPts val="0"/>
+              </a:spcAft>
+              <a:buClr>
+                <a:schemeClr val="lt1"/>
+              </a:buClr>
+              <a:buSzPts val="1800"/>
+              <a:buFont typeface="Calibri"/>
+              <a:buNone/>
+            </a:pPr>
+            <a:endParaRPr sz="1800" b="0" i="0" u="none" strike="noStrike" cap="none">
+              <a:solidFill>
+                <a:srgbClr val="13294B"/>
+              </a:solidFill>
+              <a:latin typeface="Calibri"/>
+              <a:ea typeface="Calibri"/>
+              <a:cs typeface="Calibri"/>
+              <a:sym typeface="Calibri"/>
+            </a:endParaRPr>
+          </a:p>
+        </p:txBody>
+      </p:sp>
+      <p:sp>
+        <p:nvSpPr>
+          <p:cNvPr id="120" name="Google Shape;120;p29">
+            <a:extLst>
+              <a:ext uri="{FF2B5EF4-FFF2-40B4-BE49-F238E27FC236}">
+                <a16:creationId xmlns:a16="http://schemas.microsoft.com/office/drawing/2014/main" id="{C941C760-8B23-A46D-5C4A-981290CB9EBC}"/>
+              </a:ext>
+            </a:extLst>
+          </p:cNvPr>
+          <p:cNvSpPr txBox="1"/>
+          <p:nvPr/>
+        </p:nvSpPr>
+        <p:spPr>
+          <a:xfrm>
+            <a:off x="376810" y="204051"/>
+            <a:ext cx="10910026" cy="461624"/>
+          </a:xfrm>
+          <a:prstGeom prst="rect">
+            <a:avLst/>
+          </a:prstGeom>
+          <a:noFill/>
+          <a:ln>
+            <a:noFill/>
+          </a:ln>
+        </p:spPr>
+        <p:txBody>
+          <a:bodyPr spcFirstLastPara="1" wrap="square" lIns="91425" tIns="45700" rIns="91425" bIns="45700" anchor="t" anchorCtr="0">
+            <a:spAutoFit/>
+          </a:bodyPr>
+          <a:lstStyle/>
+          <a:p>
+            <a:pPr marL="0" marR="0" lvl="0" indent="0" algn="l" rtl="0">
+              <a:lnSpc>
+                <a:spcPct val="100000"/>
+              </a:lnSpc>
+              <a:spcBef>
+                <a:spcPts val="0"/>
+              </a:spcBef>
+              <a:spcAft>
+                <a:spcPts val="0"/>
+              </a:spcAft>
+              <a:buClr>
+                <a:srgbClr val="000000"/>
+              </a:buClr>
+              <a:buSzPts val="2400"/>
+              <a:buFont typeface="Arial"/>
+              <a:buNone/>
+            </a:pPr>
+            <a:r>
+              <a:rPr lang="en-US" sz="2400" b="0" i="0" u="none" strike="noStrike" cap="none" dirty="0">
+                <a:solidFill>
+                  <a:schemeClr val="lt1"/>
+                </a:solidFill>
+                <a:latin typeface="Arial"/>
+                <a:ea typeface="Arial"/>
+                <a:cs typeface="Arial"/>
+                <a:sym typeface="Arial"/>
+              </a:rPr>
+              <a:t>Review – 5-minute partner discussion</a:t>
+            </a:r>
+            <a:endParaRPr sz="2400" b="0" i="0" u="none" strike="noStrike" cap="none" dirty="0">
+              <a:solidFill>
+                <a:schemeClr val="lt1"/>
+              </a:solidFill>
+              <a:latin typeface="Arial"/>
+              <a:ea typeface="Arial"/>
+              <a:cs typeface="Arial"/>
+              <a:sym typeface="Arial"/>
+            </a:endParaRPr>
+          </a:p>
+        </p:txBody>
+      </p:sp>
+      <p:pic>
+        <p:nvPicPr>
+          <p:cNvPr id="121" name="Google Shape;121;p29">
+            <a:extLst>
+              <a:ext uri="{FF2B5EF4-FFF2-40B4-BE49-F238E27FC236}">
+                <a16:creationId xmlns:a16="http://schemas.microsoft.com/office/drawing/2014/main" id="{C1984774-B7FA-53FC-ECBE-3FFBD377F556}"/>
+              </a:ext>
+            </a:extLst>
+          </p:cNvPr>
+          <p:cNvPicPr preferRelativeResize="0"/>
+          <p:nvPr/>
+        </p:nvPicPr>
+        <p:blipFill rotWithShape="1">
+          <a:blip r:embed="rId4">
+            <a:alphaModFix/>
+          </a:blip>
+          <a:srcRect/>
+          <a:stretch/>
+        </p:blipFill>
+        <p:spPr>
+          <a:xfrm>
+            <a:off x="11557509" y="233819"/>
+            <a:ext cx="271308" cy="389810"/>
+          </a:xfrm>
+          <a:prstGeom prst="rect">
+            <a:avLst/>
+          </a:prstGeom>
+          <a:noFill/>
+          <a:ln>
+            <a:noFill/>
+          </a:ln>
+        </p:spPr>
+      </p:pic>
+      <p:sp>
+        <p:nvSpPr>
+          <p:cNvPr id="122" name="Google Shape;122;p29">
+            <a:extLst>
+              <a:ext uri="{FF2B5EF4-FFF2-40B4-BE49-F238E27FC236}">
+                <a16:creationId xmlns:a16="http://schemas.microsoft.com/office/drawing/2014/main" id="{D52648EA-0120-942E-FA7D-98B9C25F4F34}"/>
+              </a:ext>
+            </a:extLst>
+          </p:cNvPr>
+          <p:cNvSpPr txBox="1"/>
+          <p:nvPr/>
+        </p:nvSpPr>
+        <p:spPr>
+          <a:xfrm>
+            <a:off x="9335597" y="6524381"/>
+            <a:ext cx="2473415" cy="230792"/>
+          </a:xfrm>
+          <a:prstGeom prst="rect">
+            <a:avLst/>
+          </a:prstGeom>
+          <a:noFill/>
+          <a:ln>
+            <a:noFill/>
+          </a:ln>
+        </p:spPr>
+        <p:txBody>
+          <a:bodyPr spcFirstLastPara="1" wrap="square" lIns="91425" tIns="45700" rIns="91425" bIns="45700" anchor="t" anchorCtr="0">
+            <a:spAutoFit/>
+          </a:bodyPr>
+          <a:lstStyle/>
+          <a:p>
+            <a:pPr marL="0" marR="0" lvl="0" indent="0" algn="r" rtl="0">
+              <a:lnSpc>
+                <a:spcPct val="100000"/>
+              </a:lnSpc>
+              <a:spcBef>
+                <a:spcPts val="0"/>
+              </a:spcBef>
+              <a:spcAft>
+                <a:spcPts val="0"/>
+              </a:spcAft>
+              <a:buNone/>
+            </a:pPr>
+            <a:r>
+              <a:rPr lang="en-US" sz="900" b="0" i="0" u="none" strike="noStrike" cap="none">
+                <a:solidFill>
+                  <a:srgbClr val="13294B"/>
+                </a:solidFill>
+                <a:latin typeface="Arial"/>
+                <a:ea typeface="Arial"/>
+                <a:cs typeface="Arial"/>
+                <a:sym typeface="Arial"/>
+              </a:rPr>
+              <a:t>GRAINGER ENGINEERING</a:t>
+            </a:r>
+            <a:endParaRPr/>
+          </a:p>
+        </p:txBody>
+      </p:sp>
+      <p:sp>
+        <p:nvSpPr>
+          <p:cNvPr id="123" name="Google Shape;123;p29">
+            <a:extLst>
+              <a:ext uri="{FF2B5EF4-FFF2-40B4-BE49-F238E27FC236}">
+                <a16:creationId xmlns:a16="http://schemas.microsoft.com/office/drawing/2014/main" id="{9187DBB9-03BE-10E2-9B63-400A9675CEAD}"/>
+              </a:ext>
+            </a:extLst>
+          </p:cNvPr>
+          <p:cNvSpPr txBox="1"/>
+          <p:nvPr/>
+        </p:nvSpPr>
+        <p:spPr>
+          <a:xfrm>
+            <a:off x="376807" y="6524381"/>
+            <a:ext cx="7991337" cy="230792"/>
+          </a:xfrm>
+          <a:prstGeom prst="rect">
+            <a:avLst/>
+          </a:prstGeom>
+          <a:noFill/>
+          <a:ln>
+            <a:noFill/>
+          </a:ln>
+        </p:spPr>
+        <p:txBody>
+          <a:bodyPr spcFirstLastPara="1" wrap="square" lIns="91425" tIns="45700" rIns="91425" bIns="45700" anchor="t" anchorCtr="0">
+            <a:spAutoFit/>
+          </a:bodyPr>
+          <a:lstStyle/>
+          <a:p>
+            <a:pPr marL="0" marR="0" lvl="0" indent="0" algn="l" rtl="0">
+              <a:lnSpc>
+                <a:spcPct val="100000"/>
+              </a:lnSpc>
+              <a:spcBef>
+                <a:spcPts val="0"/>
+              </a:spcBef>
+              <a:spcAft>
+                <a:spcPts val="0"/>
+              </a:spcAft>
+              <a:buNone/>
+            </a:pPr>
+            <a:r>
+              <a:rPr lang="en-US" sz="900" dirty="0">
+                <a:solidFill>
+                  <a:srgbClr val="13294B"/>
+                </a:solidFill>
+              </a:rPr>
+              <a:t>SYSTEMS ENGINEERING </a:t>
+            </a:r>
+            <a:endParaRPr dirty="0"/>
+          </a:p>
+        </p:txBody>
+      </p:sp>
+      <p:grpSp>
+        <p:nvGrpSpPr>
+          <p:cNvPr id="124" name="Google Shape;124;p29">
+            <a:extLst>
+              <a:ext uri="{FF2B5EF4-FFF2-40B4-BE49-F238E27FC236}">
+                <a16:creationId xmlns:a16="http://schemas.microsoft.com/office/drawing/2014/main" id="{73B542CF-2028-95AA-CCEF-91A8D02AD178}"/>
+              </a:ext>
+            </a:extLst>
+          </p:cNvPr>
+          <p:cNvGrpSpPr/>
+          <p:nvPr/>
+        </p:nvGrpSpPr>
+        <p:grpSpPr>
+          <a:xfrm>
+            <a:off x="4066674" y="6601537"/>
+            <a:ext cx="5233412" cy="70446"/>
+            <a:chOff x="4033424" y="6601537"/>
+            <a:chExt cx="5233412" cy="70446"/>
+          </a:xfrm>
+        </p:grpSpPr>
+        <p:cxnSp>
+          <p:nvCxnSpPr>
+            <p:cNvPr id="125" name="Google Shape;125;p29">
+              <a:extLst>
+                <a:ext uri="{FF2B5EF4-FFF2-40B4-BE49-F238E27FC236}">
+                  <a16:creationId xmlns:a16="http://schemas.microsoft.com/office/drawing/2014/main" id="{33141631-F3ED-2759-4D92-932A85BC40E3}"/>
+                </a:ext>
+              </a:extLst>
+            </p:cNvPr>
+            <p:cNvCxnSpPr/>
+            <p:nvPr/>
+          </p:nvCxnSpPr>
+          <p:spPr>
+            <a:xfrm rot="10800000">
+              <a:off x="4033424" y="6639606"/>
+              <a:ext cx="5164651" cy="0"/>
+            </a:xfrm>
+            <a:prstGeom prst="straightConnector1">
+              <a:avLst/>
+            </a:prstGeom>
+            <a:noFill/>
+            <a:ln w="9525" cap="flat" cmpd="sng">
+              <a:solidFill>
+                <a:srgbClr val="13294B"/>
+              </a:solidFill>
+              <a:prstDash val="solid"/>
+              <a:round/>
+              <a:headEnd type="none" w="sm" len="sm"/>
+              <a:tailEnd type="none" w="sm" len="sm"/>
+            </a:ln>
+          </p:spPr>
+        </p:cxnSp>
+        <p:sp>
+          <p:nvSpPr>
+            <p:cNvPr id="126" name="Google Shape;126;p29">
+              <a:extLst>
+                <a:ext uri="{FF2B5EF4-FFF2-40B4-BE49-F238E27FC236}">
+                  <a16:creationId xmlns:a16="http://schemas.microsoft.com/office/drawing/2014/main" id="{E4D9BF8E-CB10-CAD2-7648-4939A5B564E5}"/>
+                </a:ext>
+              </a:extLst>
+            </p:cNvPr>
+            <p:cNvSpPr/>
+            <p:nvPr/>
+          </p:nvSpPr>
+          <p:spPr>
+            <a:xfrm>
+              <a:off x="9196390" y="6601537"/>
+              <a:ext cx="70446" cy="70446"/>
+            </a:xfrm>
+            <a:prstGeom prst="ellipse">
+              <a:avLst/>
+            </a:prstGeom>
+            <a:solidFill>
+              <a:srgbClr val="13294B"/>
+            </a:solidFill>
+            <a:ln>
+              <a:noFill/>
+            </a:ln>
+          </p:spPr>
+          <p:txBody>
+            <a:bodyPr spcFirstLastPara="1" wrap="square" lIns="91425" tIns="45700" rIns="91425" bIns="45700" anchor="ctr" anchorCtr="0">
+              <a:noAutofit/>
+            </a:bodyPr>
+            <a:lstStyle/>
+            <a:p>
+              <a:pPr marL="0" marR="0" lvl="0" indent="0" algn="ctr" rtl="0">
+                <a:lnSpc>
+                  <a:spcPct val="100000"/>
+                </a:lnSpc>
+                <a:spcBef>
+                  <a:spcPts val="0"/>
+                </a:spcBef>
+                <a:spcAft>
+                  <a:spcPts val="0"/>
+                </a:spcAft>
+                <a:buNone/>
+              </a:pPr>
+              <a:endParaRPr sz="1400" b="0" i="0" u="none" strike="noStrike" cap="none">
+                <a:solidFill>
+                  <a:srgbClr val="13294B"/>
+                </a:solidFill>
+                <a:latin typeface="Arial"/>
+                <a:ea typeface="Arial"/>
+                <a:cs typeface="Arial"/>
+                <a:sym typeface="Arial"/>
+              </a:endParaRPr>
+            </a:p>
+          </p:txBody>
+        </p:sp>
+      </p:grpSp>
+    </p:spTree>
+    <p:extLst>
+      <p:ext uri="{BB962C8B-B14F-4D97-AF65-F5344CB8AC3E}">
+        <p14:creationId xmlns:p14="http://schemas.microsoft.com/office/powerpoint/2010/main" val="1702080834"/>
+      </p:ext>
+    </p:extLst>
+  </p:cSld>
+  <p:clrMapOvr>
+    <a:masterClrMapping/>
+  </p:clrMapOvr>
+</p:sld>
+</file>
+
+<file path=ppt/slides/slide20.xml><?xml version="1.0" encoding="utf-8"?>
 <p:sld xmlns:a="http://schemas.openxmlformats.org/drawingml/2006/main" xmlns:r="http://schemas.openxmlformats.org/officeDocument/2006/relationships" xmlns:p="http://schemas.openxmlformats.org/presentationml/2006/main">
   <p:cSld>
     <p:bg>
@@ -22473,583 +24084,7 @@
 </p:sld>
 </file>
 
-<file path=ppt/slides/slide2.xml><?xml version="1.0" encoding="utf-8"?>
-<p:sld xmlns:a="http://schemas.openxmlformats.org/drawingml/2006/main" xmlns:r="http://schemas.openxmlformats.org/officeDocument/2006/relationships" xmlns:p="http://schemas.openxmlformats.org/presentationml/2006/main">
-  <p:cSld>
-    <p:spTree>
-      <p:nvGrpSpPr>
-        <p:cNvPr id="1" name="Shape 117">
-          <a:extLst>
-            <a:ext uri="{FF2B5EF4-FFF2-40B4-BE49-F238E27FC236}">
-              <a16:creationId xmlns:a16="http://schemas.microsoft.com/office/drawing/2014/main" id="{B787707C-0AB4-57C3-5639-B4BEF4389386}"/>
-            </a:ext>
-          </a:extLst>
-        </p:cNvPr>
-        <p:cNvGrpSpPr/>
-        <p:nvPr/>
-      </p:nvGrpSpPr>
-      <p:grpSpPr>
-        <a:xfrm>
-          <a:off x="0" y="0"/>
-          <a:ext cx="0" cy="0"/>
-          <a:chOff x="0" y="0"/>
-          <a:chExt cx="0" cy="0"/>
-        </a:xfrm>
-      </p:grpSpPr>
-      <p:sp>
-        <p:nvSpPr>
-          <p:cNvPr id="118" name="Google Shape;118;p29">
-            <a:extLst>
-              <a:ext uri="{FF2B5EF4-FFF2-40B4-BE49-F238E27FC236}">
-                <a16:creationId xmlns:a16="http://schemas.microsoft.com/office/drawing/2014/main" id="{E7EA1A55-2BAC-C6A5-ABC3-168138F62B6C}"/>
-              </a:ext>
-            </a:extLst>
-          </p:cNvPr>
-          <p:cNvSpPr txBox="1">
-            <a:spLocks noGrp="1"/>
-          </p:cNvSpPr>
-          <p:nvPr>
-            <p:ph type="body" idx="1"/>
-          </p:nvPr>
-        </p:nvSpPr>
-        <p:spPr>
-          <a:xfrm>
-            <a:off x="376809" y="1334279"/>
-            <a:ext cx="11177401" cy="4821102"/>
-          </a:xfrm>
-          <a:prstGeom prst="rect">
-            <a:avLst/>
-          </a:prstGeom>
-          <a:noFill/>
-          <a:ln>
-            <a:noFill/>
-          </a:ln>
-        </p:spPr>
-        <p:txBody>
-          <a:bodyPr spcFirstLastPara="1" wrap="square" lIns="91425" tIns="45700" rIns="91425" bIns="45700" anchor="t" anchorCtr="0">
-            <a:noAutofit/>
-          </a:bodyPr>
-          <a:lstStyle/>
-          <a:p>
-            <a:pPr marL="0" indent="0">
-              <a:lnSpc>
-                <a:spcPct val="100000"/>
-              </a:lnSpc>
-              <a:spcBef>
-                <a:spcPts val="0"/>
-              </a:spcBef>
-              <a:buSzPts val="3000"/>
-              <a:buNone/>
-            </a:pPr>
-            <a:r>
-              <a:rPr lang="en-US" sz="2400" dirty="0">
-                <a:solidFill>
-                  <a:schemeClr val="dk1"/>
-                </a:solidFill>
-                <a:latin typeface="Arial"/>
-                <a:ea typeface="Arial"/>
-                <a:cs typeface="Arial"/>
-                <a:sym typeface="Arial"/>
-              </a:rPr>
-              <a:t>Talk to the person next to you and answer these questions.</a:t>
-            </a:r>
-          </a:p>
-          <a:p>
-            <a:pPr marL="285750" indent="-285750">
-              <a:lnSpc>
-                <a:spcPct val="100000"/>
-              </a:lnSpc>
-              <a:spcBef>
-                <a:spcPts val="0"/>
-              </a:spcBef>
-              <a:buSzPts val="3000"/>
-            </a:pPr>
-            <a:endParaRPr lang="en-US" sz="2400" dirty="0">
-              <a:latin typeface="Arial"/>
-              <a:ea typeface="Arial"/>
-              <a:cs typeface="Arial"/>
-              <a:sym typeface="Arial"/>
-            </a:endParaRPr>
-          </a:p>
-          <a:p>
-            <a:pPr marL="285750" indent="-285750">
-              <a:lnSpc>
-                <a:spcPct val="100000"/>
-              </a:lnSpc>
-              <a:spcBef>
-                <a:spcPts val="0"/>
-              </a:spcBef>
-              <a:buSzPts val="3000"/>
-            </a:pPr>
-            <a:r>
-              <a:rPr lang="en-US" sz="2400" dirty="0">
-                <a:solidFill>
-                  <a:schemeClr val="dk1"/>
-                </a:solidFill>
-                <a:latin typeface="Arial"/>
-                <a:ea typeface="Arial"/>
-                <a:cs typeface="Arial"/>
-                <a:sym typeface="Arial"/>
-              </a:rPr>
-              <a:t>Question 1</a:t>
-            </a:r>
-          </a:p>
-          <a:p>
-            <a:pPr marL="285750" indent="-285750">
-              <a:lnSpc>
-                <a:spcPct val="100000"/>
-              </a:lnSpc>
-              <a:spcBef>
-                <a:spcPts val="0"/>
-              </a:spcBef>
-              <a:buSzPts val="3000"/>
-            </a:pPr>
-            <a:r>
-              <a:rPr lang="en-US" sz="2400" dirty="0">
-                <a:latin typeface="Arial"/>
-                <a:ea typeface="Arial"/>
-                <a:cs typeface="Arial"/>
-                <a:sym typeface="Arial"/>
-              </a:rPr>
-              <a:t>Question 2</a:t>
-            </a:r>
-            <a:endParaRPr lang="en-US" sz="2400" dirty="0">
-              <a:solidFill>
-                <a:schemeClr val="dk1"/>
-              </a:solidFill>
-              <a:latin typeface="Arial"/>
-              <a:ea typeface="Arial"/>
-              <a:cs typeface="Arial"/>
-              <a:sym typeface="Arial"/>
-            </a:endParaRPr>
-          </a:p>
-          <a:p>
-            <a:pPr marL="285750" indent="-285750">
-              <a:lnSpc>
-                <a:spcPct val="100000"/>
-              </a:lnSpc>
-              <a:spcBef>
-                <a:spcPts val="0"/>
-              </a:spcBef>
-              <a:buSzPts val="3000"/>
-            </a:pPr>
-            <a:endParaRPr sz="2400" dirty="0">
-              <a:solidFill>
-                <a:schemeClr val="dk1"/>
-              </a:solidFill>
-              <a:latin typeface="Arial"/>
-              <a:ea typeface="Arial"/>
-              <a:cs typeface="Arial"/>
-              <a:sym typeface="Arial"/>
-            </a:endParaRPr>
-          </a:p>
-        </p:txBody>
-      </p:sp>
-      <p:sp>
-        <p:nvSpPr>
-          <p:cNvPr id="119" name="Google Shape;119;p29">
-            <a:extLst>
-              <a:ext uri="{FF2B5EF4-FFF2-40B4-BE49-F238E27FC236}">
-                <a16:creationId xmlns:a16="http://schemas.microsoft.com/office/drawing/2014/main" id="{AADDCC56-907C-FD39-6E34-87042D08FA2E}"/>
-              </a:ext>
-            </a:extLst>
-          </p:cNvPr>
-          <p:cNvSpPr/>
-          <p:nvPr/>
-        </p:nvSpPr>
-        <p:spPr>
-          <a:xfrm rot="10800000" flipH="1">
-            <a:off x="0" y="0"/>
-            <a:ext cx="12192000" cy="868220"/>
-          </a:xfrm>
-          <a:prstGeom prst="rect">
-            <a:avLst/>
-          </a:prstGeom>
-          <a:solidFill>
-            <a:srgbClr val="13294B"/>
-          </a:solidFill>
-          <a:ln>
-            <a:noFill/>
-          </a:ln>
-        </p:spPr>
-        <p:txBody>
-          <a:bodyPr spcFirstLastPara="1" wrap="square" lIns="91425" tIns="45700" rIns="91425" bIns="45700" anchor="ctr" anchorCtr="0">
-            <a:noAutofit/>
-          </a:bodyPr>
-          <a:lstStyle/>
-          <a:p>
-            <a:pPr marL="0" marR="0" lvl="0" indent="0" algn="ctr" rtl="0">
-              <a:lnSpc>
-                <a:spcPct val="100000"/>
-              </a:lnSpc>
-              <a:spcBef>
-                <a:spcPts val="0"/>
-              </a:spcBef>
-              <a:spcAft>
-                <a:spcPts val="0"/>
-              </a:spcAft>
-              <a:buClr>
-                <a:schemeClr val="lt1"/>
-              </a:buClr>
-              <a:buSzPts val="1800"/>
-              <a:buFont typeface="Calibri"/>
-              <a:buNone/>
-            </a:pPr>
-            <a:endParaRPr sz="1800" b="0" i="0" u="none" strike="noStrike" cap="none">
-              <a:solidFill>
-                <a:srgbClr val="13294B"/>
-              </a:solidFill>
-              <a:latin typeface="Calibri"/>
-              <a:ea typeface="Calibri"/>
-              <a:cs typeface="Calibri"/>
-              <a:sym typeface="Calibri"/>
-            </a:endParaRPr>
-          </a:p>
-        </p:txBody>
-      </p:sp>
-      <p:sp>
-        <p:nvSpPr>
-          <p:cNvPr id="120" name="Google Shape;120;p29">
-            <a:extLst>
-              <a:ext uri="{FF2B5EF4-FFF2-40B4-BE49-F238E27FC236}">
-                <a16:creationId xmlns:a16="http://schemas.microsoft.com/office/drawing/2014/main" id="{C941C760-8B23-A46D-5C4A-981290CB9EBC}"/>
-              </a:ext>
-            </a:extLst>
-          </p:cNvPr>
-          <p:cNvSpPr txBox="1"/>
-          <p:nvPr/>
-        </p:nvSpPr>
-        <p:spPr>
-          <a:xfrm>
-            <a:off x="376810" y="204051"/>
-            <a:ext cx="10910026" cy="461624"/>
-          </a:xfrm>
-          <a:prstGeom prst="rect">
-            <a:avLst/>
-          </a:prstGeom>
-          <a:noFill/>
-          <a:ln>
-            <a:noFill/>
-          </a:ln>
-        </p:spPr>
-        <p:txBody>
-          <a:bodyPr spcFirstLastPara="1" wrap="square" lIns="91425" tIns="45700" rIns="91425" bIns="45700" anchor="t" anchorCtr="0">
-            <a:spAutoFit/>
-          </a:bodyPr>
-          <a:lstStyle/>
-          <a:p>
-            <a:pPr marL="0" marR="0" lvl="0" indent="0" algn="l" rtl="0">
-              <a:lnSpc>
-                <a:spcPct val="100000"/>
-              </a:lnSpc>
-              <a:spcBef>
-                <a:spcPts val="0"/>
-              </a:spcBef>
-              <a:spcAft>
-                <a:spcPts val="0"/>
-              </a:spcAft>
-              <a:buClr>
-                <a:srgbClr val="000000"/>
-              </a:buClr>
-              <a:buSzPts val="2400"/>
-              <a:buFont typeface="Arial"/>
-              <a:buNone/>
-            </a:pPr>
-            <a:r>
-              <a:rPr lang="en-US" sz="2400" b="0" i="0" u="none" strike="noStrike" cap="none" dirty="0">
-                <a:solidFill>
-                  <a:schemeClr val="lt1"/>
-                </a:solidFill>
-                <a:latin typeface="Arial"/>
-                <a:ea typeface="Arial"/>
-                <a:cs typeface="Arial"/>
-                <a:sym typeface="Arial"/>
-              </a:rPr>
-              <a:t>Review – 5-minute partner discussion</a:t>
-            </a:r>
-            <a:endParaRPr sz="2400" b="0" i="0" u="none" strike="noStrike" cap="none" dirty="0">
-              <a:solidFill>
-                <a:schemeClr val="lt1"/>
-              </a:solidFill>
-              <a:latin typeface="Arial"/>
-              <a:ea typeface="Arial"/>
-              <a:cs typeface="Arial"/>
-              <a:sym typeface="Arial"/>
-            </a:endParaRPr>
-          </a:p>
-        </p:txBody>
-      </p:sp>
-      <p:pic>
-        <p:nvPicPr>
-          <p:cNvPr id="121" name="Google Shape;121;p29">
-            <a:extLst>
-              <a:ext uri="{FF2B5EF4-FFF2-40B4-BE49-F238E27FC236}">
-                <a16:creationId xmlns:a16="http://schemas.microsoft.com/office/drawing/2014/main" id="{C1984774-B7FA-53FC-ECBE-3FFBD377F556}"/>
-              </a:ext>
-            </a:extLst>
-          </p:cNvPr>
-          <p:cNvPicPr preferRelativeResize="0"/>
-          <p:nvPr/>
-        </p:nvPicPr>
-        <p:blipFill rotWithShape="1">
-          <a:blip r:embed="rId3">
-            <a:alphaModFix/>
-          </a:blip>
-          <a:srcRect/>
-          <a:stretch/>
-        </p:blipFill>
-        <p:spPr>
-          <a:xfrm>
-            <a:off x="11557509" y="233819"/>
-            <a:ext cx="271308" cy="389810"/>
-          </a:xfrm>
-          <a:prstGeom prst="rect">
-            <a:avLst/>
-          </a:prstGeom>
-          <a:noFill/>
-          <a:ln>
-            <a:noFill/>
-          </a:ln>
-        </p:spPr>
-      </p:pic>
-      <p:sp>
-        <p:nvSpPr>
-          <p:cNvPr id="122" name="Google Shape;122;p29">
-            <a:extLst>
-              <a:ext uri="{FF2B5EF4-FFF2-40B4-BE49-F238E27FC236}">
-                <a16:creationId xmlns:a16="http://schemas.microsoft.com/office/drawing/2014/main" id="{D52648EA-0120-942E-FA7D-98B9C25F4F34}"/>
-              </a:ext>
-            </a:extLst>
-          </p:cNvPr>
-          <p:cNvSpPr txBox="1"/>
-          <p:nvPr/>
-        </p:nvSpPr>
-        <p:spPr>
-          <a:xfrm>
-            <a:off x="9335597" y="6524381"/>
-            <a:ext cx="2473415" cy="230792"/>
-          </a:xfrm>
-          <a:prstGeom prst="rect">
-            <a:avLst/>
-          </a:prstGeom>
-          <a:noFill/>
-          <a:ln>
-            <a:noFill/>
-          </a:ln>
-        </p:spPr>
-        <p:txBody>
-          <a:bodyPr spcFirstLastPara="1" wrap="square" lIns="91425" tIns="45700" rIns="91425" bIns="45700" anchor="t" anchorCtr="0">
-            <a:spAutoFit/>
-          </a:bodyPr>
-          <a:lstStyle/>
-          <a:p>
-            <a:pPr marL="0" marR="0" lvl="0" indent="0" algn="r" rtl="0">
-              <a:lnSpc>
-                <a:spcPct val="100000"/>
-              </a:lnSpc>
-              <a:spcBef>
-                <a:spcPts val="0"/>
-              </a:spcBef>
-              <a:spcAft>
-                <a:spcPts val="0"/>
-              </a:spcAft>
-              <a:buNone/>
-            </a:pPr>
-            <a:r>
-              <a:rPr lang="en-US" sz="900" b="0" i="0" u="none" strike="noStrike" cap="none">
-                <a:solidFill>
-                  <a:srgbClr val="13294B"/>
-                </a:solidFill>
-                <a:latin typeface="Arial"/>
-                <a:ea typeface="Arial"/>
-                <a:cs typeface="Arial"/>
-                <a:sym typeface="Arial"/>
-              </a:rPr>
-              <a:t>GRAINGER ENGINEERING</a:t>
-            </a:r>
-            <a:endParaRPr/>
-          </a:p>
-        </p:txBody>
-      </p:sp>
-      <p:sp>
-        <p:nvSpPr>
-          <p:cNvPr id="123" name="Google Shape;123;p29">
-            <a:extLst>
-              <a:ext uri="{FF2B5EF4-FFF2-40B4-BE49-F238E27FC236}">
-                <a16:creationId xmlns:a16="http://schemas.microsoft.com/office/drawing/2014/main" id="{9187DBB9-03BE-10E2-9B63-400A9675CEAD}"/>
-              </a:ext>
-            </a:extLst>
-          </p:cNvPr>
-          <p:cNvSpPr txBox="1"/>
-          <p:nvPr/>
-        </p:nvSpPr>
-        <p:spPr>
-          <a:xfrm>
-            <a:off x="376807" y="6524381"/>
-            <a:ext cx="7991337" cy="230792"/>
-          </a:xfrm>
-          <a:prstGeom prst="rect">
-            <a:avLst/>
-          </a:prstGeom>
-          <a:noFill/>
-          <a:ln>
-            <a:noFill/>
-          </a:ln>
-        </p:spPr>
-        <p:txBody>
-          <a:bodyPr spcFirstLastPara="1" wrap="square" lIns="91425" tIns="45700" rIns="91425" bIns="45700" anchor="t" anchorCtr="0">
-            <a:spAutoFit/>
-          </a:bodyPr>
-          <a:lstStyle/>
-          <a:p>
-            <a:pPr marL="0" marR="0" lvl="0" indent="0" algn="l" rtl="0">
-              <a:lnSpc>
-                <a:spcPct val="100000"/>
-              </a:lnSpc>
-              <a:spcBef>
-                <a:spcPts val="0"/>
-              </a:spcBef>
-              <a:spcAft>
-                <a:spcPts val="0"/>
-              </a:spcAft>
-              <a:buNone/>
-            </a:pPr>
-            <a:r>
-              <a:rPr lang="en-US" sz="900" dirty="0">
-                <a:solidFill>
-                  <a:srgbClr val="13294B"/>
-                </a:solidFill>
-              </a:rPr>
-              <a:t>SYSTEMS ENGINEERING </a:t>
-            </a:r>
-            <a:endParaRPr dirty="0"/>
-          </a:p>
-        </p:txBody>
-      </p:sp>
-      <p:grpSp>
-        <p:nvGrpSpPr>
-          <p:cNvPr id="124" name="Google Shape;124;p29">
-            <a:extLst>
-              <a:ext uri="{FF2B5EF4-FFF2-40B4-BE49-F238E27FC236}">
-                <a16:creationId xmlns:a16="http://schemas.microsoft.com/office/drawing/2014/main" id="{73B542CF-2028-95AA-CCEF-91A8D02AD178}"/>
-              </a:ext>
-            </a:extLst>
-          </p:cNvPr>
-          <p:cNvGrpSpPr/>
-          <p:nvPr/>
-        </p:nvGrpSpPr>
-        <p:grpSpPr>
-          <a:xfrm>
-            <a:off x="4066674" y="6601537"/>
-            <a:ext cx="5233412" cy="70446"/>
-            <a:chOff x="4033424" y="6601537"/>
-            <a:chExt cx="5233412" cy="70446"/>
-          </a:xfrm>
-        </p:grpSpPr>
-        <p:cxnSp>
-          <p:nvCxnSpPr>
-            <p:cNvPr id="125" name="Google Shape;125;p29">
-              <a:extLst>
-                <a:ext uri="{FF2B5EF4-FFF2-40B4-BE49-F238E27FC236}">
-                  <a16:creationId xmlns:a16="http://schemas.microsoft.com/office/drawing/2014/main" id="{33141631-F3ED-2759-4D92-932A85BC40E3}"/>
-                </a:ext>
-              </a:extLst>
-            </p:cNvPr>
-            <p:cNvCxnSpPr/>
-            <p:nvPr/>
-          </p:nvCxnSpPr>
-          <p:spPr>
-            <a:xfrm rot="10800000">
-              <a:off x="4033424" y="6639606"/>
-              <a:ext cx="5164651" cy="0"/>
-            </a:xfrm>
-            <a:prstGeom prst="straightConnector1">
-              <a:avLst/>
-            </a:prstGeom>
-            <a:noFill/>
-            <a:ln w="9525" cap="flat" cmpd="sng">
-              <a:solidFill>
-                <a:srgbClr val="13294B"/>
-              </a:solidFill>
-              <a:prstDash val="solid"/>
-              <a:round/>
-              <a:headEnd type="none" w="sm" len="sm"/>
-              <a:tailEnd type="none" w="sm" len="sm"/>
-            </a:ln>
-          </p:spPr>
-        </p:cxnSp>
-        <p:sp>
-          <p:nvSpPr>
-            <p:cNvPr id="126" name="Google Shape;126;p29">
-              <a:extLst>
-                <a:ext uri="{FF2B5EF4-FFF2-40B4-BE49-F238E27FC236}">
-                  <a16:creationId xmlns:a16="http://schemas.microsoft.com/office/drawing/2014/main" id="{E4D9BF8E-CB10-CAD2-7648-4939A5B564E5}"/>
-                </a:ext>
-              </a:extLst>
-            </p:cNvPr>
-            <p:cNvSpPr/>
-            <p:nvPr/>
-          </p:nvSpPr>
-          <p:spPr>
-            <a:xfrm>
-              <a:off x="9196390" y="6601537"/>
-              <a:ext cx="70446" cy="70446"/>
-            </a:xfrm>
-            <a:prstGeom prst="ellipse">
-              <a:avLst/>
-            </a:prstGeom>
-            <a:solidFill>
-              <a:srgbClr val="13294B"/>
-            </a:solidFill>
-            <a:ln>
-              <a:noFill/>
-            </a:ln>
-          </p:spPr>
-          <p:txBody>
-            <a:bodyPr spcFirstLastPara="1" wrap="square" lIns="91425" tIns="45700" rIns="91425" bIns="45700" anchor="ctr" anchorCtr="0">
-              <a:noAutofit/>
-            </a:bodyPr>
-            <a:lstStyle/>
-            <a:p>
-              <a:pPr marL="0" marR="0" lvl="0" indent="0" algn="ctr" rtl="0">
-                <a:lnSpc>
-                  <a:spcPct val="100000"/>
-                </a:lnSpc>
-                <a:spcBef>
-                  <a:spcPts val="0"/>
-                </a:spcBef>
-                <a:spcAft>
-                  <a:spcPts val="0"/>
-                </a:spcAft>
-                <a:buNone/>
-              </a:pPr>
-              <a:endParaRPr sz="1400" b="0" i="0" u="none" strike="noStrike" cap="none">
-                <a:solidFill>
-                  <a:srgbClr val="13294B"/>
-                </a:solidFill>
-                <a:latin typeface="Arial"/>
-                <a:ea typeface="Arial"/>
-                <a:cs typeface="Arial"/>
-                <a:sym typeface="Arial"/>
-              </a:endParaRPr>
-            </a:p>
-          </p:txBody>
-        </p:sp>
-      </p:grpSp>
-    </p:spTree>
-    <p:extLst>
-      <p:ext uri="{BB962C8B-B14F-4D97-AF65-F5344CB8AC3E}">
-        <p14:creationId xmlns:p14="http://schemas.microsoft.com/office/powerpoint/2010/main" val="1702080834"/>
-      </p:ext>
-    </p:extLst>
-  </p:cSld>
-  <p:clrMapOvr>
-    <a:masterClrMapping/>
-  </p:clrMapOvr>
-</p:sld>
-</file>
-
-<file path=ppt/slides/slide20.xml><?xml version="1.0" encoding="utf-8"?>
+<file path=ppt/slides/slide21.xml><?xml version="1.0" encoding="utf-8"?>
 <p:sld xmlns:a="http://schemas.openxmlformats.org/drawingml/2006/main" xmlns:r="http://schemas.openxmlformats.org/officeDocument/2006/relationships" xmlns:p="http://schemas.openxmlformats.org/presentationml/2006/main">
   <p:cSld>
     <p:bg>
@@ -23469,17 +24504,31 @@
                 <a:cs typeface="Arial"/>
                 <a:sym typeface="Arial"/>
               </a:rPr>
-              <a:t>Starting Lab X this week. This a X-week lab!</a:t>
+              <a:t>Starting Lab 6 this week. This a 3-week lab!</a:t>
             </a:r>
-            <a:endParaRPr lang="en-US" sz="1800" dirty="0">
-              <a:solidFill>
-                <a:srgbClr val="E84B36"/>
-              </a:solidFill>
-              <a:latin typeface="Arial"/>
-              <a:ea typeface="Arial"/>
-              <a:cs typeface="Arial"/>
-              <a:sym typeface="Arial"/>
-            </a:endParaRPr>
+          </a:p>
+          <a:p>
+            <a:pPr marL="285750" indent="-285750">
+              <a:lnSpc>
+                <a:spcPct val="100000"/>
+              </a:lnSpc>
+              <a:spcBef>
+                <a:spcPts val="0"/>
+              </a:spcBef>
+              <a:buSzPts val="3000"/>
+            </a:pPr>
+            <a:r>
+              <a:rPr lang="en-US" sz="1800" dirty="0">
+                <a:solidFill>
+                  <a:schemeClr val="tx1"/>
+                </a:solidFill>
+                <a:latin typeface="Arial"/>
+                <a:ea typeface="Arial"/>
+                <a:cs typeface="Arial"/>
+                <a:sym typeface="Arial"/>
+              </a:rPr>
+              <a:t>Don’t forget to have the Lab LabVIEW application implemented before lab.</a:t>
+            </a:r>
           </a:p>
           <a:p>
             <a:pPr marL="0" indent="0">
@@ -23555,14 +24604,156 @@
                 <a:cs typeface="Arial"/>
                 <a:sym typeface="Arial"/>
               </a:rPr>
-              <a:t>Check-offs for …</a:t>
+              <a:t>Check-offs for </a:t>
             </a:r>
-            <a:endParaRPr lang="en-US" sz="1800" b="1" dirty="0">
+            <a:r>
+              <a:rPr lang="en-US" sz="1800" dirty="0">
+                <a:latin typeface="Arial"/>
+                <a:ea typeface="Arial"/>
+                <a:cs typeface="Arial"/>
+                <a:sym typeface="Arial"/>
+                <a:hlinkClick r:id="rId3"/>
+              </a:rPr>
+              <a:t>homework 4</a:t>
+            </a:r>
+            <a:r>
+              <a:rPr lang="en-US" sz="1800" dirty="0">
+                <a:latin typeface="Arial"/>
+                <a:ea typeface="Arial"/>
+                <a:cs typeface="Arial"/>
+                <a:sym typeface="Arial"/>
+              </a:rPr>
+              <a:t> Ex 2 and 3 are due </a:t>
+            </a:r>
+            <a:r>
+              <a:rPr lang="en-US" sz="1800" b="1" dirty="0">
+                <a:latin typeface="Arial"/>
+                <a:ea typeface="Arial"/>
+                <a:cs typeface="Arial"/>
+                <a:sym typeface="Arial"/>
+              </a:rPr>
+              <a:t>March 31, 5PM (The end of office hours)</a:t>
+            </a:r>
+            <a:endParaRPr lang="en-US" sz="1800" dirty="0">
               <a:latin typeface="Arial"/>
               <a:ea typeface="Arial"/>
               <a:cs typeface="Arial"/>
               <a:sym typeface="Arial"/>
             </a:endParaRPr>
+          </a:p>
+          <a:p>
+            <a:pPr marL="285750" indent="-285750">
+              <a:lnSpc>
+                <a:spcPct val="100000"/>
+              </a:lnSpc>
+              <a:spcBef>
+                <a:spcPts val="0"/>
+              </a:spcBef>
+              <a:buSzPts val="3000"/>
+            </a:pPr>
+            <a:r>
+              <a:rPr lang="en-US" sz="1800" dirty="0">
+                <a:latin typeface="Arial"/>
+                <a:ea typeface="Arial"/>
+                <a:cs typeface="Arial"/>
+                <a:sym typeface="Arial"/>
+              </a:rPr>
+              <a:t>Check-offs for </a:t>
+            </a:r>
+            <a:r>
+              <a:rPr lang="en-US" sz="1800" dirty="0">
+                <a:latin typeface="Arial"/>
+                <a:ea typeface="Arial"/>
+                <a:cs typeface="Arial"/>
+                <a:sym typeface="Arial"/>
+                <a:hlinkClick r:id="rId3"/>
+              </a:rPr>
+              <a:t>homework 4</a:t>
+            </a:r>
+            <a:r>
+              <a:rPr lang="en-US" sz="1800" dirty="0">
+                <a:latin typeface="Arial"/>
+                <a:ea typeface="Arial"/>
+                <a:cs typeface="Arial"/>
+                <a:sym typeface="Arial"/>
+              </a:rPr>
+              <a:t> Ex 4 are due </a:t>
+            </a:r>
+            <a:r>
+              <a:rPr lang="en-US" sz="1800" b="1" dirty="0">
+                <a:latin typeface="Arial"/>
+                <a:ea typeface="Arial"/>
+                <a:cs typeface="Arial"/>
+                <a:sym typeface="Arial"/>
+              </a:rPr>
+              <a:t>April 7, 5PM (The end of office hours)</a:t>
+            </a:r>
+          </a:p>
+          <a:p>
+            <a:pPr marL="285750" indent="-285750">
+              <a:lnSpc>
+                <a:spcPct val="100000"/>
+              </a:lnSpc>
+              <a:spcBef>
+                <a:spcPts val="0"/>
+              </a:spcBef>
+              <a:buSzPts val="3000"/>
+            </a:pPr>
+            <a:r>
+              <a:rPr lang="en-US" sz="1800" dirty="0">
+                <a:latin typeface="Arial"/>
+                <a:ea typeface="Arial"/>
+                <a:cs typeface="Arial"/>
+                <a:sym typeface="Arial"/>
+              </a:rPr>
+              <a:t>Remainder of </a:t>
+            </a:r>
+            <a:r>
+              <a:rPr lang="en-US" sz="1800" dirty="0">
+                <a:latin typeface="Arial"/>
+                <a:ea typeface="Arial"/>
+                <a:cs typeface="Arial"/>
+                <a:sym typeface="Arial"/>
+                <a:hlinkClick r:id="rId3"/>
+              </a:rPr>
+              <a:t>homework 4</a:t>
+            </a:r>
+            <a:r>
+              <a:rPr lang="en-US" sz="1800" dirty="0">
+                <a:latin typeface="Arial"/>
+                <a:ea typeface="Arial"/>
+                <a:cs typeface="Arial"/>
+                <a:sym typeface="Arial"/>
+              </a:rPr>
+              <a:t> due on </a:t>
+            </a:r>
+            <a:r>
+              <a:rPr lang="en-US" sz="1800" dirty="0" err="1">
+                <a:latin typeface="Arial"/>
+                <a:ea typeface="Arial"/>
+                <a:cs typeface="Arial"/>
+                <a:sym typeface="Arial"/>
+              </a:rPr>
+              <a:t>Gradescope</a:t>
+            </a:r>
+            <a:r>
+              <a:rPr lang="en-US" sz="1800" dirty="0">
+                <a:latin typeface="Arial"/>
+                <a:ea typeface="Arial"/>
+                <a:cs typeface="Arial"/>
+                <a:sym typeface="Arial"/>
+              </a:rPr>
+              <a:t> on </a:t>
+            </a:r>
+            <a:r>
+              <a:rPr lang="en-US" sz="1800" b="1" dirty="0">
+                <a:latin typeface="Arial"/>
+                <a:ea typeface="Arial"/>
+                <a:cs typeface="Arial"/>
+                <a:sym typeface="Arial"/>
+              </a:rPr>
+              <a:t>April 8, 9AM</a:t>
+            </a:r>
           </a:p>
         </p:txBody>
       </p:sp>
@@ -23713,7 +24904,7 @@
           <p:nvPr/>
         </p:nvPicPr>
         <p:blipFill rotWithShape="1">
-          <a:blip r:embed="rId3">
+          <a:blip r:embed="rId4">
             <a:alphaModFix/>
           </a:blip>
           <a:srcRect/>
@@ -24543,8 +25734,8 @@
         </p:nvSpPr>
         <p:spPr>
           <a:xfrm>
-            <a:off x="1295400" y="2948490"/>
-            <a:ext cx="9601200" cy="1338788"/>
+            <a:off x="1295400" y="3225489"/>
+            <a:ext cx="9601200" cy="784790"/>
           </a:xfrm>
           <a:prstGeom prst="rect">
             <a:avLst/>
@@ -24578,7 +25769,7 @@
               <a:buNone/>
             </a:pPr>
             <a:r>
-              <a:rPr lang="en-US" sz="4500" b="1" i="0" u="none" strike="noStrike" cap="none">
+              <a:rPr lang="en-US" sz="4500" b="1" i="0" u="none" strike="noStrike" cap="none" dirty="0">
                 <a:solidFill>
                   <a:srgbClr val="15264B"/>
                 </a:solidFill>
@@ -24587,64 +25778,9 @@
                 <a:cs typeface="Arial"/>
                 <a:sym typeface="Arial"/>
               </a:rPr>
-              <a:t>Heading</a:t>
+              <a:t>Path planning</a:t>
             </a:r>
-            <a:endParaRPr/>
-          </a:p>
-          <a:p>
-            <a:pPr marL="0" marR="0" lvl="0" indent="0" algn="ctr" rtl="0">
-              <a:lnSpc>
-                <a:spcPct val="100000"/>
-              </a:lnSpc>
-              <a:spcBef>
-                <a:spcPts val="0"/>
-              </a:spcBef>
-              <a:spcAft>
-                <a:spcPts val="0"/>
-              </a:spcAft>
-              <a:buClr>
-                <a:srgbClr val="000000"/>
-              </a:buClr>
-              <a:buSzPts val="1800"/>
-              <a:buFont typeface="Arial"/>
-              <a:buNone/>
-            </a:pPr>
-            <a:endParaRPr sz="1800" b="1" i="0" u="none" strike="noStrike" cap="none">
-              <a:solidFill>
-                <a:srgbClr val="15264B"/>
-              </a:solidFill>
-              <a:latin typeface="Arial"/>
-              <a:ea typeface="Arial"/>
-              <a:cs typeface="Arial"/>
-              <a:sym typeface="Arial"/>
-            </a:endParaRPr>
-          </a:p>
-          <a:p>
-            <a:pPr marL="0" marR="0" lvl="0" indent="0" algn="ctr" rtl="0">
-              <a:lnSpc>
-                <a:spcPct val="100000"/>
-              </a:lnSpc>
-              <a:spcBef>
-                <a:spcPts val="0"/>
-              </a:spcBef>
-              <a:spcAft>
-                <a:spcPts val="0"/>
-              </a:spcAft>
-              <a:buNone/>
-            </a:pPr>
-            <a:r>
-              <a:rPr lang="en-US" sz="1800" b="0" i="0" u="none" strike="noStrike" cap="none">
-                <a:solidFill>
-                  <a:srgbClr val="15264B"/>
-                </a:solidFill>
-                <a:latin typeface="Arial"/>
-                <a:ea typeface="Arial"/>
-                <a:cs typeface="Arial"/>
-                <a:sym typeface="Arial"/>
-              </a:rPr>
-              <a:t>(Main section divider slide option two, or transition slide.)</a:t>
-            </a:r>
-            <a:endParaRPr sz="1800" b="0" i="0" u="none" strike="noStrike" cap="none">
+            <a:endParaRPr sz="1800" b="0" i="0" u="none" strike="noStrike" cap="none" dirty="0">
               <a:solidFill>
                 <a:srgbClr val="15264B"/>
               </a:solidFill>
@@ -25021,13 +26157,94 @@
               <a:buNone/>
             </a:pPr>
             <a:r>
-              <a:rPr lang="en-US" sz="2400">
+              <a:rPr lang="en-US" sz="2400" dirty="0">
                 <a:latin typeface="Arial"/>
                 <a:ea typeface="Arial"/>
                 <a:cs typeface="Arial"/>
                 <a:sym typeface="Arial"/>
               </a:rPr>
-              <a:t>Empt</a:t>
+              <a:t>I would HIGHLY recommend you looking at:</a:t>
+            </a:r>
+          </a:p>
+          <a:p>
+            <a:pPr marL="0" indent="0">
+              <a:lnSpc>
+                <a:spcPct val="100000"/>
+              </a:lnSpc>
+              <a:spcBef>
+                <a:spcPts val="0"/>
+              </a:spcBef>
+              <a:buSzPts val="3000"/>
+              <a:buNone/>
+            </a:pPr>
+            <a:endParaRPr lang="en-US" sz="2400" dirty="0">
+              <a:solidFill>
+                <a:schemeClr val="dk1"/>
+              </a:solidFill>
+              <a:latin typeface="Arial"/>
+              <a:ea typeface="Arial"/>
+              <a:cs typeface="Arial"/>
+              <a:sym typeface="Arial"/>
+            </a:endParaRPr>
+          </a:p>
+          <a:p>
+            <a:pPr marL="342900">
+              <a:lnSpc>
+                <a:spcPct val="100000"/>
+              </a:lnSpc>
+              <a:spcBef>
+                <a:spcPts val="0"/>
+              </a:spcBef>
+              <a:buSzPts val="3000"/>
+            </a:pPr>
+            <a:r>
+              <a:rPr lang="en-US" sz="2350" dirty="0">
+                <a:latin typeface="Arial"/>
+                <a:ea typeface="Arial"/>
+                <a:cs typeface="Arial"/>
+                <a:sym typeface="Arial"/>
+                <a:hlinkClick r:id="rId3"/>
+              </a:rPr>
+              <a:t>https://theory.stanford.edu/~amitp/GameProgramming/MapRepresentations.html</a:t>
+            </a:r>
+            <a:r>
+              <a:rPr lang="en-US" sz="2350" dirty="0">
+                <a:latin typeface="Arial"/>
+                <a:ea typeface="Arial"/>
+                <a:cs typeface="Arial"/>
+                <a:sym typeface="Arial"/>
+              </a:rPr>
+              <a:t> </a:t>
+            </a:r>
+            <a:endParaRPr lang="en-US" sz="2350" dirty="0">
+              <a:solidFill>
+                <a:schemeClr val="dk1"/>
+              </a:solidFill>
+              <a:latin typeface="Arial"/>
+              <a:ea typeface="Arial"/>
+              <a:cs typeface="Arial"/>
+              <a:sym typeface="Arial"/>
+            </a:endParaRPr>
+          </a:p>
+          <a:p>
+            <a:pPr marL="342900">
+              <a:lnSpc>
+                <a:spcPct val="100000"/>
+              </a:lnSpc>
+              <a:spcBef>
+                <a:spcPts val="0"/>
+              </a:spcBef>
+              <a:buSzPts val="3000"/>
+            </a:pPr>
+            <a:r>
+              <a:rPr lang="en-US" sz="2400" dirty="0">
+                <a:latin typeface="Arial"/>
+                <a:ea typeface="Arial"/>
+                <a:cs typeface="Arial"/>
+                <a:sym typeface="Arial"/>
+                <a:hlinkClick r:id="rId4"/>
+              </a:rPr>
+              <a:t>https://www.redblobgames.com/pathfinding/a-star/introduction.html</a:t>
             </a:r>
             <a:r>
               <a:rPr lang="en-US" sz="2400" dirty="0">
@@ -25036,7 +26253,49 @@
                 <a:cs typeface="Arial"/>
                 <a:sym typeface="Arial"/>
               </a:rPr>
-              <a:t>y</a:t>
+              <a:t> </a:t>
+            </a:r>
+          </a:p>
+          <a:p>
+            <a:pPr marL="0" indent="0">
+              <a:lnSpc>
+                <a:spcPct val="100000"/>
+              </a:lnSpc>
+              <a:spcBef>
+                <a:spcPts val="0"/>
+              </a:spcBef>
+              <a:buSzPts val="3000"/>
+              <a:buNone/>
+            </a:pPr>
+            <a:endParaRPr lang="en-US" sz="2400" dirty="0">
+              <a:solidFill>
+                <a:schemeClr val="dk1"/>
+              </a:solidFill>
+              <a:latin typeface="Arial"/>
+              <a:ea typeface="Arial"/>
+              <a:cs typeface="Arial"/>
+              <a:sym typeface="Arial"/>
+            </a:endParaRPr>
+          </a:p>
+          <a:p>
+            <a:pPr marL="0" indent="0">
+              <a:lnSpc>
+                <a:spcPct val="100000"/>
+              </a:lnSpc>
+              <a:spcBef>
+                <a:spcPts val="0"/>
+              </a:spcBef>
+              <a:buSzPts val="3000"/>
+              <a:buNone/>
+            </a:pPr>
+            <a:r>
+              <a:rPr lang="en-US" sz="2400" dirty="0">
+                <a:latin typeface="Arial"/>
+                <a:ea typeface="Arial"/>
+                <a:cs typeface="Arial"/>
+                <a:sym typeface="Arial"/>
+              </a:rPr>
+              <a:t>This is a series of interactable tutorial for path planning, it is very useful and goes through all the material in this lecture!</a:t>
             </a:r>
             <a:endParaRPr lang="en-US" sz="2400" dirty="0">
               <a:solidFill>
@@ -25161,12 +26420,16 @@
               <a:buNone/>
             </a:pPr>
             <a:r>
-              <a:rPr lang="en-US" sz="2400" dirty="0">
+              <a:rPr lang="en-US" sz="2400" b="0" i="0" u="none" strike="noStrike" cap="none" dirty="0">
                 <a:solidFill>
                   <a:schemeClr val="lt1"/>
                 </a:solidFill>
+                <a:latin typeface="Arial"/>
+                <a:ea typeface="Arial"/>
+                <a:cs typeface="Arial"/>
+                <a:sym typeface="Arial"/>
               </a:rPr>
-              <a:t>Empty</a:t>
+              <a:t>Preface</a:t>
             </a:r>
             <a:endParaRPr sz="2400" b="0" i="0" u="none" strike="noStrike" cap="none" dirty="0">
               <a:solidFill>
@@ -25193,7 +26456,7 @@
           <p:nvPr/>
         </p:nvPicPr>
         <p:blipFill rotWithShape="1">
-          <a:blip r:embed="rId3">
+          <a:blip r:embed="rId5">
             <a:alphaModFix/>
           </a:blip>
           <a:srcRect/>
@@ -25455,6 +26718,504 @@
   <p:cSld>
     <p:spTree>
       <p:nvGrpSpPr>
+        <p:cNvPr id="1" name="Shape 117">
+          <a:extLst>
+            <a:ext uri="{FF2B5EF4-FFF2-40B4-BE49-F238E27FC236}">
+              <a16:creationId xmlns:a16="http://schemas.microsoft.com/office/drawing/2014/main" id="{CAB31BED-0250-AE07-2DD3-6A6C2EB391E4}"/>
+            </a:ext>
+          </a:extLst>
+        </p:cNvPr>
+        <p:cNvGrpSpPr/>
+        <p:nvPr/>
+      </p:nvGrpSpPr>
+      <p:grpSpPr>
+        <a:xfrm>
+          <a:off x="0" y="0"/>
+          <a:ext cx="0" cy="0"/>
+          <a:chOff x="0" y="0"/>
+          <a:chExt cx="0" cy="0"/>
+        </a:xfrm>
+      </p:grpSpPr>
+      <p:sp>
+        <p:nvSpPr>
+          <p:cNvPr id="118" name="Google Shape;118;p29">
+            <a:extLst>
+              <a:ext uri="{FF2B5EF4-FFF2-40B4-BE49-F238E27FC236}">
+                <a16:creationId xmlns:a16="http://schemas.microsoft.com/office/drawing/2014/main" id="{2BE0E2B7-1369-7096-6138-7E551BF623EA}"/>
+              </a:ext>
+            </a:extLst>
+          </p:cNvPr>
+          <p:cNvSpPr txBox="1">
+            <a:spLocks noGrp="1"/>
+          </p:cNvSpPr>
+          <p:nvPr>
+            <p:ph type="body" idx="1"/>
+          </p:nvPr>
+        </p:nvSpPr>
+        <p:spPr>
+          <a:xfrm>
+            <a:off x="376809" y="1334279"/>
+            <a:ext cx="11177401" cy="4821102"/>
+          </a:xfrm>
+          <a:prstGeom prst="rect">
+            <a:avLst/>
+          </a:prstGeom>
+          <a:noFill/>
+          <a:ln>
+            <a:noFill/>
+          </a:ln>
+        </p:spPr>
+        <p:txBody>
+          <a:bodyPr spcFirstLastPara="1" wrap="square" lIns="91425" tIns="45700" rIns="91425" bIns="45700" anchor="t" anchorCtr="0">
+            <a:noAutofit/>
+          </a:bodyPr>
+          <a:lstStyle/>
+          <a:p>
+            <a:pPr marL="0" indent="0">
+              <a:lnSpc>
+                <a:spcPct val="100000"/>
+              </a:lnSpc>
+              <a:spcBef>
+                <a:spcPts val="0"/>
+              </a:spcBef>
+              <a:buSzPts val="3000"/>
+              <a:buNone/>
+            </a:pPr>
+            <a:r>
+              <a:rPr lang="en-US" sz="2400">
+                <a:latin typeface="Arial"/>
+                <a:ea typeface="Arial"/>
+                <a:cs typeface="Arial"/>
+                <a:sym typeface="Arial"/>
+              </a:rPr>
+              <a:t>Empt</a:t>
+            </a:r>
+            <a:r>
+              <a:rPr lang="en-US" sz="2400" dirty="0">
+                <a:latin typeface="Arial"/>
+                <a:ea typeface="Arial"/>
+                <a:cs typeface="Arial"/>
+                <a:sym typeface="Arial"/>
+              </a:rPr>
+              <a:t>y</a:t>
+            </a:r>
+            <a:endParaRPr lang="en-US" sz="2400" dirty="0">
+              <a:solidFill>
+                <a:schemeClr val="dk1"/>
+              </a:solidFill>
+              <a:latin typeface="Arial"/>
+              <a:ea typeface="Arial"/>
+              <a:cs typeface="Arial"/>
+              <a:sym typeface="Arial"/>
+            </a:endParaRPr>
+          </a:p>
+        </p:txBody>
+      </p:sp>
+      <p:sp>
+        <p:nvSpPr>
+          <p:cNvPr id="119" name="Google Shape;119;p29">
+            <a:extLst>
+              <a:ext uri="{FF2B5EF4-FFF2-40B4-BE49-F238E27FC236}">
+                <a16:creationId xmlns:a16="http://schemas.microsoft.com/office/drawing/2014/main" id="{2682A598-1CAE-743D-E80B-FC85664EA1D1}"/>
+              </a:ext>
+            </a:extLst>
+          </p:cNvPr>
+          <p:cNvSpPr/>
+          <p:nvPr/>
+        </p:nvSpPr>
+        <p:spPr>
+          <a:xfrm rot="10800000" flipH="1">
+            <a:off x="0" y="0"/>
+            <a:ext cx="12192000" cy="868220"/>
+          </a:xfrm>
+          <a:prstGeom prst="rect">
+            <a:avLst/>
+          </a:prstGeom>
+          <a:solidFill>
+            <a:srgbClr val="13294B"/>
+          </a:solidFill>
+          <a:ln>
+            <a:noFill/>
+          </a:ln>
+        </p:spPr>
+        <p:txBody>
+          <a:bodyPr spcFirstLastPara="1" wrap="square" lIns="91425" tIns="45700" rIns="91425" bIns="45700" anchor="ctr" anchorCtr="0">
+            <a:noAutofit/>
+          </a:bodyPr>
+          <a:lstStyle/>
+          <a:p>
+            <a:pPr marL="0" marR="0" lvl="0" indent="0" algn="ctr" rtl="0">
+              <a:lnSpc>
+                <a:spcPct val="100000"/>
+              </a:lnSpc>
+              <a:spcBef>
+                <a:spcPts val="0"/>
+              </a:spcBef>
+              <a:spcAft>
+                <a:spcPts val="0"/>
+              </a:spcAft>
+              <a:buClr>
+                <a:schemeClr val="lt1"/>
+              </a:buClr>
+              <a:buSzPts val="1800"/>
+              <a:buFont typeface="Calibri"/>
+              <a:buNone/>
+            </a:pPr>
+            <a:endParaRPr sz="1800" b="0" i="0" u="none" strike="noStrike" cap="none">
+              <a:solidFill>
+                <a:srgbClr val="13294B"/>
+              </a:solidFill>
+              <a:latin typeface="Calibri"/>
+              <a:ea typeface="Calibri"/>
+              <a:cs typeface="Calibri"/>
+              <a:sym typeface="Calibri"/>
+            </a:endParaRPr>
+          </a:p>
+        </p:txBody>
+      </p:sp>
+      <p:sp>
+        <p:nvSpPr>
+          <p:cNvPr id="120" name="Google Shape;120;p29">
+            <a:extLst>
+              <a:ext uri="{FF2B5EF4-FFF2-40B4-BE49-F238E27FC236}">
+                <a16:creationId xmlns:a16="http://schemas.microsoft.com/office/drawing/2014/main" id="{4B266D89-781E-9220-8AD5-217ECD89B6DF}"/>
+              </a:ext>
+            </a:extLst>
+          </p:cNvPr>
+          <p:cNvSpPr txBox="1"/>
+          <p:nvPr/>
+        </p:nvSpPr>
+        <p:spPr>
+          <a:xfrm>
+            <a:off x="376810" y="204051"/>
+            <a:ext cx="10910026" cy="461624"/>
+          </a:xfrm>
+          <a:prstGeom prst="rect">
+            <a:avLst/>
+          </a:prstGeom>
+          <a:noFill/>
+          <a:ln>
+            <a:noFill/>
+          </a:ln>
+        </p:spPr>
+        <p:txBody>
+          <a:bodyPr spcFirstLastPara="1" wrap="square" lIns="91425" tIns="45700" rIns="91425" bIns="45700" anchor="t" anchorCtr="0">
+            <a:spAutoFit/>
+          </a:bodyPr>
+          <a:lstStyle/>
+          <a:p>
+            <a:pPr marL="0" marR="0" lvl="0" indent="0" algn="l" rtl="0">
+              <a:lnSpc>
+                <a:spcPct val="100000"/>
+              </a:lnSpc>
+              <a:spcBef>
+                <a:spcPts val="0"/>
+              </a:spcBef>
+              <a:spcAft>
+                <a:spcPts val="0"/>
+              </a:spcAft>
+              <a:buClr>
+                <a:srgbClr val="000000"/>
+              </a:buClr>
+              <a:buSzPts val="2400"/>
+              <a:buFont typeface="Arial"/>
+              <a:buNone/>
+            </a:pPr>
+            <a:r>
+              <a:rPr lang="en-US" sz="2400" dirty="0">
+                <a:solidFill>
+                  <a:schemeClr val="lt1"/>
+                </a:solidFill>
+              </a:rPr>
+              <a:t>Empty</a:t>
+            </a:r>
+            <a:endParaRPr sz="2400" b="0" i="0" u="none" strike="noStrike" cap="none" dirty="0">
+              <a:solidFill>
+                <a:schemeClr val="lt1"/>
+              </a:solidFill>
+              <a:latin typeface="Arial"/>
+              <a:ea typeface="Arial"/>
+              <a:cs typeface="Arial"/>
+              <a:sym typeface="Arial"/>
+            </a:endParaRPr>
+          </a:p>
+        </p:txBody>
+      </p:sp>
+      <p:pic>
+        <p:nvPicPr>
+          <p:cNvPr id="121" name="Google Shape;121;p29">
+            <a:extLst>
+              <a:ext uri="{FF2B5EF4-FFF2-40B4-BE49-F238E27FC236}">
+                <a16:creationId xmlns:a16="http://schemas.microsoft.com/office/drawing/2014/main" id="{947035C2-EF7A-764A-381D-DBD204849F95}"/>
+              </a:ext>
+            </a:extLst>
+          </p:cNvPr>
+          <p:cNvPicPr preferRelativeResize="0"/>
+          <p:nvPr/>
+        </p:nvPicPr>
+        <p:blipFill rotWithShape="1">
+          <a:blip r:embed="rId3">
+            <a:alphaModFix/>
+          </a:blip>
+          <a:srcRect/>
+          <a:stretch/>
+        </p:blipFill>
+        <p:spPr>
+          <a:xfrm>
+            <a:off x="11557509" y="233819"/>
+            <a:ext cx="271308" cy="389810"/>
+          </a:xfrm>
+          <a:prstGeom prst="rect">
+            <a:avLst/>
+          </a:prstGeom>
+          <a:noFill/>
+          <a:ln>
+            <a:noFill/>
+          </a:ln>
+        </p:spPr>
+      </p:pic>
+      <p:sp>
+        <p:nvSpPr>
+          <p:cNvPr id="122" name="Google Shape;122;p29">
+            <a:extLst>
+              <a:ext uri="{FF2B5EF4-FFF2-40B4-BE49-F238E27FC236}">
+                <a16:creationId xmlns:a16="http://schemas.microsoft.com/office/drawing/2014/main" id="{72DBAF6A-A221-32E4-DB7D-538B0E127EA9}"/>
+              </a:ext>
+            </a:extLst>
+          </p:cNvPr>
+          <p:cNvSpPr txBox="1"/>
+          <p:nvPr/>
+        </p:nvSpPr>
+        <p:spPr>
+          <a:xfrm>
+            <a:off x="9335597" y="6524381"/>
+            <a:ext cx="2473415" cy="230792"/>
+          </a:xfrm>
+          <a:prstGeom prst="rect">
+            <a:avLst/>
+          </a:prstGeom>
+          <a:noFill/>
+          <a:ln>
+            <a:noFill/>
+          </a:ln>
+        </p:spPr>
+        <p:txBody>
+          <a:bodyPr spcFirstLastPara="1" wrap="square" lIns="91425" tIns="45700" rIns="91425" bIns="45700" anchor="t" anchorCtr="0">
+            <a:spAutoFit/>
+          </a:bodyPr>
+          <a:lstStyle/>
+          <a:p>
+            <a:pPr marL="0" marR="0" lvl="0" indent="0" algn="r" rtl="0">
+              <a:lnSpc>
+                <a:spcPct val="100000"/>
+              </a:lnSpc>
+              <a:spcBef>
+                <a:spcPts val="0"/>
+              </a:spcBef>
+              <a:spcAft>
+                <a:spcPts val="0"/>
+              </a:spcAft>
+              <a:buNone/>
+            </a:pPr>
+            <a:r>
+              <a:rPr lang="en-US" sz="900" b="0" i="0" u="none" strike="noStrike" cap="none">
+                <a:solidFill>
+                  <a:srgbClr val="13294B"/>
+                </a:solidFill>
+                <a:latin typeface="Arial"/>
+                <a:ea typeface="Arial"/>
+                <a:cs typeface="Arial"/>
+                <a:sym typeface="Arial"/>
+              </a:rPr>
+              <a:t>GRAINGER ENGINEERING</a:t>
+            </a:r>
+            <a:endParaRPr/>
+          </a:p>
+        </p:txBody>
+      </p:sp>
+      <p:sp>
+        <p:nvSpPr>
+          <p:cNvPr id="123" name="Google Shape;123;p29">
+            <a:extLst>
+              <a:ext uri="{FF2B5EF4-FFF2-40B4-BE49-F238E27FC236}">
+                <a16:creationId xmlns:a16="http://schemas.microsoft.com/office/drawing/2014/main" id="{8BD26DD5-03C4-3792-5F3C-BF6E15D1E434}"/>
+              </a:ext>
+            </a:extLst>
+          </p:cNvPr>
+          <p:cNvSpPr txBox="1"/>
+          <p:nvPr/>
+        </p:nvSpPr>
+        <p:spPr>
+          <a:xfrm>
+            <a:off x="376807" y="6524381"/>
+            <a:ext cx="7991337" cy="230792"/>
+          </a:xfrm>
+          <a:prstGeom prst="rect">
+            <a:avLst/>
+          </a:prstGeom>
+          <a:noFill/>
+          <a:ln>
+            <a:noFill/>
+          </a:ln>
+        </p:spPr>
+        <p:txBody>
+          <a:bodyPr spcFirstLastPara="1" wrap="square" lIns="91425" tIns="45700" rIns="91425" bIns="45700" anchor="t" anchorCtr="0">
+            <a:spAutoFit/>
+          </a:bodyPr>
+          <a:lstStyle/>
+          <a:p>
+            <a:pPr marL="0" marR="0" lvl="0" indent="0" algn="l" rtl="0">
+              <a:lnSpc>
+                <a:spcPct val="100000"/>
+              </a:lnSpc>
+              <a:spcBef>
+                <a:spcPts val="0"/>
+              </a:spcBef>
+              <a:spcAft>
+                <a:spcPts val="0"/>
+              </a:spcAft>
+              <a:buNone/>
+            </a:pPr>
+            <a:r>
+              <a:rPr lang="en-US" sz="900" dirty="0">
+                <a:solidFill>
+                  <a:srgbClr val="13294B"/>
+                </a:solidFill>
+              </a:rPr>
+              <a:t>SYSTEMS ENGINEERING </a:t>
+            </a:r>
+            <a:endParaRPr dirty="0"/>
+          </a:p>
+        </p:txBody>
+      </p:sp>
+      <p:grpSp>
+        <p:nvGrpSpPr>
+          <p:cNvPr id="124" name="Google Shape;124;p29">
+            <a:extLst>
+              <a:ext uri="{FF2B5EF4-FFF2-40B4-BE49-F238E27FC236}">
+                <a16:creationId xmlns:a16="http://schemas.microsoft.com/office/drawing/2014/main" id="{439EF623-249B-FF09-5496-3A302EDA9563}"/>
+              </a:ext>
+            </a:extLst>
+          </p:cNvPr>
+          <p:cNvGrpSpPr/>
+          <p:nvPr/>
+        </p:nvGrpSpPr>
+        <p:grpSpPr>
+          <a:xfrm>
+            <a:off x="4066674" y="6601537"/>
+            <a:ext cx="5233412" cy="70446"/>
+            <a:chOff x="4033424" y="6601537"/>
+            <a:chExt cx="5233412" cy="70446"/>
+          </a:xfrm>
+        </p:grpSpPr>
+        <p:cxnSp>
+          <p:nvCxnSpPr>
+            <p:cNvPr id="125" name="Google Shape;125;p29">
+              <a:extLst>
+                <a:ext uri="{FF2B5EF4-FFF2-40B4-BE49-F238E27FC236}">
+                  <a16:creationId xmlns:a16="http://schemas.microsoft.com/office/drawing/2014/main" id="{8A43F7AF-CE4D-F760-A14B-88E517C54735}"/>
+                </a:ext>
+              </a:extLst>
+            </p:cNvPr>
+            <p:cNvCxnSpPr/>
+            <p:nvPr/>
+          </p:nvCxnSpPr>
+          <p:spPr>
+            <a:xfrm rot="10800000">
+              <a:off x="4033424" y="6639606"/>
+              <a:ext cx="5164651" cy="0"/>
+            </a:xfrm>
+            <a:prstGeom prst="straightConnector1">
+              <a:avLst/>
+            </a:prstGeom>
+            <a:noFill/>
+            <a:ln w="9525" cap="flat" cmpd="sng">
+              <a:solidFill>
+                <a:srgbClr val="13294B"/>
+              </a:solidFill>
+              <a:prstDash val="solid"/>
+              <a:round/>
+              <a:headEnd type="none" w="sm" len="sm"/>
+              <a:tailEnd type="none" w="sm" len="sm"/>
+            </a:ln>
+          </p:spPr>
+        </p:cxnSp>
+        <p:sp>
+          <p:nvSpPr>
+            <p:cNvPr id="126" name="Google Shape;126;p29">
+              <a:extLst>
+                <a:ext uri="{FF2B5EF4-FFF2-40B4-BE49-F238E27FC236}">
+                  <a16:creationId xmlns:a16="http://schemas.microsoft.com/office/drawing/2014/main" id="{6EBD68D3-D381-E193-901B-DC322546F85C}"/>
+                </a:ext>
+              </a:extLst>
+            </p:cNvPr>
+            <p:cNvSpPr/>
+            <p:nvPr/>
+          </p:nvSpPr>
+          <p:spPr>
+            <a:xfrm>
+              <a:off x="9196390" y="6601537"/>
+              <a:ext cx="70446" cy="70446"/>
+            </a:xfrm>
+            <a:prstGeom prst="ellipse">
+              <a:avLst/>
+            </a:prstGeom>
+            <a:solidFill>
+              <a:srgbClr val="13294B"/>
+            </a:solidFill>
+            <a:ln>
+              <a:noFill/>
+            </a:ln>
+          </p:spPr>
+          <p:txBody>
+            <a:bodyPr spcFirstLastPara="1" wrap="square" lIns="91425" tIns="45700" rIns="91425" bIns="45700" anchor="ctr" anchorCtr="0">
+              <a:noAutofit/>
+            </a:bodyPr>
+            <a:lstStyle/>
+            <a:p>
+              <a:pPr marL="0" marR="0" lvl="0" indent="0" algn="ctr" rtl="0">
+                <a:lnSpc>
+                  <a:spcPct val="100000"/>
+                </a:lnSpc>
+                <a:spcBef>
+                  <a:spcPts val="0"/>
+                </a:spcBef>
+                <a:spcAft>
+                  <a:spcPts val="0"/>
+                </a:spcAft>
+                <a:buNone/>
+              </a:pPr>
+              <a:endParaRPr sz="1400" b="0" i="0" u="none" strike="noStrike" cap="none">
+                <a:solidFill>
+                  <a:srgbClr val="13294B"/>
+                </a:solidFill>
+                <a:latin typeface="Arial"/>
+                <a:ea typeface="Arial"/>
+                <a:cs typeface="Arial"/>
+                <a:sym typeface="Arial"/>
+              </a:endParaRPr>
+            </a:p>
+          </p:txBody>
+        </p:sp>
+      </p:grpSp>
+    </p:spTree>
+    <p:extLst>
+      <p:ext uri="{BB962C8B-B14F-4D97-AF65-F5344CB8AC3E}">
+        <p14:creationId xmlns:p14="http://schemas.microsoft.com/office/powerpoint/2010/main" val="2562259408"/>
+      </p:ext>
+    </p:extLst>
+  </p:cSld>
+  <p:clrMapOvr>
+    <a:masterClrMapping/>
+  </p:clrMapOvr>
+</p:sld>
+</file>
+
+<file path=ppt/slides/slide8.xml><?xml version="1.0" encoding="utf-8"?>
+<p:sld xmlns:a="http://schemas.openxmlformats.org/drawingml/2006/main" xmlns:r="http://schemas.openxmlformats.org/officeDocument/2006/relationships" xmlns:p="http://schemas.openxmlformats.org/presentationml/2006/main">
+  <p:cSld>
+    <p:spTree>
+      <p:nvGrpSpPr>
         <p:cNvPr id="1" name="Shape 117"/>
         <p:cNvGrpSpPr/>
         <p:nvPr/>
@@ -26050,7 +27811,7 @@
 </p:sld>
 </file>
 
-<file path=ppt/slides/slide8.xml><?xml version="1.0" encoding="utf-8"?>
+<file path=ppt/slides/slide9.xml><?xml version="1.0" encoding="utf-8"?>
 <p:sld xmlns:a="http://schemas.openxmlformats.org/drawingml/2006/main" xmlns:r="http://schemas.openxmlformats.org/officeDocument/2006/relationships" xmlns:p="http://schemas.openxmlformats.org/presentationml/2006/main">
   <p:cSld>
     <p:spTree>
@@ -26599,845 +28360,6 @@
         <p:sp>
           <p:nvSpPr>
             <p:cNvPr id="140" name="Google Shape;140;p30"/>
-            <p:cNvSpPr/>
-            <p:nvPr/>
-          </p:nvSpPr>
-          <p:spPr>
-            <a:xfrm>
-              <a:off x="9196390" y="6601537"/>
-              <a:ext cx="70446" cy="70446"/>
-            </a:xfrm>
-            <a:prstGeom prst="ellipse">
-              <a:avLst/>
-            </a:prstGeom>
-            <a:solidFill>
-              <a:srgbClr val="13294B"/>
-            </a:solidFill>
-            <a:ln>
-              <a:noFill/>
-            </a:ln>
-          </p:spPr>
-          <p:txBody>
-            <a:bodyPr spcFirstLastPara="1" wrap="square" lIns="91425" tIns="45700" rIns="91425" bIns="45700" anchor="ctr" anchorCtr="0">
-              <a:noAutofit/>
-            </a:bodyPr>
-            <a:lstStyle/>
-            <a:p>
-              <a:pPr marL="0" marR="0" lvl="0" indent="0" algn="ctr" rtl="0">
-                <a:lnSpc>
-                  <a:spcPct val="100000"/>
-                </a:lnSpc>
-                <a:spcBef>
-                  <a:spcPts val="0"/>
-                </a:spcBef>
-                <a:spcAft>
-                  <a:spcPts val="0"/>
-                </a:spcAft>
-                <a:buNone/>
-              </a:pPr>
-              <a:endParaRPr sz="1400" b="0" i="0" u="none" strike="noStrike" cap="none">
-                <a:solidFill>
-                  <a:srgbClr val="13294B"/>
-                </a:solidFill>
-                <a:latin typeface="Arial"/>
-                <a:ea typeface="Arial"/>
-                <a:cs typeface="Arial"/>
-                <a:sym typeface="Arial"/>
-              </a:endParaRPr>
-            </a:p>
-          </p:txBody>
-        </p:sp>
-      </p:grpSp>
-    </p:spTree>
-  </p:cSld>
-  <p:clrMapOvr>
-    <a:masterClrMapping/>
-  </p:clrMapOvr>
-</p:sld>
-</file>
-
-<file path=ppt/slides/slide9.xml><?xml version="1.0" encoding="utf-8"?>
-<p:sld xmlns:a="http://schemas.openxmlformats.org/drawingml/2006/main" xmlns:r="http://schemas.openxmlformats.org/officeDocument/2006/relationships" xmlns:p="http://schemas.openxmlformats.org/presentationml/2006/main">
-  <p:cSld>
-    <p:spTree>
-      <p:nvGrpSpPr>
-        <p:cNvPr id="1" name="Shape 144"/>
-        <p:cNvGrpSpPr/>
-        <p:nvPr/>
-      </p:nvGrpSpPr>
-      <p:grpSpPr>
-        <a:xfrm>
-          <a:off x="0" y="0"/>
-          <a:ext cx="0" cy="0"/>
-          <a:chOff x="0" y="0"/>
-          <a:chExt cx="0" cy="0"/>
-        </a:xfrm>
-      </p:grpSpPr>
-      <p:sp>
-        <p:nvSpPr>
-          <p:cNvPr id="145" name="Google Shape;145;p31"/>
-          <p:cNvSpPr/>
-          <p:nvPr/>
-        </p:nvSpPr>
-        <p:spPr>
-          <a:xfrm>
-            <a:off x="475566" y="1263717"/>
-            <a:ext cx="4356660" cy="2315647"/>
-          </a:xfrm>
-          <a:prstGeom prst="rect">
-            <a:avLst/>
-          </a:prstGeom>
-          <a:solidFill>
-            <a:srgbClr val="D8D8D8"/>
-          </a:solidFill>
-          <a:ln>
-            <a:noFill/>
-          </a:ln>
-        </p:spPr>
-        <p:txBody>
-          <a:bodyPr spcFirstLastPara="1" wrap="square" lIns="91425" tIns="45700" rIns="91425" bIns="45700" anchor="ctr" anchorCtr="0">
-            <a:noAutofit/>
-          </a:bodyPr>
-          <a:lstStyle/>
-          <a:p>
-            <a:pPr marL="0" marR="0" lvl="0" indent="0" algn="ctr" rtl="0">
-              <a:lnSpc>
-                <a:spcPct val="100000"/>
-              </a:lnSpc>
-              <a:spcBef>
-                <a:spcPts val="0"/>
-              </a:spcBef>
-              <a:spcAft>
-                <a:spcPts val="0"/>
-              </a:spcAft>
-              <a:buClr>
-                <a:srgbClr val="000000"/>
-              </a:buClr>
-              <a:buSzPts val="1800"/>
-              <a:buFont typeface="Arial"/>
-              <a:buNone/>
-            </a:pPr>
-            <a:endParaRPr sz="1800" b="0" i="0" u="none" strike="noStrike" cap="none">
-              <a:solidFill>
-                <a:schemeClr val="lt1"/>
-              </a:solidFill>
-              <a:latin typeface="Calibri"/>
-              <a:ea typeface="Calibri"/>
-              <a:cs typeface="Calibri"/>
-              <a:sym typeface="Calibri"/>
-            </a:endParaRPr>
-          </a:p>
-        </p:txBody>
-      </p:sp>
-      <p:sp>
-        <p:nvSpPr>
-          <p:cNvPr id="146" name="Google Shape;146;p31"/>
-          <p:cNvSpPr txBox="1"/>
-          <p:nvPr/>
-        </p:nvSpPr>
-        <p:spPr>
-          <a:xfrm>
-            <a:off x="1494115" y="2239572"/>
-            <a:ext cx="2280491" cy="369332"/>
-          </a:xfrm>
-          <a:prstGeom prst="rect">
-            <a:avLst/>
-          </a:prstGeom>
-          <a:noFill/>
-          <a:ln>
-            <a:noFill/>
-          </a:ln>
-        </p:spPr>
-        <p:txBody>
-          <a:bodyPr spcFirstLastPara="1" wrap="square" lIns="91425" tIns="45700" rIns="91425" bIns="45700" anchor="t" anchorCtr="0">
-            <a:spAutoFit/>
-          </a:bodyPr>
-          <a:lstStyle/>
-          <a:p>
-            <a:pPr marL="0" marR="0" lvl="0" indent="0" algn="ctr" rtl="0">
-              <a:lnSpc>
-                <a:spcPct val="100000"/>
-              </a:lnSpc>
-              <a:spcBef>
-                <a:spcPts val="0"/>
-              </a:spcBef>
-              <a:spcAft>
-                <a:spcPts val="0"/>
-              </a:spcAft>
-              <a:buClr>
-                <a:srgbClr val="000000"/>
-              </a:buClr>
-              <a:buSzPts val="1800"/>
-              <a:buFont typeface="Arial"/>
-              <a:buNone/>
-            </a:pPr>
-            <a:r>
-              <a:rPr lang="en-US" sz="1800" b="0" i="0" u="none" strike="noStrike" cap="none">
-                <a:solidFill>
-                  <a:srgbClr val="A5A5A5"/>
-                </a:solidFill>
-                <a:latin typeface="Arial"/>
-                <a:ea typeface="Arial"/>
-                <a:cs typeface="Arial"/>
-                <a:sym typeface="Arial"/>
-              </a:rPr>
-              <a:t>IMAGE / GRAPHIC</a:t>
-            </a:r>
-            <a:endParaRPr sz="1400" b="0" i="0" u="none" strike="noStrike" cap="none">
-              <a:solidFill>
-                <a:srgbClr val="000000"/>
-              </a:solidFill>
-              <a:latin typeface="Arial"/>
-              <a:ea typeface="Arial"/>
-              <a:cs typeface="Arial"/>
-              <a:sym typeface="Arial"/>
-            </a:endParaRPr>
-          </a:p>
-        </p:txBody>
-      </p:sp>
-      <p:sp>
-        <p:nvSpPr>
-          <p:cNvPr id="147" name="Google Shape;147;p31"/>
-          <p:cNvSpPr/>
-          <p:nvPr/>
-        </p:nvSpPr>
-        <p:spPr>
-          <a:xfrm>
-            <a:off x="475566" y="3774068"/>
-            <a:ext cx="4356660" cy="2315647"/>
-          </a:xfrm>
-          <a:prstGeom prst="rect">
-            <a:avLst/>
-          </a:prstGeom>
-          <a:solidFill>
-            <a:srgbClr val="D8D8D8"/>
-          </a:solidFill>
-          <a:ln>
-            <a:noFill/>
-          </a:ln>
-        </p:spPr>
-        <p:txBody>
-          <a:bodyPr spcFirstLastPara="1" wrap="square" lIns="91425" tIns="45700" rIns="91425" bIns="45700" anchor="ctr" anchorCtr="0">
-            <a:noAutofit/>
-          </a:bodyPr>
-          <a:lstStyle/>
-          <a:p>
-            <a:pPr marL="0" marR="0" lvl="0" indent="0" algn="ctr" rtl="0">
-              <a:lnSpc>
-                <a:spcPct val="100000"/>
-              </a:lnSpc>
-              <a:spcBef>
-                <a:spcPts val="0"/>
-              </a:spcBef>
-              <a:spcAft>
-                <a:spcPts val="0"/>
-              </a:spcAft>
-              <a:buClr>
-                <a:srgbClr val="000000"/>
-              </a:buClr>
-              <a:buSzPts val="1800"/>
-              <a:buFont typeface="Arial"/>
-              <a:buNone/>
-            </a:pPr>
-            <a:endParaRPr sz="1800" b="0" i="0" u="none" strike="noStrike" cap="none">
-              <a:solidFill>
-                <a:schemeClr val="lt1"/>
-              </a:solidFill>
-              <a:latin typeface="Calibri"/>
-              <a:ea typeface="Calibri"/>
-              <a:cs typeface="Calibri"/>
-              <a:sym typeface="Calibri"/>
-            </a:endParaRPr>
-          </a:p>
-        </p:txBody>
-      </p:sp>
-      <p:sp>
-        <p:nvSpPr>
-          <p:cNvPr id="148" name="Google Shape;148;p31"/>
-          <p:cNvSpPr txBox="1"/>
-          <p:nvPr/>
-        </p:nvSpPr>
-        <p:spPr>
-          <a:xfrm>
-            <a:off x="1494115" y="4747225"/>
-            <a:ext cx="2280491" cy="369332"/>
-          </a:xfrm>
-          <a:prstGeom prst="rect">
-            <a:avLst/>
-          </a:prstGeom>
-          <a:noFill/>
-          <a:ln>
-            <a:noFill/>
-          </a:ln>
-        </p:spPr>
-        <p:txBody>
-          <a:bodyPr spcFirstLastPara="1" wrap="square" lIns="91425" tIns="45700" rIns="91425" bIns="45700" anchor="t" anchorCtr="0">
-            <a:spAutoFit/>
-          </a:bodyPr>
-          <a:lstStyle/>
-          <a:p>
-            <a:pPr marL="0" marR="0" lvl="0" indent="0" algn="ctr" rtl="0">
-              <a:lnSpc>
-                <a:spcPct val="100000"/>
-              </a:lnSpc>
-              <a:spcBef>
-                <a:spcPts val="0"/>
-              </a:spcBef>
-              <a:spcAft>
-                <a:spcPts val="0"/>
-              </a:spcAft>
-              <a:buClr>
-                <a:srgbClr val="000000"/>
-              </a:buClr>
-              <a:buSzPts val="1800"/>
-              <a:buFont typeface="Arial"/>
-              <a:buNone/>
-            </a:pPr>
-            <a:r>
-              <a:rPr lang="en-US" sz="1800" b="0" i="0" u="none" strike="noStrike" cap="none">
-                <a:solidFill>
-                  <a:srgbClr val="A5A5A5"/>
-                </a:solidFill>
-                <a:latin typeface="Arial"/>
-                <a:ea typeface="Arial"/>
-                <a:cs typeface="Arial"/>
-                <a:sym typeface="Arial"/>
-              </a:rPr>
-              <a:t>IMAGE / GRAPHIC</a:t>
-            </a:r>
-            <a:endParaRPr sz="1400" b="0" i="0" u="none" strike="noStrike" cap="none">
-              <a:solidFill>
-                <a:srgbClr val="000000"/>
-              </a:solidFill>
-              <a:latin typeface="Arial"/>
-              <a:ea typeface="Arial"/>
-              <a:cs typeface="Arial"/>
-              <a:sym typeface="Arial"/>
-            </a:endParaRPr>
-          </a:p>
-        </p:txBody>
-      </p:sp>
-      <p:sp>
-        <p:nvSpPr>
-          <p:cNvPr id="149" name="Google Shape;149;p31"/>
-          <p:cNvSpPr txBox="1"/>
-          <p:nvPr/>
-        </p:nvSpPr>
-        <p:spPr>
-          <a:xfrm>
-            <a:off x="5122548" y="1334279"/>
-            <a:ext cx="6686464" cy="4821102"/>
-          </a:xfrm>
-          <a:prstGeom prst="rect">
-            <a:avLst/>
-          </a:prstGeom>
-          <a:noFill/>
-          <a:ln>
-            <a:noFill/>
-          </a:ln>
-        </p:spPr>
-        <p:txBody>
-          <a:bodyPr spcFirstLastPara="1" wrap="square" lIns="91425" tIns="45700" rIns="91425" bIns="45700" anchor="t" anchorCtr="0">
-            <a:noAutofit/>
-          </a:bodyPr>
-          <a:lstStyle/>
-          <a:p>
-            <a:pPr marL="0" marR="0" lvl="0" indent="0" algn="l" rtl="0">
-              <a:lnSpc>
-                <a:spcPct val="100000"/>
-              </a:lnSpc>
-              <a:spcBef>
-                <a:spcPts val="0"/>
-              </a:spcBef>
-              <a:spcAft>
-                <a:spcPts val="0"/>
-              </a:spcAft>
-              <a:buNone/>
-            </a:pPr>
-            <a:r>
-              <a:rPr lang="en-US" sz="2600" b="1" i="0" u="none" strike="noStrike" cap="none">
-                <a:solidFill>
-                  <a:srgbClr val="E84B36"/>
-                </a:solidFill>
-                <a:latin typeface="Arial"/>
-                <a:ea typeface="Arial"/>
-                <a:cs typeface="Arial"/>
-                <a:sym typeface="Arial"/>
-              </a:rPr>
-              <a:t>Lorem Ipsum Dolor Sit Amet Consectetur Adipiscing</a:t>
-            </a:r>
-            <a:endParaRPr sz="2600" b="1" i="0" u="none" strike="noStrike" cap="none">
-              <a:solidFill>
-                <a:srgbClr val="E84B36"/>
-              </a:solidFill>
-              <a:latin typeface="Arial"/>
-              <a:ea typeface="Arial"/>
-              <a:cs typeface="Arial"/>
-              <a:sym typeface="Arial"/>
-            </a:endParaRPr>
-          </a:p>
-          <a:p>
-            <a:pPr marL="0" marR="0" lvl="0" indent="0" algn="l" rtl="0">
-              <a:lnSpc>
-                <a:spcPct val="100000"/>
-              </a:lnSpc>
-              <a:spcBef>
-                <a:spcPts val="0"/>
-              </a:spcBef>
-              <a:spcAft>
-                <a:spcPts val="0"/>
-              </a:spcAft>
-              <a:buNone/>
-            </a:pPr>
-            <a:endParaRPr sz="1800" b="0" i="0" u="none" strike="noStrike" cap="none">
-              <a:solidFill>
-                <a:schemeClr val="dk1"/>
-              </a:solidFill>
-              <a:latin typeface="Arial"/>
-              <a:ea typeface="Arial"/>
-              <a:cs typeface="Arial"/>
-              <a:sym typeface="Arial"/>
-            </a:endParaRPr>
-          </a:p>
-          <a:p>
-            <a:pPr marL="0" marR="0" lvl="0" indent="0" algn="l" rtl="0">
-              <a:lnSpc>
-                <a:spcPct val="100000"/>
-              </a:lnSpc>
-              <a:spcBef>
-                <a:spcPts val="0"/>
-              </a:spcBef>
-              <a:spcAft>
-                <a:spcPts val="0"/>
-              </a:spcAft>
-              <a:buNone/>
-            </a:pPr>
-            <a:r>
-              <a:rPr lang="en-US" sz="1800" b="0" i="0" u="none" strike="noStrike" cap="none">
-                <a:solidFill>
-                  <a:srgbClr val="000000"/>
-                </a:solidFill>
-                <a:latin typeface="Arial"/>
-                <a:ea typeface="Arial"/>
-                <a:cs typeface="Arial"/>
-                <a:sym typeface="Arial"/>
-              </a:rPr>
-              <a:t>Lorem ipsum dolor sit amet, consectetur adipiscing elit, sed do eiusmod tempor incididunt ut labore et dolore magna aliqua. Ut enim ad minim veniam, quis nostrud exercitation ullamco laboris nisi ut aliquip ex ea commodo consequat. </a:t>
-            </a:r>
-            <a:endParaRPr/>
-          </a:p>
-          <a:p>
-            <a:pPr marL="0" marR="0" lvl="0" indent="0" algn="l" rtl="0">
-              <a:lnSpc>
-                <a:spcPct val="100000"/>
-              </a:lnSpc>
-              <a:spcBef>
-                <a:spcPts val="0"/>
-              </a:spcBef>
-              <a:spcAft>
-                <a:spcPts val="0"/>
-              </a:spcAft>
-              <a:buNone/>
-            </a:pPr>
-            <a:endParaRPr sz="1800" b="0" i="0" u="none" strike="noStrike" cap="none">
-              <a:solidFill>
-                <a:schemeClr val="dk1"/>
-              </a:solidFill>
-              <a:latin typeface="Arial"/>
-              <a:ea typeface="Arial"/>
-              <a:cs typeface="Arial"/>
-              <a:sym typeface="Arial"/>
-            </a:endParaRPr>
-          </a:p>
-          <a:p>
-            <a:pPr marL="0" marR="0" lvl="0" indent="0" algn="l" rtl="0">
-              <a:lnSpc>
-                <a:spcPct val="100000"/>
-              </a:lnSpc>
-              <a:spcBef>
-                <a:spcPts val="0"/>
-              </a:spcBef>
-              <a:spcAft>
-                <a:spcPts val="0"/>
-              </a:spcAft>
-              <a:buNone/>
-            </a:pPr>
-            <a:r>
-              <a:rPr lang="en-US" sz="2000" b="1" i="0" u="none" strike="noStrike" cap="none">
-                <a:solidFill>
-                  <a:srgbClr val="15264B"/>
-                </a:solidFill>
-                <a:latin typeface="Arial"/>
-                <a:ea typeface="Arial"/>
-                <a:cs typeface="Arial"/>
-                <a:sym typeface="Arial"/>
-              </a:rPr>
-              <a:t>Lorem Ipsum Dolor Sit Amet Consectetur Adipiscing</a:t>
-            </a:r>
-            <a:endParaRPr sz="2000" b="1" i="0" u="none" strike="noStrike" cap="none">
-              <a:solidFill>
-                <a:srgbClr val="15264B"/>
-              </a:solidFill>
-              <a:latin typeface="Arial"/>
-              <a:ea typeface="Arial"/>
-              <a:cs typeface="Arial"/>
-              <a:sym typeface="Arial"/>
-            </a:endParaRPr>
-          </a:p>
-          <a:p>
-            <a:pPr marL="0" marR="0" lvl="0" indent="0" algn="l" rtl="0">
-              <a:lnSpc>
-                <a:spcPct val="100000"/>
-              </a:lnSpc>
-              <a:spcBef>
-                <a:spcPts val="0"/>
-              </a:spcBef>
-              <a:spcAft>
-                <a:spcPts val="0"/>
-              </a:spcAft>
-              <a:buNone/>
-            </a:pPr>
-            <a:endParaRPr sz="1800" b="1" i="0" u="none" strike="noStrike" cap="none">
-              <a:solidFill>
-                <a:schemeClr val="dk1"/>
-              </a:solidFill>
-              <a:latin typeface="Arial"/>
-              <a:ea typeface="Arial"/>
-              <a:cs typeface="Arial"/>
-              <a:sym typeface="Arial"/>
-            </a:endParaRPr>
-          </a:p>
-          <a:p>
-            <a:pPr marL="0" marR="0" lvl="0" indent="0" algn="l" rtl="0">
-              <a:lnSpc>
-                <a:spcPct val="100000"/>
-              </a:lnSpc>
-              <a:spcBef>
-                <a:spcPts val="0"/>
-              </a:spcBef>
-              <a:spcAft>
-                <a:spcPts val="0"/>
-              </a:spcAft>
-              <a:buNone/>
-            </a:pPr>
-            <a:r>
-              <a:rPr lang="en-US" sz="1800" b="0" i="0" u="none" strike="noStrike" cap="none">
-                <a:solidFill>
-                  <a:srgbClr val="000000"/>
-                </a:solidFill>
-                <a:latin typeface="Arial"/>
-                <a:ea typeface="Arial"/>
-                <a:cs typeface="Arial"/>
-                <a:sym typeface="Arial"/>
-              </a:rPr>
-              <a:t>Lorem ipsum dolor sit amet, consectetur adipiscing elit, sed do eiusmod tempor incididunt ut labore et dolore magna aliqua.</a:t>
-            </a:r>
-            <a:endParaRPr sz="1800" b="1" i="0" u="none" strike="noStrike" cap="none">
-              <a:solidFill>
-                <a:schemeClr val="dk1"/>
-              </a:solidFill>
-              <a:latin typeface="Arial"/>
-              <a:ea typeface="Arial"/>
-              <a:cs typeface="Arial"/>
-              <a:sym typeface="Arial"/>
-            </a:endParaRPr>
-          </a:p>
-        </p:txBody>
-      </p:sp>
-      <p:sp>
-        <p:nvSpPr>
-          <p:cNvPr id="150" name="Google Shape;150;p31"/>
-          <p:cNvSpPr/>
-          <p:nvPr/>
-        </p:nvSpPr>
-        <p:spPr>
-          <a:xfrm rot="10800000" flipH="1">
-            <a:off x="0" y="0"/>
-            <a:ext cx="12192000" cy="868220"/>
-          </a:xfrm>
-          <a:prstGeom prst="rect">
-            <a:avLst/>
-          </a:prstGeom>
-          <a:solidFill>
-            <a:srgbClr val="13294B"/>
-          </a:solidFill>
-          <a:ln>
-            <a:noFill/>
-          </a:ln>
-        </p:spPr>
-        <p:txBody>
-          <a:bodyPr spcFirstLastPara="1" wrap="square" lIns="91425" tIns="45700" rIns="91425" bIns="45700" anchor="ctr" anchorCtr="0">
-            <a:noAutofit/>
-          </a:bodyPr>
-          <a:lstStyle/>
-          <a:p>
-            <a:pPr marL="0" marR="0" lvl="0" indent="0" algn="ctr" rtl="0">
-              <a:lnSpc>
-                <a:spcPct val="100000"/>
-              </a:lnSpc>
-              <a:spcBef>
-                <a:spcPts val="0"/>
-              </a:spcBef>
-              <a:spcAft>
-                <a:spcPts val="0"/>
-              </a:spcAft>
-              <a:buClr>
-                <a:schemeClr val="lt1"/>
-              </a:buClr>
-              <a:buSzPts val="1800"/>
-              <a:buFont typeface="Calibri"/>
-              <a:buNone/>
-            </a:pPr>
-            <a:endParaRPr sz="1800" b="0" i="0" u="none" strike="noStrike" cap="none">
-              <a:solidFill>
-                <a:srgbClr val="13294B"/>
-              </a:solidFill>
-              <a:latin typeface="Calibri"/>
-              <a:ea typeface="Calibri"/>
-              <a:cs typeface="Calibri"/>
-              <a:sym typeface="Calibri"/>
-            </a:endParaRPr>
-          </a:p>
-        </p:txBody>
-      </p:sp>
-      <p:sp>
-        <p:nvSpPr>
-          <p:cNvPr id="151" name="Google Shape;151;p31"/>
-          <p:cNvSpPr txBox="1"/>
-          <p:nvPr/>
-        </p:nvSpPr>
-        <p:spPr>
-          <a:xfrm>
-            <a:off x="376810" y="204051"/>
-            <a:ext cx="10910026" cy="461624"/>
-          </a:xfrm>
-          <a:prstGeom prst="rect">
-            <a:avLst/>
-          </a:prstGeom>
-          <a:noFill/>
-          <a:ln>
-            <a:noFill/>
-          </a:ln>
-        </p:spPr>
-        <p:txBody>
-          <a:bodyPr spcFirstLastPara="1" wrap="square" lIns="91425" tIns="45700" rIns="91425" bIns="45700" anchor="t" anchorCtr="0">
-            <a:spAutoFit/>
-          </a:bodyPr>
-          <a:lstStyle/>
-          <a:p>
-            <a:pPr marL="0" marR="0" lvl="0" indent="0" algn="l" rtl="0">
-              <a:lnSpc>
-                <a:spcPct val="100000"/>
-              </a:lnSpc>
-              <a:spcBef>
-                <a:spcPts val="0"/>
-              </a:spcBef>
-              <a:spcAft>
-                <a:spcPts val="0"/>
-              </a:spcAft>
-              <a:buClr>
-                <a:srgbClr val="000000"/>
-              </a:buClr>
-              <a:buSzPts val="2400"/>
-              <a:buFont typeface="Arial"/>
-              <a:buNone/>
-            </a:pPr>
-            <a:r>
-              <a:rPr lang="en-US" sz="2400" b="0" i="0" u="none" strike="noStrike" cap="none">
-                <a:solidFill>
-                  <a:schemeClr val="lt1"/>
-                </a:solidFill>
-                <a:latin typeface="Arial"/>
-                <a:ea typeface="Arial"/>
-                <a:cs typeface="Arial"/>
-                <a:sym typeface="Arial"/>
-              </a:rPr>
-              <a:t>Slide Title</a:t>
-            </a:r>
-            <a:endParaRPr sz="2400" b="0" i="0" u="none" strike="noStrike" cap="none">
-              <a:solidFill>
-                <a:schemeClr val="lt1"/>
-              </a:solidFill>
-              <a:latin typeface="Arial"/>
-              <a:ea typeface="Arial"/>
-              <a:cs typeface="Arial"/>
-              <a:sym typeface="Arial"/>
-            </a:endParaRPr>
-          </a:p>
-        </p:txBody>
-      </p:sp>
-      <p:pic>
-        <p:nvPicPr>
-          <p:cNvPr id="152" name="Google Shape;152;p31"/>
-          <p:cNvPicPr preferRelativeResize="0"/>
-          <p:nvPr/>
-        </p:nvPicPr>
-        <p:blipFill rotWithShape="1">
-          <a:blip r:embed="rId3">
-            <a:alphaModFix/>
-          </a:blip>
-          <a:srcRect/>
-          <a:stretch/>
-        </p:blipFill>
-        <p:spPr>
-          <a:xfrm>
-            <a:off x="11557509" y="233819"/>
-            <a:ext cx="271308" cy="389810"/>
-          </a:xfrm>
-          <a:prstGeom prst="rect">
-            <a:avLst/>
-          </a:prstGeom>
-          <a:noFill/>
-          <a:ln>
-            <a:noFill/>
-          </a:ln>
-        </p:spPr>
-      </p:pic>
-      <p:sp>
-        <p:nvSpPr>
-          <p:cNvPr id="153" name="Google Shape;153;p31"/>
-          <p:cNvSpPr txBox="1"/>
-          <p:nvPr/>
-        </p:nvSpPr>
-        <p:spPr>
-          <a:xfrm>
-            <a:off x="9335597" y="6524381"/>
-            <a:ext cx="2473415" cy="230792"/>
-          </a:xfrm>
-          <a:prstGeom prst="rect">
-            <a:avLst/>
-          </a:prstGeom>
-          <a:noFill/>
-          <a:ln>
-            <a:noFill/>
-          </a:ln>
-        </p:spPr>
-        <p:txBody>
-          <a:bodyPr spcFirstLastPara="1" wrap="square" lIns="91425" tIns="45700" rIns="91425" bIns="45700" anchor="t" anchorCtr="0">
-            <a:spAutoFit/>
-          </a:bodyPr>
-          <a:lstStyle/>
-          <a:p>
-            <a:pPr marL="0" marR="0" lvl="0" indent="0" algn="r" rtl="0">
-              <a:lnSpc>
-                <a:spcPct val="100000"/>
-              </a:lnSpc>
-              <a:spcBef>
-                <a:spcPts val="0"/>
-              </a:spcBef>
-              <a:spcAft>
-                <a:spcPts val="0"/>
-              </a:spcAft>
-              <a:buNone/>
-            </a:pPr>
-            <a:r>
-              <a:rPr lang="en-US" sz="900" b="0" i="0" u="none" strike="noStrike" cap="none">
-                <a:solidFill>
-                  <a:srgbClr val="13294B"/>
-                </a:solidFill>
-                <a:latin typeface="Arial"/>
-                <a:ea typeface="Arial"/>
-                <a:cs typeface="Arial"/>
-                <a:sym typeface="Arial"/>
-              </a:rPr>
-              <a:t>GRAINGER ENGINEERING</a:t>
-            </a:r>
-            <a:endParaRPr/>
-          </a:p>
-        </p:txBody>
-      </p:sp>
-      <p:sp>
-        <p:nvSpPr>
-          <p:cNvPr id="154" name="Google Shape;154;p31"/>
-          <p:cNvSpPr txBox="1"/>
-          <p:nvPr/>
-        </p:nvSpPr>
-        <p:spPr>
-          <a:xfrm>
-            <a:off x="376807" y="6524381"/>
-            <a:ext cx="7991400" cy="230700"/>
-          </a:xfrm>
-          <a:prstGeom prst="rect">
-            <a:avLst/>
-          </a:prstGeom>
-          <a:noFill/>
-          <a:ln>
-            <a:noFill/>
-          </a:ln>
-        </p:spPr>
-        <p:txBody>
-          <a:bodyPr spcFirstLastPara="1" wrap="square" lIns="91425" tIns="45700" rIns="91425" bIns="45700" anchor="t" anchorCtr="0">
-            <a:spAutoFit/>
-          </a:bodyPr>
-          <a:lstStyle/>
-          <a:p>
-            <a:pPr marL="0" marR="0" lvl="0" indent="0" algn="l" rtl="0">
-              <a:lnSpc>
-                <a:spcPct val="100000"/>
-              </a:lnSpc>
-              <a:spcBef>
-                <a:spcPts val="0"/>
-              </a:spcBef>
-              <a:spcAft>
-                <a:spcPts val="0"/>
-              </a:spcAft>
-              <a:buNone/>
-            </a:pPr>
-            <a:r>
-              <a:rPr lang="en-US" sz="900" dirty="0">
-                <a:solidFill>
-                  <a:srgbClr val="13294B"/>
-                </a:solidFill>
-              </a:rPr>
-              <a:t>SYSTEMS ENGINEERING</a:t>
-            </a:r>
-            <a:endParaRPr dirty="0"/>
-          </a:p>
-        </p:txBody>
-      </p:sp>
-      <p:grpSp>
-        <p:nvGrpSpPr>
-          <p:cNvPr id="155" name="Google Shape;155;p31"/>
-          <p:cNvGrpSpPr/>
-          <p:nvPr/>
-        </p:nvGrpSpPr>
-        <p:grpSpPr>
-          <a:xfrm>
-            <a:off x="4066674" y="6601537"/>
-            <a:ext cx="5233412" cy="70446"/>
-            <a:chOff x="4033424" y="6601537"/>
-            <a:chExt cx="5233412" cy="70446"/>
-          </a:xfrm>
-        </p:grpSpPr>
-        <p:cxnSp>
-          <p:nvCxnSpPr>
-            <p:cNvPr id="156" name="Google Shape;156;p31"/>
-            <p:cNvCxnSpPr/>
-            <p:nvPr/>
-          </p:nvCxnSpPr>
-          <p:spPr>
-            <a:xfrm rot="10800000">
-              <a:off x="4033424" y="6639606"/>
-              <a:ext cx="5164651" cy="0"/>
-            </a:xfrm>
-            <a:prstGeom prst="straightConnector1">
-              <a:avLst/>
-            </a:prstGeom>
-            <a:noFill/>
-            <a:ln w="9525" cap="flat" cmpd="sng">
-              <a:solidFill>
-                <a:srgbClr val="13294B"/>
-              </a:solidFill>
-              <a:prstDash val="solid"/>
-              <a:round/>
-              <a:headEnd type="none" w="sm" len="sm"/>
-              <a:tailEnd type="none" w="sm" len="sm"/>
-            </a:ln>
-          </p:spPr>
-        </p:cxnSp>
-        <p:sp>
-          <p:nvSpPr>
-            <p:cNvPr id="157" name="Google Shape;157;p31"/>
             <p:cNvSpPr/>
             <p:nvPr/>
           </p:nvSpPr>

</xml_diff>